<commit_message>
Keep every finding: five top findings plus an "Other findings" slide
Top findings stay at five or fewer, the ones the decision rests on. Every
other finding that met the evidence bar now goes on one "Other findings"
slide and report section, one line each with strength, tagged
"unexpected" where it fell outside the research questions. Nothing that
passed the evidence bar is dropped; a finding whose evidence didn't hold
goes in the appendix with the reason. The study record stays the full
list.

Stage 6 and 7 guides, readout and report templates, standard 7.1, three
eval scenarios, README bullet, examples README, and the example readout
and report in Markdown, Word and PowerPoint. Adapters rebuilt.

Co-Authored-By: Claude Fable 5.1 <noreply@anthropic.com>
Claude-Session: https://claude.ai/code/session_01NyNcFk8gXG7WMR8gzeKd9N
</commit_message>
<xml_diff>
--- a/docs/examples/example-readout.pptx
+++ b/docs/examples/example-readout.pptx
@@ -18,9 +18,10 @@
     <p:sldId id="266" r:id="rId12"/>
     <p:sldId id="267" r:id="rId13"/>
     <p:sldId id="268" r:id="rId14"/>
+    <p:sldId id="269" r:id="rId15"/>
   </p:sldIdLst>
   <p:notesMasterIdLst>
-    <p:notesMasterId r:id="rId15"/>
+    <p:notesMasterId r:id="rId16"/>
   </p:notesMasterIdLst>
   <p:sldSz cx="9144000" cy="5143500"/>
   <p:notesSz cx="5143500" cy="9144000"/>
@@ -119,29 +120,30 @@
   <p:extLst>
     <p:ext uri="{521415D9-36F7-43E2-AB2F-B90AF26B5E84}">
       <p14:sectionLst xmlns:p14="http://schemas.microsoft.com/office/powerpoint/2010/main">
-        <p14:section name="Opening" id="{d5a06f43-4e91-72b0-05de-248771050b7e}">
+        <p14:section name="Opening" id="{689ffb9a-cbb3-6791-ce7b-92c1284be3ba}">
           <p14:sldIdLst>
             <p14:sldId id="256"/>
             <p14:sldId id="257"/>
             <p14:sldId id="258"/>
           </p14:sldIdLst>
         </p14:section>
-        <p14:section name="Findings" id="{f9fcda90-f36c-c1a2-8640-68ae0a787f18}">
+        <p14:section name="Findings" id="{bbd0d3b6-ec34-309f-44d3-850c571e6aa1}">
           <p14:sldIdLst>
             <p14:sldId id="259"/>
             <p14:sldId id="260"/>
             <p14:sldId id="261"/>
             <p14:sldId id="262"/>
             <p14:sldId id="263"/>
+            <p14:sldId id="264"/>
           </p14:sldIdLst>
         </p14:section>
-        <p14:section name="What it means" id="{758e3a03-0ccf-2f00-51a8-a8a2137d0a7a}">
+        <p14:section name="What it means" id="{372057f4-8926-8178-0f91-170f32e391e6}">
           <p14:sldIdLst>
-            <p14:sldId id="264"/>
             <p14:sldId id="265"/>
             <p14:sldId id="266"/>
             <p14:sldId id="267"/>
             <p14:sldId id="268"/>
+            <p14:sldId id="269"/>
           </p14:sldIdLst>
         </p14:section>
       </p14:sectionLst>
@@ -924,6 +926,94 @@
             <a:fld id="{F7021451-1387-4CA6-816F-3879F97B5CBC}" type="slidenum">
               <a:rPr lang="en-US"/>
               <a:t>13</a:t>
+            </a:fld>
+            <a:endParaRPr lang="en-US"/>
+          </a:p>
+        </p:txBody>
+      </p:sp>
+    </p:spTree>
+    <p:extLst>
+      <p:ext uri="{BB962C8B-B14F-4D97-AF65-F5344CB8AC3E}">
+        <p14:creationId xmlns:p14="http://schemas.microsoft.com/office/powerpoint/2010/main" val="1024086991"/>
+      </p:ext>
+    </p:extLst>
+  </p:cSld>
+  <p:clrMapOvr>
+    <a:masterClrMapping/>
+  </p:clrMapOvr>
+</p:notes>
+</file>
+
+<file path=ppt/notesSlides/notesSlide14.xml><?xml version="1.0" encoding="utf-8"?>
+<p:notes xmlns:a="http://schemas.openxmlformats.org/drawingml/2006/main" xmlns:r="http://schemas.openxmlformats.org/officeDocument/2006/relationships" xmlns:p="http://schemas.openxmlformats.org/presentationml/2006/main">
+  <p:cSld>
+    <p:spTree>
+      <p:nvGrpSpPr>
+        <p:cNvPr id="1" name=""/>
+        <p:cNvGrpSpPr/>
+        <p:nvPr/>
+      </p:nvGrpSpPr>
+      <p:grpSpPr>
+        <a:xfrm>
+          <a:off x="0" y="0"/>
+          <a:ext cx="0" cy="0"/>
+          <a:chOff x="0" y="0"/>
+          <a:chExt cx="0" cy="0"/>
+        </a:xfrm>
+      </p:grpSpPr>
+      <p:sp>
+        <p:nvSpPr>
+          <p:cNvPr id="2" name="Slide Image Placeholder 1"/>
+          <p:cNvSpPr>
+            <a:spLocks noGrp="1" noRot="1" noChangeAspect="1"/>
+          </p:cNvSpPr>
+          <p:nvPr>
+            <p:ph type="sldImg"/>
+          </p:nvPr>
+        </p:nvSpPr>
+        <p:spPr/>
+      </p:sp>
+      <p:sp>
+        <p:nvSpPr>
+          <p:cNvPr id="3" name="Notes Placeholder 2"/>
+          <p:cNvSpPr>
+            <a:spLocks noGrp="1"/>
+          </p:cNvSpPr>
+          <p:nvPr>
+            <p:ph type="body" idx="1"/>
+          </p:nvPr>
+        </p:nvSpPr>
+        <p:spPr/>
+        <p:txBody>
+          <a:bodyPr/>
+          <a:lstStyle/>
+          <a:p>
+            <a:r>
+              <a:rPr lang="en-US" dirty="0"/>
+              <a:t/>
+            </a:r>
+            <a:endParaRPr lang="en-US" dirty="0"/>
+          </a:p>
+        </p:txBody>
+      </p:sp>
+      <p:sp>
+        <p:nvSpPr>
+          <p:cNvPr id="4" name="Slide Number Placeholder 3"/>
+          <p:cNvSpPr>
+            <a:spLocks noGrp="1"/>
+          </p:cNvSpPr>
+          <p:nvPr>
+            <p:ph type="sldNum" sz="quarter" idx="10"/>
+          </p:nvPr>
+        </p:nvSpPr>
+        <p:spPr/>
+        <p:txBody>
+          <a:bodyPr/>
+          <a:lstStyle/>
+          <a:p>
+            <a:fld id="{F7021451-1387-4CA6-816F-3879F97B5CBC}" type="slidenum">
+              <a:rPr lang="en-US"/>
+              <a:t>14</a:t>
             </a:fld>
             <a:endParaRPr lang="en-US"/>
           </a:p>
@@ -2570,7 +2660,7 @@
         </p:nvSpPr>
         <p:spPr>
           <a:xfrm>
-            <a:off x="548640" y="347472"/>
+            <a:off x="548640" y="1371600"/>
             <a:ext cx="8046720" cy="274320"/>
           </a:xfrm>
           <a:prstGeom prst="rect">
@@ -2589,10 +2679,10 @@
             <a:r>
               <a:rPr lang="en-US" sz="1050" b="1" spc="200" kern="0" dirty="0">
                 <a:solidFill>
-                  <a:schemeClr val="accent4"/>
-                </a:solidFill>
-              </a:rPr>
-              <a:t>WHAT TO DO</a:t>
+                  <a:schemeClr val="accent2"/>
+                </a:solidFill>
+              </a:rPr>
+              <a:t>SUMMARY</a:t>
             </a:r>
             <a:endParaRPr lang="en-US" sz="1050" dirty="0"/>
           </a:p>
@@ -2608,6 +2698,179 @@
         </p:nvSpPr>
         <p:spPr>
           <a:xfrm>
+            <a:off x="548640" y="1691640"/>
+            <a:ext cx="8046720" cy="1188720"/>
+          </a:xfrm>
+          <a:prstGeom prst="rect">
+            <a:avLst/>
+          </a:prstGeom>
+          <a:noFill/>
+          <a:ln/>
+        </p:spPr>
+        <p:txBody>
+          <a:bodyPr wrap="square" lIns="0" tIns="0" rIns="0" bIns="0" rtlCol="0" anchor="t"/>
+          <a:lstStyle/>
+          <a:p>
+            <a:pPr algn="l" indent="0" marL="0">
+              <a:buNone/>
+            </a:pPr>
+            <a:r>
+              <a:rPr lang="en-US" sz="3400" b="1" dirty="0">
+                <a:solidFill>
+                  <a:schemeClr val="bg1"/>
+                </a:solidFill>
+              </a:rPr>
+              <a:t>Fix import before touching the dialog</a:t>
+            </a:r>
+            <a:endParaRPr lang="en-US" sz="3400" dirty="0"/>
+          </a:p>
+        </p:txBody>
+      </p:sp>
+      <p:sp>
+        <p:nvSpPr>
+          <p:cNvPr id="4" name="Text 0"/>
+          <p:cNvSpPr/>
+          <p:nvPr>
+            <p:ph idx="102" type="body" hasCustomPrompt="1"/>
+          </p:nvPr>
+        </p:nvSpPr>
+        <p:spPr>
+          <a:xfrm>
+            <a:off x="548640" y="2971800"/>
+            <a:ext cx="8046720" cy="1463040"/>
+          </a:xfrm>
+          <a:prstGeom prst="rect">
+            <a:avLst/>
+          </a:prstGeom>
+          <a:noFill/>
+          <a:ln/>
+        </p:spPr>
+        <p:txBody>
+          <a:bodyPr wrap="square" lIns="0" tIns="0" rIns="0" bIns="0" rtlCol="0" anchor="t"/>
+          <a:lstStyle/>
+          <a:p>
+            <a:pPr indent="0" marL="0">
+              <a:spcAft>
+                <a:spcPts val="600"/>
+              </a:spcAft>
+              <a:buNone/>
+            </a:pPr>
+            <a:r>
+              <a:rPr lang="en-US" sz="1600" dirty="0">
+                <a:solidFill>
+                  <a:schemeClr val="bg2"/>
+                </a:solidFill>
+              </a:rPr>
+              <a:t>We asked why people abandon export. Mostly they don’t fail at export; they fail at import and only notice at export.</a:t>
+            </a:r>
+            <a:endParaRPr lang="en-US" sz="1600" dirty="0"/>
+          </a:p>
+          <a:p>
+            <a:pPr indent="0" marL="0">
+              <a:spcAft>
+                <a:spcPts val="600"/>
+              </a:spcAft>
+              <a:buNone/>
+            </a:pPr>
+            <a:r>
+              <a:rPr lang="en-US" sz="1600" dirty="0">
+                <a:solidFill>
+                  <a:schemeClr val="bg2"/>
+                </a:solidFill>
+              </a:rPr>
+              <a:t>A separate, smaller group is fully blocked by column order.</a:t>
+            </a:r>
+            <a:endParaRPr lang="en-US" sz="1600" dirty="0"/>
+          </a:p>
+          <a:p>
+            <a:pPr indent="0" marL="0">
+              <a:buNone/>
+            </a:pPr>
+            <a:r>
+              <a:rPr lang="en-US" sz="1600" dirty="0">
+                <a:solidFill>
+                  <a:schemeClr val="bg2"/>
+                </a:solidFill>
+              </a:rPr>
+              <a:t>Confidence is moderate overall: eight sessions, one segment over-represented.</a:t>
+            </a:r>
+            <a:endParaRPr lang="en-US" sz="1600" dirty="0"/>
+          </a:p>
+        </p:txBody>
+      </p:sp>
+    </p:spTree>
+  </p:cSld>
+  <p:clrMapOvr>
+    <a:masterClrMapping/>
+  </p:clrMapOvr>
+</p:sld>
+</file>
+
+<file path=ppt/slides/slide11.xml><?xml version="1.0" encoding="utf-8"?>
+<p:sld xmlns:a="http://schemas.openxmlformats.org/drawingml/2006/main" xmlns:r="http://schemas.openxmlformats.org/officeDocument/2006/relationships" xmlns:p="http://schemas.openxmlformats.org/presentationml/2006/main">
+  <p:cSld name="Slide 11">
+    <p:spTree>
+      <p:nvGrpSpPr>
+        <p:cNvPr id="1" name=""/>
+        <p:cNvGrpSpPr/>
+        <p:nvPr/>
+      </p:nvGrpSpPr>
+      <p:grpSpPr>
+        <a:xfrm>
+          <a:off x="0" y="0"/>
+          <a:ext cx="0" cy="0"/>
+          <a:chOff x="0" y="0"/>
+          <a:chExt cx="0" cy="0"/>
+        </a:xfrm>
+      </p:grpSpPr>
+      <p:sp>
+        <p:nvSpPr>
+          <p:cNvPr id="2" name="Text 0"/>
+          <p:cNvSpPr/>
+          <p:nvPr>
+            <p:ph idx="100" type="body" hasCustomPrompt="1"/>
+          </p:nvPr>
+        </p:nvSpPr>
+        <p:spPr>
+          <a:xfrm>
+            <a:off x="548640" y="347472"/>
+            <a:ext cx="8046720" cy="274320"/>
+          </a:xfrm>
+          <a:prstGeom prst="rect">
+            <a:avLst/>
+          </a:prstGeom>
+          <a:noFill/>
+          <a:ln/>
+        </p:spPr>
+        <p:txBody>
+          <a:bodyPr wrap="square" lIns="0" tIns="0" rIns="0" bIns="0" rtlCol="0" anchor="b"/>
+          <a:lstStyle/>
+          <a:p>
+            <a:pPr indent="0" marL="0">
+              <a:buNone/>
+            </a:pPr>
+            <a:r>
+              <a:rPr lang="en-US" sz="1050" b="1" spc="200" kern="0" dirty="0">
+                <a:solidFill>
+                  <a:schemeClr val="accent4"/>
+                </a:solidFill>
+              </a:rPr>
+              <a:t>WHAT TO DO</a:t>
+            </a:r>
+            <a:endParaRPr lang="en-US" sz="1050" dirty="0"/>
+          </a:p>
+        </p:txBody>
+      </p:sp>
+      <p:sp>
+        <p:nvSpPr>
+          <p:cNvPr id="3" name="Text 0"/>
+          <p:cNvSpPr/>
+          <p:nvPr>
+            <p:ph idx="101" type="title" hasCustomPrompt="1"/>
+          </p:nvPr>
+        </p:nvSpPr>
+        <p:spPr>
+          <a:xfrm>
             <a:off x="548640" y="640080"/>
             <a:ext cx="8046720" cy="548640"/>
           </a:xfrm>
@@ -2640,7 +2903,7 @@
       </p:sp>
       <p:graphicFrame>
         <p:nvGraphicFramePr>
-          <p:cNvPr id="11" name="Table 0"/>
+          <p:cNvPr id="12" name="Table 0"/>
           <p:cNvGraphicFramePr>
             <a:graphicFrameLocks noGrp="1"/>
           </p:cNvGraphicFramePr>
@@ -3692,941 +3955,6 @@
             <a:pPr algn="l"/>
             <a:fld id="{F7021451-1387-4CA6-816F-3879F97B5CBC}" type="slidenum">
               <a:rPr b="0" lang="en-US"/>
-              <a:t>10</a:t>
-            </a:fld>
-            <a:endParaRPr lang="en-US"/>
-          </a:p>
-        </p:txBody>
-      </p:sp>
-    </p:spTree>
-  </p:cSld>
-  <p:clrMapOvr>
-    <a:masterClrMapping/>
-  </p:clrMapOvr>
-</p:sld>
-</file>
-
-<file path=ppt/slides/slide11.xml><?xml version="1.0" encoding="utf-8"?>
-<p:sld xmlns:a="http://schemas.openxmlformats.org/drawingml/2006/main" xmlns:r="http://schemas.openxmlformats.org/officeDocument/2006/relationships" xmlns:p="http://schemas.openxmlformats.org/presentationml/2006/main">
-  <p:cSld name="Slide 11">
-    <p:spTree>
-      <p:nvGrpSpPr>
-        <p:cNvPr id="1" name=""/>
-        <p:cNvGrpSpPr/>
-        <p:nvPr/>
-      </p:nvGrpSpPr>
-      <p:grpSpPr>
-        <a:xfrm>
-          <a:off x="0" y="0"/>
-          <a:ext cx="0" cy="0"/>
-          <a:chOff x="0" y="0"/>
-          <a:chExt cx="0" cy="0"/>
-        </a:xfrm>
-      </p:grpSpPr>
-      <p:sp>
-        <p:nvSpPr>
-          <p:cNvPr id="2" name="Text 0"/>
-          <p:cNvSpPr/>
-          <p:nvPr>
-            <p:ph idx="100" type="body" hasCustomPrompt="1"/>
-          </p:nvPr>
-        </p:nvSpPr>
-        <p:spPr>
-          <a:xfrm>
-            <a:off x="548640" y="347472"/>
-            <a:ext cx="8046720" cy="274320"/>
-          </a:xfrm>
-          <a:prstGeom prst="rect">
-            <a:avLst/>
-          </a:prstGeom>
-          <a:noFill/>
-          <a:ln/>
-        </p:spPr>
-        <p:txBody>
-          <a:bodyPr wrap="square" lIns="0" tIns="0" rIns="0" bIns="0" rtlCol="0" anchor="b"/>
-          <a:lstStyle/>
-          <a:p>
-            <a:pPr indent="0" marL="0">
-              <a:buNone/>
-            </a:pPr>
-            <a:r>
-              <a:rPr lang="en-US" sz="1050" b="1" spc="200" kern="0" dirty="0">
-                <a:solidFill>
-                  <a:schemeClr val="accent4"/>
-                </a:solidFill>
-              </a:rPr>
-              <a:t>WHAT HAPPENS NOW</a:t>
-            </a:r>
-            <a:endParaRPr lang="en-US" sz="1050" dirty="0"/>
-          </a:p>
-        </p:txBody>
-      </p:sp>
-      <p:sp>
-        <p:nvSpPr>
-          <p:cNvPr id="3" name="Text 0"/>
-          <p:cNvSpPr/>
-          <p:nvPr>
-            <p:ph idx="101" type="title" hasCustomPrompt="1"/>
-          </p:nvPr>
-        </p:nvSpPr>
-        <p:spPr>
-          <a:xfrm>
-            <a:off x="548640" y="640080"/>
-            <a:ext cx="8046720" cy="548640"/>
-          </a:xfrm>
-          <a:prstGeom prst="rect">
-            <a:avLst/>
-          </a:prstGeom>
-          <a:noFill/>
-          <a:ln/>
-        </p:spPr>
-        <p:txBody>
-          <a:bodyPr wrap="square" lIns="0" tIns="0" rIns="0" bIns="0" rtlCol="0" anchor="t">
-            <a:normAutofit/>
-          </a:bodyPr>
-          <a:lstStyle/>
-          <a:p>
-            <a:pPr algn="l" indent="0" marL="0">
-              <a:buNone/>
-            </a:pPr>
-            <a:r>
-              <a:rPr lang="en-US" sz="2600" b="1" dirty="0">
-                <a:solidFill>
-                  <a:schemeClr val="tx2"/>
-                </a:solidFill>
-              </a:rPr>
-              <a:t>Next steps</a:t>
-            </a:r>
-            <a:endParaRPr lang="en-US" sz="2600" dirty="0"/>
-          </a:p>
-        </p:txBody>
-      </p:sp>
-      <p:sp>
-        <p:nvSpPr>
-          <p:cNvPr id="4" name="Shape 2"/>
-          <p:cNvSpPr/>
-          <p:nvPr/>
-        </p:nvSpPr>
-        <p:spPr>
-          <a:xfrm>
-            <a:off x="713232" y="1627632"/>
-            <a:ext cx="6172200" cy="0"/>
-          </a:xfrm>
-          <a:prstGeom prst="line">
-            <a:avLst/>
-          </a:prstGeom>
-          <a:noFill/>
-          <a:ln w="19050">
-            <a:solidFill>
-              <a:srgbClr val="A7BEAE"/>
-            </a:solidFill>
-            <a:prstDash val="solid"/>
-          </a:ln>
-        </p:spPr>
-      </p:sp>
-      <p:sp>
-        <p:nvSpPr>
-          <p:cNvPr id="5" name="Shape 3"/>
-          <p:cNvSpPr/>
-          <p:nvPr/>
-        </p:nvSpPr>
-        <p:spPr>
-          <a:xfrm>
-            <a:off x="548640" y="1463040"/>
-            <a:ext cx="329184" cy="329184"/>
-          </a:xfrm>
-          <a:prstGeom prst="ellipse">
-            <a:avLst/>
-          </a:prstGeom>
-          <a:solidFill>
-            <a:schemeClr val="accent2"/>
-          </a:solidFill>
-          <a:ln/>
-        </p:spPr>
-      </p:sp>
-      <p:sp>
-        <p:nvSpPr>
-          <p:cNvPr id="6" name="Text 4"/>
-          <p:cNvSpPr txBox="1"/>
-          <p:nvPr/>
-        </p:nvSpPr>
-        <p:spPr>
-          <a:xfrm>
-            <a:off x="548640" y="1463040"/>
-            <a:ext cx="329184" cy="329184"/>
-          </a:xfrm>
-          <a:prstGeom prst="rect">
-            <a:avLst/>
-          </a:prstGeom>
-          <a:noFill/>
-          <a:ln/>
-        </p:spPr>
-        <p:txBody>
-          <a:bodyPr wrap="square" lIns="0" tIns="0" rIns="0" bIns="0" rtlCol="0" anchor="ctr"/>
-          <a:lstStyle/>
-          <a:p>
-            <a:pPr algn="ctr" indent="0" marL="0">
-              <a:buNone/>
-            </a:pPr>
-            <a:r>
-              <a:rPr lang="en-US" sz="1200" b="1" dirty="0">
-                <a:solidFill>
-                  <a:schemeClr val="tx2"/>
-                </a:solidFill>
-              </a:rPr>
-              <a:t>1</a:t>
-            </a:r>
-            <a:endParaRPr lang="en-US" sz="1200" dirty="0"/>
-          </a:p>
-        </p:txBody>
-      </p:sp>
-      <p:sp>
-        <p:nvSpPr>
-          <p:cNvPr id="7" name="Shape 5"/>
-          <p:cNvSpPr/>
-          <p:nvPr/>
-        </p:nvSpPr>
-        <p:spPr>
-          <a:xfrm>
-            <a:off x="548640" y="1965960"/>
-            <a:ext cx="1828800" cy="2377440"/>
-          </a:xfrm>
-          <a:prstGeom prst="roundRect">
-            <a:avLst>
-              <a:gd name="adj" fmla="val 5000"/>
-            </a:avLst>
-          </a:prstGeom>
-          <a:solidFill>
-            <a:schemeClr val="bg2"/>
-          </a:solidFill>
-          <a:ln w="12700">
-            <a:solidFill>
-              <a:schemeClr val="bg2"/>
-            </a:solidFill>
-            <a:prstDash val="solid"/>
-          </a:ln>
-        </p:spPr>
-      </p:sp>
-      <p:sp>
-        <p:nvSpPr>
-          <p:cNvPr id="8" name="Text 6"/>
-          <p:cNvSpPr txBox="1"/>
-          <p:nvPr/>
-        </p:nvSpPr>
-        <p:spPr>
-          <a:xfrm>
-            <a:off x="685800" y="2103120"/>
-            <a:ext cx="1554480" cy="411480"/>
-          </a:xfrm>
-          <a:prstGeom prst="rect">
-            <a:avLst/>
-          </a:prstGeom>
-          <a:noFill/>
-          <a:ln/>
-        </p:spPr>
-        <p:txBody>
-          <a:bodyPr wrap="square" lIns="0" tIns="0" rIns="0" bIns="0" rtlCol="0" anchor="t"/>
-          <a:lstStyle/>
-          <a:p>
-            <a:pPr indent="0" marL="0">
-              <a:buNone/>
-            </a:pPr>
-            <a:r>
-              <a:rPr lang="en-US" sz="1800" b="1" dirty="0">
-                <a:solidFill>
-                  <a:schemeClr val="tx2"/>
-                </a:solidFill>
-              </a:rPr>
-              <a:t>24 Oct</a:t>
-            </a:r>
-            <a:endParaRPr lang="en-US" sz="1800" dirty="0"/>
-          </a:p>
-        </p:txBody>
-      </p:sp>
-      <p:sp>
-        <p:nvSpPr>
-          <p:cNvPr id="9" name="Text 7"/>
-          <p:cNvSpPr txBox="1"/>
-          <p:nvPr/>
-        </p:nvSpPr>
-        <p:spPr>
-          <a:xfrm>
-            <a:off x="685800" y="2560320"/>
-            <a:ext cx="1554480" cy="731520"/>
-          </a:xfrm>
-          <a:prstGeom prst="rect">
-            <a:avLst/>
-          </a:prstGeom>
-          <a:noFill/>
-          <a:ln/>
-        </p:spPr>
-        <p:txBody>
-          <a:bodyPr wrap="square" lIns="0" tIns="0" rIns="0" bIns="0" rtlCol="0" anchor="t"/>
-          <a:lstStyle/>
-          <a:p>
-            <a:pPr indent="0" marL="0">
-              <a:buNone/>
-            </a:pPr>
-            <a:r>
-              <a:rPr lang="en-US" sz="1300" b="1" dirty="0">
-                <a:solidFill>
-                  <a:schemeClr val="tx1"/>
-                </a:solidFill>
-              </a:rPr>
-              <a:t>Marco returns the finance-team count</a:t>
-            </a:r>
-            <a:endParaRPr lang="en-US" sz="1300" dirty="0"/>
-          </a:p>
-        </p:txBody>
-      </p:sp>
-      <p:sp>
-        <p:nvSpPr>
-          <p:cNvPr id="10" name="Text 8"/>
-          <p:cNvSpPr txBox="1"/>
-          <p:nvPr/>
-        </p:nvSpPr>
-        <p:spPr>
-          <a:xfrm>
-            <a:off x="685800" y="3291840"/>
-            <a:ext cx="1554480" cy="960120"/>
-          </a:xfrm>
-          <a:prstGeom prst="rect">
-            <a:avLst/>
-          </a:prstGeom>
-          <a:noFill/>
-          <a:ln/>
-        </p:spPr>
-        <p:txBody>
-          <a:bodyPr wrap="square" lIns="0" tIns="0" rIns="0" bIns="0" rtlCol="0" anchor="t"/>
-          <a:lstStyle/>
-          <a:p>
-            <a:pPr indent="0" marL="0">
-              <a:buNone/>
-            </a:pPr>
-            <a:r>
-              <a:rPr lang="en-US" sz="1100" dirty="0">
-                <a:solidFill>
-                  <a:schemeClr val="tx1"/>
-                </a:solidFill>
-              </a:rPr>
-              <a:t>Sizes Finding 2 before the decision.</a:t>
-            </a:r>
-            <a:endParaRPr lang="en-US" sz="1100" dirty="0"/>
-          </a:p>
-        </p:txBody>
-      </p:sp>
-      <p:sp>
-        <p:nvSpPr>
-          <p:cNvPr id="11" name="Shape 9"/>
-          <p:cNvSpPr/>
-          <p:nvPr/>
-        </p:nvSpPr>
-        <p:spPr>
-          <a:xfrm>
-            <a:off x="2606040" y="1463040"/>
-            <a:ext cx="329184" cy="329184"/>
-          </a:xfrm>
-          <a:prstGeom prst="ellipse">
-            <a:avLst/>
-          </a:prstGeom>
-          <a:solidFill>
-            <a:schemeClr val="accent2"/>
-          </a:solidFill>
-          <a:ln/>
-        </p:spPr>
-      </p:sp>
-      <p:sp>
-        <p:nvSpPr>
-          <p:cNvPr id="12" name="Text 10"/>
-          <p:cNvSpPr txBox="1"/>
-          <p:nvPr/>
-        </p:nvSpPr>
-        <p:spPr>
-          <a:xfrm>
-            <a:off x="2606040" y="1463040"/>
-            <a:ext cx="329184" cy="329184"/>
-          </a:xfrm>
-          <a:prstGeom prst="rect">
-            <a:avLst/>
-          </a:prstGeom>
-          <a:noFill/>
-          <a:ln/>
-        </p:spPr>
-        <p:txBody>
-          <a:bodyPr wrap="square" lIns="0" tIns="0" rIns="0" bIns="0" rtlCol="0" anchor="ctr"/>
-          <a:lstStyle/>
-          <a:p>
-            <a:pPr algn="ctr" indent="0" marL="0">
-              <a:buNone/>
-            </a:pPr>
-            <a:r>
-              <a:rPr lang="en-US" sz="1200" b="1" dirty="0">
-                <a:solidFill>
-                  <a:schemeClr val="tx2"/>
-                </a:solidFill>
-              </a:rPr>
-              <a:t>2</a:t>
-            </a:r>
-            <a:endParaRPr lang="en-US" sz="1200" dirty="0"/>
-          </a:p>
-        </p:txBody>
-      </p:sp>
-      <p:sp>
-        <p:nvSpPr>
-          <p:cNvPr id="13" name="Shape 11"/>
-          <p:cNvSpPr/>
-          <p:nvPr/>
-        </p:nvSpPr>
-        <p:spPr>
-          <a:xfrm>
-            <a:off x="2606040" y="1965960"/>
-            <a:ext cx="1828800" cy="2377440"/>
-          </a:xfrm>
-          <a:prstGeom prst="roundRect">
-            <a:avLst>
-              <a:gd name="adj" fmla="val 5000"/>
-            </a:avLst>
-          </a:prstGeom>
-          <a:solidFill>
-            <a:schemeClr val="bg2"/>
-          </a:solidFill>
-          <a:ln w="12700">
-            <a:solidFill>
-              <a:schemeClr val="bg2"/>
-            </a:solidFill>
-            <a:prstDash val="solid"/>
-          </a:ln>
-        </p:spPr>
-      </p:sp>
-      <p:sp>
-        <p:nvSpPr>
-          <p:cNvPr id="14" name="Text 12"/>
-          <p:cNvSpPr txBox="1"/>
-          <p:nvPr/>
-        </p:nvSpPr>
-        <p:spPr>
-          <a:xfrm>
-            <a:off x="2743200" y="2103120"/>
-            <a:ext cx="1554480" cy="411480"/>
-          </a:xfrm>
-          <a:prstGeom prst="rect">
-            <a:avLst/>
-          </a:prstGeom>
-          <a:noFill/>
-          <a:ln/>
-        </p:spPr>
-        <p:txBody>
-          <a:bodyPr wrap="square" lIns="0" tIns="0" rIns="0" bIns="0" rtlCol="0" anchor="t"/>
-          <a:lstStyle/>
-          <a:p>
-            <a:pPr indent="0" marL="0">
-              <a:buNone/>
-            </a:pPr>
-            <a:r>
-              <a:rPr lang="en-US" sz="1800" b="1" dirty="0">
-                <a:solidFill>
-                  <a:schemeClr val="tx2"/>
-                </a:solidFill>
-              </a:rPr>
-              <a:t>30 Oct</a:t>
-            </a:r>
-            <a:endParaRPr lang="en-US" sz="1800" dirty="0"/>
-          </a:p>
-        </p:txBody>
-      </p:sp>
-      <p:sp>
-        <p:nvSpPr>
-          <p:cNvPr id="15" name="Text 13"/>
-          <p:cNvSpPr txBox="1"/>
-          <p:nvPr/>
-        </p:nvSpPr>
-        <p:spPr>
-          <a:xfrm>
-            <a:off x="2743200" y="2560320"/>
-            <a:ext cx="1554480" cy="731520"/>
-          </a:xfrm>
-          <a:prstGeom prst="rect">
-            <a:avLst/>
-          </a:prstGeom>
-          <a:noFill/>
-          <a:ln/>
-        </p:spPr>
-        <p:txBody>
-          <a:bodyPr wrap="square" lIns="0" tIns="0" rIns="0" bIns="0" rtlCol="0" anchor="t"/>
-          <a:lstStyle/>
-          <a:p>
-            <a:pPr indent="0" marL="0">
-              <a:buNone/>
-            </a:pPr>
-            <a:r>
-              <a:rPr lang="en-US" sz="1300" b="1" dirty="0">
-                <a:solidFill>
-                  <a:schemeClr val="tx1"/>
-                </a:solidFill>
-              </a:rPr>
-              <a:t>Sam decides</a:t>
-            </a:r>
-            <a:endParaRPr lang="en-US" sz="1300" dirty="0"/>
-          </a:p>
-        </p:txBody>
-      </p:sp>
-      <p:sp>
-        <p:nvSpPr>
-          <p:cNvPr id="16" name="Text 14"/>
-          <p:cNvSpPr txBox="1"/>
-          <p:nvPr/>
-        </p:nvSpPr>
-        <p:spPr>
-          <a:xfrm>
-            <a:off x="2743200" y="3291840"/>
-            <a:ext cx="1554480" cy="960120"/>
-          </a:xfrm>
-          <a:prstGeom prst="rect">
-            <a:avLst/>
-          </a:prstGeom>
-          <a:noFill/>
-          <a:ln/>
-        </p:spPr>
-        <p:txBody>
-          <a:bodyPr wrap="square" lIns="0" tIns="0" rIns="0" bIns="0" rtlCol="0" anchor="t"/>
-          <a:lstStyle/>
-          <a:p>
-            <a:pPr indent="0" marL="0">
-              <a:buNone/>
-            </a:pPr>
-            <a:r>
-              <a:rPr lang="en-US" sz="1100" dirty="0">
-                <a:solidFill>
-                  <a:schemeClr val="tx1"/>
-                </a:solidFill>
-              </a:rPr>
-              <a:t>This deck and the report are the inputs.</a:t>
-            </a:r>
-            <a:endParaRPr lang="en-US" sz="1100" dirty="0"/>
-          </a:p>
-        </p:txBody>
-      </p:sp>
-      <p:sp>
-        <p:nvSpPr>
-          <p:cNvPr id="17" name="Shape 15"/>
-          <p:cNvSpPr/>
-          <p:nvPr/>
-        </p:nvSpPr>
-        <p:spPr>
-          <a:xfrm>
-            <a:off x="4663440" y="1463040"/>
-            <a:ext cx="329184" cy="329184"/>
-          </a:xfrm>
-          <a:prstGeom prst="ellipse">
-            <a:avLst/>
-          </a:prstGeom>
-          <a:solidFill>
-            <a:schemeClr val="accent2"/>
-          </a:solidFill>
-          <a:ln/>
-        </p:spPr>
-      </p:sp>
-      <p:sp>
-        <p:nvSpPr>
-          <p:cNvPr id="18" name="Text 16"/>
-          <p:cNvSpPr txBox="1"/>
-          <p:nvPr/>
-        </p:nvSpPr>
-        <p:spPr>
-          <a:xfrm>
-            <a:off x="4663440" y="1463040"/>
-            <a:ext cx="329184" cy="329184"/>
-          </a:xfrm>
-          <a:prstGeom prst="rect">
-            <a:avLst/>
-          </a:prstGeom>
-          <a:noFill/>
-          <a:ln/>
-        </p:spPr>
-        <p:txBody>
-          <a:bodyPr wrap="square" lIns="0" tIns="0" rIns="0" bIns="0" rtlCol="0" anchor="ctr"/>
-          <a:lstStyle/>
-          <a:p>
-            <a:pPr algn="ctr" indent="0" marL="0">
-              <a:buNone/>
-            </a:pPr>
-            <a:r>
-              <a:rPr lang="en-US" sz="1200" b="1" dirty="0">
-                <a:solidFill>
-                  <a:schemeClr val="tx2"/>
-                </a:solidFill>
-              </a:rPr>
-              <a:t>3</a:t>
-            </a:r>
-            <a:endParaRPr lang="en-US" sz="1200" dirty="0"/>
-          </a:p>
-        </p:txBody>
-      </p:sp>
-      <p:sp>
-        <p:nvSpPr>
-          <p:cNvPr id="19" name="Shape 17"/>
-          <p:cNvSpPr/>
-          <p:nvPr/>
-        </p:nvSpPr>
-        <p:spPr>
-          <a:xfrm>
-            <a:off x="4663440" y="1965960"/>
-            <a:ext cx="1828800" cy="2377440"/>
-          </a:xfrm>
-          <a:prstGeom prst="roundRect">
-            <a:avLst>
-              <a:gd name="adj" fmla="val 5000"/>
-            </a:avLst>
-          </a:prstGeom>
-          <a:solidFill>
-            <a:schemeClr val="bg2"/>
-          </a:solidFill>
-          <a:ln w="12700">
-            <a:solidFill>
-              <a:schemeClr val="bg2"/>
-            </a:solidFill>
-            <a:prstDash val="solid"/>
-          </a:ln>
-        </p:spPr>
-      </p:sp>
-      <p:sp>
-        <p:nvSpPr>
-          <p:cNvPr id="20" name="Text 18"/>
-          <p:cNvSpPr txBox="1"/>
-          <p:nvPr/>
-        </p:nvSpPr>
-        <p:spPr>
-          <a:xfrm>
-            <a:off x="4800600" y="2103120"/>
-            <a:ext cx="1554480" cy="411480"/>
-          </a:xfrm>
-          <a:prstGeom prst="rect">
-            <a:avLst/>
-          </a:prstGeom>
-          <a:noFill/>
-          <a:ln/>
-        </p:spPr>
-        <p:txBody>
-          <a:bodyPr wrap="square" lIns="0" tIns="0" rIns="0" bIns="0" rtlCol="0" anchor="t"/>
-          <a:lstStyle/>
-          <a:p>
-            <a:pPr indent="0" marL="0">
-              <a:buNone/>
-            </a:pPr>
-            <a:r>
-              <a:rPr lang="en-US" sz="1800" b="1" dirty="0">
-                <a:solidFill>
-                  <a:schemeClr val="tx2"/>
-                </a:solidFill>
-              </a:rPr>
-              <a:t>November</a:t>
-            </a:r>
-            <a:endParaRPr lang="en-US" sz="1800" dirty="0"/>
-          </a:p>
-        </p:txBody>
-      </p:sp>
-      <p:sp>
-        <p:nvSpPr>
-          <p:cNvPr id="21" name="Text 19"/>
-          <p:cNvSpPr txBox="1"/>
-          <p:nvPr/>
-        </p:nvSpPr>
-        <p:spPr>
-          <a:xfrm>
-            <a:off x="4800600" y="2560320"/>
-            <a:ext cx="1554480" cy="731520"/>
-          </a:xfrm>
-          <a:prstGeom prst="rect">
-            <a:avLst/>
-          </a:prstGeom>
-          <a:noFill/>
-          <a:ln/>
-        </p:spPr>
-        <p:txBody>
-          <a:bodyPr wrap="square" lIns="0" tIns="0" rIns="0" bIns="0" rtlCol="0" anchor="t"/>
-          <a:lstStyle/>
-          <a:p>
-            <a:pPr indent="0" marL="0">
-              <a:buNone/>
-            </a:pPr>
-            <a:r>
-              <a:rPr lang="en-US" sz="1300" b="1" dirty="0">
-                <a:solidFill>
-                  <a:schemeClr val="tx1"/>
-                </a:solidFill>
-              </a:rPr>
-              <a:t>Three follow-up sessions</a:t>
-            </a:r>
-            <a:endParaRPr lang="en-US" sz="1300" dirty="0"/>
-          </a:p>
-        </p:txBody>
-      </p:sp>
-      <p:sp>
-        <p:nvSpPr>
-          <p:cNvPr id="22" name="Text 20"/>
-          <p:cNvSpPr txBox="1"/>
-          <p:nvPr/>
-        </p:nvSpPr>
-        <p:spPr>
-          <a:xfrm>
-            <a:off x="4800600" y="3291840"/>
-            <a:ext cx="1554480" cy="960120"/>
-          </a:xfrm>
-          <a:prstGeom prst="rect">
-            <a:avLst/>
-          </a:prstGeom>
-          <a:noFill/>
-          <a:ln/>
-        </p:spPr>
-        <p:txBody>
-          <a:bodyPr wrap="square" lIns="0" tIns="0" rIns="0" bIns="0" rtlCol="0" anchor="t"/>
-          <a:lstStyle/>
-          <a:p>
-            <a:pPr indent="0" marL="0">
-              <a:buNone/>
-            </a:pPr>
-            <a:r>
-              <a:rPr lang="en-US" sz="1100" dirty="0">
-                <a:solidFill>
-                  <a:schemeClr val="tx1"/>
-                </a:solidFill>
-              </a:rPr>
-              <a:t>With finance-team customers, if the import check is approved.</a:t>
-            </a:r>
-            <a:endParaRPr lang="en-US" sz="1100" dirty="0"/>
-          </a:p>
-        </p:txBody>
-      </p:sp>
-      <p:sp>
-        <p:nvSpPr>
-          <p:cNvPr id="23" name="Shape 21"/>
-          <p:cNvSpPr/>
-          <p:nvPr/>
-        </p:nvSpPr>
-        <p:spPr>
-          <a:xfrm>
-            <a:off x="6720840" y="1463040"/>
-            <a:ext cx="329184" cy="329184"/>
-          </a:xfrm>
-          <a:prstGeom prst="ellipse">
-            <a:avLst/>
-          </a:prstGeom>
-          <a:solidFill>
-            <a:schemeClr val="accent2"/>
-          </a:solidFill>
-          <a:ln/>
-        </p:spPr>
-      </p:sp>
-      <p:sp>
-        <p:nvSpPr>
-          <p:cNvPr id="24" name="Text 22"/>
-          <p:cNvSpPr txBox="1"/>
-          <p:nvPr/>
-        </p:nvSpPr>
-        <p:spPr>
-          <a:xfrm>
-            <a:off x="6720840" y="1463040"/>
-            <a:ext cx="329184" cy="329184"/>
-          </a:xfrm>
-          <a:prstGeom prst="rect">
-            <a:avLst/>
-          </a:prstGeom>
-          <a:noFill/>
-          <a:ln/>
-        </p:spPr>
-        <p:txBody>
-          <a:bodyPr wrap="square" lIns="0" tIns="0" rIns="0" bIns="0" rtlCol="0" anchor="ctr"/>
-          <a:lstStyle/>
-          <a:p>
-            <a:pPr algn="ctr" indent="0" marL="0">
-              <a:buNone/>
-            </a:pPr>
-            <a:r>
-              <a:rPr lang="en-US" sz="1200" b="1" dirty="0">
-                <a:solidFill>
-                  <a:schemeClr val="tx2"/>
-                </a:solidFill>
-              </a:rPr>
-              <a:t>4</a:t>
-            </a:r>
-            <a:endParaRPr lang="en-US" sz="1200" dirty="0"/>
-          </a:p>
-        </p:txBody>
-      </p:sp>
-      <p:sp>
-        <p:nvSpPr>
-          <p:cNvPr id="25" name="Shape 23"/>
-          <p:cNvSpPr/>
-          <p:nvPr/>
-        </p:nvSpPr>
-        <p:spPr>
-          <a:xfrm>
-            <a:off x="6720840" y="1965960"/>
-            <a:ext cx="1828800" cy="2377440"/>
-          </a:xfrm>
-          <a:prstGeom prst="roundRect">
-            <a:avLst>
-              <a:gd name="adj" fmla="val 5000"/>
-            </a:avLst>
-          </a:prstGeom>
-          <a:solidFill>
-            <a:schemeClr val="bg2"/>
-          </a:solidFill>
-          <a:ln w="12700">
-            <a:solidFill>
-              <a:schemeClr val="bg2"/>
-            </a:solidFill>
-            <a:prstDash val="solid"/>
-          </a:ln>
-        </p:spPr>
-      </p:sp>
-      <p:sp>
-        <p:nvSpPr>
-          <p:cNvPr id="26" name="Text 24"/>
-          <p:cNvSpPr txBox="1"/>
-          <p:nvPr/>
-        </p:nvSpPr>
-        <p:spPr>
-          <a:xfrm>
-            <a:off x="6858000" y="2103120"/>
-            <a:ext cx="1554480" cy="411480"/>
-          </a:xfrm>
-          <a:prstGeom prst="rect">
-            <a:avLst/>
-          </a:prstGeom>
-          <a:noFill/>
-          <a:ln/>
-        </p:spPr>
-        <p:txBody>
-          <a:bodyPr wrap="square" lIns="0" tIns="0" rIns="0" bIns="0" rtlCol="0" anchor="t"/>
-          <a:lstStyle/>
-          <a:p>
-            <a:pPr indent="0" marL="0">
-              <a:buNone/>
-            </a:pPr>
-            <a:r>
-              <a:rPr lang="en-US" sz="1800" b="1" dirty="0">
-                <a:solidFill>
-                  <a:schemeClr val="tx2"/>
-                </a:solidFill>
-              </a:rPr>
-              <a:t>Backlog</a:t>
-            </a:r>
-            <a:endParaRPr lang="en-US" sz="1800" dirty="0"/>
-          </a:p>
-        </p:txBody>
-      </p:sp>
-      <p:sp>
-        <p:nvSpPr>
-          <p:cNvPr id="27" name="Text 25"/>
-          <p:cNvSpPr txBox="1"/>
-          <p:nvPr/>
-        </p:nvSpPr>
-        <p:spPr>
-          <a:xfrm>
-            <a:off x="6858000" y="2560320"/>
-            <a:ext cx="1554480" cy="731520"/>
-          </a:xfrm>
-          <a:prstGeom prst="rect">
-            <a:avLst/>
-          </a:prstGeom>
-          <a:noFill/>
-          <a:ln/>
-        </p:spPr>
-        <p:txBody>
-          <a:bodyPr wrap="square" lIns="0" tIns="0" rIns="0" bIns="0" rtlCol="0" anchor="t"/>
-          <a:lstStyle/>
-          <a:p>
-            <a:pPr indent="0" marL="0">
-              <a:buNone/>
-            </a:pPr>
-            <a:r>
-              <a:rPr lang="en-US" sz="1300" b="1" dirty="0">
-                <a:solidFill>
-                  <a:schemeClr val="tx1"/>
-                </a:solidFill>
-              </a:rPr>
-              <a:t>Open question</a:t>
-            </a:r>
-            <a:endParaRPr lang="en-US" sz="1300" dirty="0"/>
-          </a:p>
-        </p:txBody>
-      </p:sp>
-      <p:sp>
-        <p:nvSpPr>
-          <p:cNvPr id="28" name="Text 26"/>
-          <p:cNvSpPr txBox="1"/>
-          <p:nvPr/>
-        </p:nvSpPr>
-        <p:spPr>
-          <a:xfrm>
-            <a:off x="6858000" y="3291840"/>
-            <a:ext cx="1554480" cy="960120"/>
-          </a:xfrm>
-          <a:prstGeom prst="rect">
-            <a:avLst/>
-          </a:prstGeom>
-          <a:noFill/>
-          <a:ln/>
-        </p:spPr>
-        <p:txBody>
-          <a:bodyPr wrap="square" lIns="0" tIns="0" rIns="0" bIns="0" rtlCol="0" anchor="t"/>
-          <a:lstStyle/>
-          <a:p>
-            <a:pPr indent="0" marL="0">
-              <a:buNone/>
-            </a:pPr>
-            <a:r>
-              <a:rPr lang="en-US" sz="1100" dirty="0">
-                <a:solidFill>
-                  <a:schemeClr val="tx1"/>
-                </a:solidFill>
-              </a:rPr>
-              <a:t>Does the import gap also affect scheduled reports?</a:t>
-            </a:r>
-            <a:endParaRPr lang="en-US" sz="1100" dirty="0"/>
-          </a:p>
-        </p:txBody>
-      </p:sp>
-      <p:sp>
-        <p:nvSpPr>
-          <p:cNvPr id="25" name="Slide Number Placeholder 0"/>
-          <p:cNvSpPr>
-            <a:spLocks noGrp="1"/>
-          </p:cNvSpPr>
-          <p:nvPr>
-            <p:ph type="sldNum" sz="quarter" idx="4294967295"/>
-          </p:nvPr>
-        </p:nvSpPr>
-        <p:spPr>
-          <a:xfrm>
-            <a:off x="8229600" y="4754880"/>
-            <a:ext cx="457200" cy="274320"/>
-          </a:xfrm>
-          <a:prstGeom prst="rect">
-            <a:avLst/>
-          </a:prstGeom>
-          <a:extLst>
-            <a:ext uri="{C572A759-6A51-4108-AA02-DFA0A04FC94B}">
-              <ma14:wrappingTextBoxFlag xmlns:ma14="http://schemas.microsoft.com/office/mac/drawingml/2011/main" val="0"/>
-            </a:ext>
-          </a:extLst>
-        </p:spPr>
-        <p:txBody>
-          <a:bodyPr/>
-          <a:lstStyle>
-            <a:lvl1pPr>
-              <a:defRPr sz="900">
-                <a:solidFill>
-                  <a:schemeClr val="accent4"/>
-                </a:solidFill>
-              </a:defRPr>
-            </a:lvl1pPr>
-          </a:lstStyle>
-          <a:p>
-            <a:pPr algn="l"/>
-            <a:fld id="{F7021451-1387-4CA6-816F-3879F97B5CBC}" type="slidenum">
-              <a:rPr b="0" lang="en-US"/>
               <a:t>11</a:t>
             </a:fld>
             <a:endParaRPr lang="en-US"/>
@@ -4690,7 +4018,7 @@
                   <a:schemeClr val="accent4"/>
                 </a:solidFill>
               </a:rPr>
-              <a:t>READ WITH CARE</a:t>
+              <a:t>WHAT HAPPENS NOW</a:t>
             </a:r>
             <a:endParaRPr lang="en-US" sz="1050" dirty="0"/>
           </a:p>
@@ -4730,7 +4058,7 @@
                   <a:schemeClr val="tx2"/>
                 </a:solidFill>
               </a:rPr>
-              <a:t>Limits of this study</a:t>
+              <a:t>Next steps</a:t>
             </a:r>
             <a:endParaRPr lang="en-US" sz="2600" dirty="0"/>
           </a:p>
@@ -4738,79 +4066,26 @@
       </p:sp>
       <p:sp>
         <p:nvSpPr>
-          <p:cNvPr id="4" name="Text 2"/>
-          <p:cNvSpPr txBox="1"/>
-          <p:nvPr/>
-        </p:nvSpPr>
-        <p:spPr>
-          <a:xfrm>
-            <a:off x="548640" y="1371600"/>
-            <a:ext cx="5120640" cy="3108960"/>
-          </a:xfrm>
-          <a:prstGeom prst="rect">
-            <a:avLst/>
-          </a:prstGeom>
-          <a:noFill/>
-          <a:ln/>
-        </p:spPr>
-        <p:txBody>
-          <a:bodyPr wrap="square" lIns="0" tIns="0" rIns="0" bIns="0" rtlCol="0" anchor="t"/>
-          <a:lstStyle/>
-          <a:p>
-            <a:pPr marL="342900" indent="-342900">
-              <a:spcAft>
-                <a:spcPts val="600"/>
-              </a:spcAft>
-              <a:buSzPct val="100000"/>
-              <a:buChar char="•"/>
-            </a:pPr>
-            <a:r>
-              <a:rPr lang="en-US" sz="1400" dirty="0">
-                <a:solidFill>
-                  <a:schemeClr val="tx1"/>
-                </a:solidFill>
-              </a:rPr>
-              <a:t>Eight participants, all onboarded by CS. Self-serve customers may differ.</a:t>
-            </a:r>
-            <a:endParaRPr lang="en-US" sz="1400" dirty="0"/>
-          </a:p>
-          <a:p>
-            <a:pPr marL="342900" indent="-342900">
-              <a:spcAft>
-                <a:spcPts val="600"/>
-              </a:spcAft>
-              <a:buSzPct val="100000"/>
-              <a:buChar char="•"/>
-            </a:pPr>
-            <a:r>
-              <a:rPr lang="en-US" sz="1400" dirty="0">
-                <a:solidFill>
-                  <a:schemeClr val="tx1"/>
-                </a:solidFill>
-              </a:rPr>
-              <a:t>Two finance-team users, so Finding 2 could be bigger or smaller than it looks.</a:t>
-            </a:r>
-            <a:endParaRPr lang="en-US" sz="1400" dirty="0"/>
-          </a:p>
-          <a:p>
-            <a:pPr marL="342900" indent="-342900">
-              <a:spcAft>
-                <a:spcPts val="600"/>
-              </a:spcAft>
-              <a:buSzPct val="100000"/>
-              <a:buChar char="•"/>
-            </a:pPr>
-            <a:r>
-              <a:rPr lang="en-US" sz="1400" dirty="0">
-                <a:solidFill>
-                  <a:schemeClr val="tx1"/>
-                </a:solidFill>
-              </a:rPr>
-              <a:t>We didn’t pull the export funnel before recruiting, so we can’t say what share of customers hit Finding 1. Skipped during planning, logged 3 October.</a:t>
-            </a:r>
-            <a:endParaRPr lang="en-US" sz="1400" dirty="0"/>
-          </a:p>
-        </p:txBody>
+          <p:cNvPr id="4" name="Shape 2"/>
+          <p:cNvSpPr/>
+          <p:nvPr/>
+        </p:nvSpPr>
+        <p:spPr>
+          <a:xfrm>
+            <a:off x="713232" y="1627632"/>
+            <a:ext cx="6172200" cy="0"/>
+          </a:xfrm>
+          <a:prstGeom prst="line">
+            <a:avLst/>
+          </a:prstGeom>
+          <a:noFill/>
+          <a:ln w="19050">
+            <a:solidFill>
+              <a:srgbClr val="A7BEAE"/>
+            </a:solidFill>
+            <a:prstDash val="solid"/>
+          </a:ln>
+        </p:spPr>
       </p:sp>
       <p:sp>
         <p:nvSpPr>
@@ -4820,12 +4095,68 @@
         </p:nvSpPr>
         <p:spPr>
           <a:xfrm>
-            <a:off x="6035040" y="1371600"/>
-            <a:ext cx="2560320" cy="1737360"/>
+            <a:off x="548640" y="1463040"/>
+            <a:ext cx="329184" cy="329184"/>
+          </a:xfrm>
+          <a:prstGeom prst="ellipse">
+            <a:avLst/>
+          </a:prstGeom>
+          <a:solidFill>
+            <a:schemeClr val="accent2"/>
+          </a:solidFill>
+          <a:ln/>
+        </p:spPr>
+      </p:sp>
+      <p:sp>
+        <p:nvSpPr>
+          <p:cNvPr id="6" name="Text 4"/>
+          <p:cNvSpPr txBox="1"/>
+          <p:nvPr/>
+        </p:nvSpPr>
+        <p:spPr>
+          <a:xfrm>
+            <a:off x="548640" y="1463040"/>
+            <a:ext cx="329184" cy="329184"/>
+          </a:xfrm>
+          <a:prstGeom prst="rect">
+            <a:avLst/>
+          </a:prstGeom>
+          <a:noFill/>
+          <a:ln/>
+        </p:spPr>
+        <p:txBody>
+          <a:bodyPr wrap="square" lIns="0" tIns="0" rIns="0" bIns="0" rtlCol="0" anchor="ctr"/>
+          <a:lstStyle/>
+          <a:p>
+            <a:pPr algn="ctr" indent="0" marL="0">
+              <a:buNone/>
+            </a:pPr>
+            <a:r>
+              <a:rPr lang="en-US" sz="1200" b="1" dirty="0">
+                <a:solidFill>
+                  <a:schemeClr val="tx2"/>
+                </a:solidFill>
+              </a:rPr>
+              <a:t>1</a:t>
+            </a:r>
+            <a:endParaRPr lang="en-US" sz="1200" dirty="0"/>
+          </a:p>
+        </p:txBody>
+      </p:sp>
+      <p:sp>
+        <p:nvSpPr>
+          <p:cNvPr id="7" name="Shape 5"/>
+          <p:cNvSpPr/>
+          <p:nvPr/>
+        </p:nvSpPr>
+        <p:spPr>
+          <a:xfrm>
+            <a:off x="548640" y="1965960"/>
+            <a:ext cx="1828800" cy="2377440"/>
           </a:xfrm>
           <a:prstGeom prst="roundRect">
             <a:avLst>
-              <a:gd name="adj" fmla="val 5263"/>
+              <a:gd name="adj" fmla="val 5000"/>
             </a:avLst>
           </a:prstGeom>
           <a:solidFill>
@@ -4841,14 +4172,14 @@
       </p:sp>
       <p:sp>
         <p:nvSpPr>
-          <p:cNvPr id="6" name="Text 4"/>
-          <p:cNvSpPr txBox="1"/>
-          <p:nvPr/>
-        </p:nvSpPr>
-        <p:spPr>
-          <a:xfrm>
-            <a:off x="6217920" y="1371600"/>
-            <a:ext cx="457200" cy="548640"/>
+          <p:cNvPr id="8" name="Text 6"/>
+          <p:cNvSpPr txBox="1"/>
+          <p:nvPr/>
+        </p:nvSpPr>
+        <p:spPr>
+          <a:xfrm>
+            <a:off x="685800" y="2103120"/>
+            <a:ext cx="1554480" cy="411480"/>
           </a:xfrm>
           <a:prstGeom prst="rect">
             <a:avLst/>
@@ -4864,27 +4195,27 @@
               <a:buNone/>
             </a:pPr>
             <a:r>
-              <a:rPr lang="en-US" sz="4000" b="1" dirty="0">
-                <a:solidFill>
-                  <a:schemeClr val="accent2"/>
-                </a:solidFill>
-              </a:rPr>
-              <a:t>“</a:t>
-            </a:r>
-            <a:endParaRPr lang="en-US" sz="4000" dirty="0"/>
-          </a:p>
-        </p:txBody>
-      </p:sp>
-      <p:sp>
-        <p:nvSpPr>
-          <p:cNvPr id="7" name="Text 5"/>
-          <p:cNvSpPr txBox="1"/>
-          <p:nvPr/>
-        </p:nvSpPr>
-        <p:spPr>
-          <a:xfrm>
-            <a:off x="6217920" y="1874520"/>
-            <a:ext cx="2194560" cy="1188720"/>
+              <a:rPr lang="en-US" sz="1800" b="1" dirty="0">
+                <a:solidFill>
+                  <a:schemeClr val="tx2"/>
+                </a:solidFill>
+              </a:rPr>
+              <a:t>24 Oct</a:t>
+            </a:r>
+            <a:endParaRPr lang="en-US" sz="1800" dirty="0"/>
+          </a:p>
+        </p:txBody>
+      </p:sp>
+      <p:sp>
+        <p:nvSpPr>
+          <p:cNvPr id="9" name="Text 7"/>
+          <p:cNvSpPr txBox="1"/>
+          <p:nvPr/>
+        </p:nvSpPr>
+        <p:spPr>
+          <a:xfrm>
+            <a:off x="685800" y="2560320"/>
+            <a:ext cx="1554480" cy="731520"/>
           </a:xfrm>
           <a:prstGeom prst="rect">
             <a:avLst/>
@@ -4900,14 +4231,623 @@
               <a:buNone/>
             </a:pPr>
             <a:r>
-              <a:rPr lang="en-US" sz="1200" i="1" dirty="0">
+              <a:rPr lang="en-US" sz="1300" b="1" dirty="0">
+                <a:solidFill>
+                  <a:schemeClr val="tx1"/>
+                </a:solidFill>
+              </a:rPr>
+              <a:t>Marco returns the finance-team count</a:t>
+            </a:r>
+            <a:endParaRPr lang="en-US" sz="1300" dirty="0"/>
+          </a:p>
+        </p:txBody>
+      </p:sp>
+      <p:sp>
+        <p:nvSpPr>
+          <p:cNvPr id="10" name="Text 8"/>
+          <p:cNvSpPr txBox="1"/>
+          <p:nvPr/>
+        </p:nvSpPr>
+        <p:spPr>
+          <a:xfrm>
+            <a:off x="685800" y="3291840"/>
+            <a:ext cx="1554480" cy="960120"/>
+          </a:xfrm>
+          <a:prstGeom prst="rect">
+            <a:avLst/>
+          </a:prstGeom>
+          <a:noFill/>
+          <a:ln/>
+        </p:spPr>
+        <p:txBody>
+          <a:bodyPr wrap="square" lIns="0" tIns="0" rIns="0" bIns="0" rtlCol="0" anchor="t"/>
+          <a:lstStyle/>
+          <a:p>
+            <a:pPr indent="0" marL="0">
+              <a:buNone/>
+            </a:pPr>
+            <a:r>
+              <a:rPr lang="en-US" sz="1100" dirty="0">
+                <a:solidFill>
+                  <a:schemeClr val="tx1"/>
+                </a:solidFill>
+              </a:rPr>
+              <a:t>Sizes Finding 2 before the decision.</a:t>
+            </a:r>
+            <a:endParaRPr lang="en-US" sz="1100" dirty="0"/>
+          </a:p>
+        </p:txBody>
+      </p:sp>
+      <p:sp>
+        <p:nvSpPr>
+          <p:cNvPr id="11" name="Shape 9"/>
+          <p:cNvSpPr/>
+          <p:nvPr/>
+        </p:nvSpPr>
+        <p:spPr>
+          <a:xfrm>
+            <a:off x="2606040" y="1463040"/>
+            <a:ext cx="329184" cy="329184"/>
+          </a:xfrm>
+          <a:prstGeom prst="ellipse">
+            <a:avLst/>
+          </a:prstGeom>
+          <a:solidFill>
+            <a:schemeClr val="accent2"/>
+          </a:solidFill>
+          <a:ln/>
+        </p:spPr>
+      </p:sp>
+      <p:sp>
+        <p:nvSpPr>
+          <p:cNvPr id="12" name="Text 10"/>
+          <p:cNvSpPr txBox="1"/>
+          <p:nvPr/>
+        </p:nvSpPr>
+        <p:spPr>
+          <a:xfrm>
+            <a:off x="2606040" y="1463040"/>
+            <a:ext cx="329184" cy="329184"/>
+          </a:xfrm>
+          <a:prstGeom prst="rect">
+            <a:avLst/>
+          </a:prstGeom>
+          <a:noFill/>
+          <a:ln/>
+        </p:spPr>
+        <p:txBody>
+          <a:bodyPr wrap="square" lIns="0" tIns="0" rIns="0" bIns="0" rtlCol="0" anchor="ctr"/>
+          <a:lstStyle/>
+          <a:p>
+            <a:pPr algn="ctr" indent="0" marL="0">
+              <a:buNone/>
+            </a:pPr>
+            <a:r>
+              <a:rPr lang="en-US" sz="1200" b="1" dirty="0">
                 <a:solidFill>
                   <a:schemeClr val="tx2"/>
                 </a:solidFill>
               </a:rPr>
-              <a:t>Magpie drafted this slide. The researcher chose to keep it in. It is in the report regardless.</a:t>
+              <a:t>2</a:t>
             </a:r>
             <a:endParaRPr lang="en-US" sz="1200" dirty="0"/>
+          </a:p>
+        </p:txBody>
+      </p:sp>
+      <p:sp>
+        <p:nvSpPr>
+          <p:cNvPr id="13" name="Shape 11"/>
+          <p:cNvSpPr/>
+          <p:nvPr/>
+        </p:nvSpPr>
+        <p:spPr>
+          <a:xfrm>
+            <a:off x="2606040" y="1965960"/>
+            <a:ext cx="1828800" cy="2377440"/>
+          </a:xfrm>
+          <a:prstGeom prst="roundRect">
+            <a:avLst>
+              <a:gd name="adj" fmla="val 5000"/>
+            </a:avLst>
+          </a:prstGeom>
+          <a:solidFill>
+            <a:schemeClr val="bg2"/>
+          </a:solidFill>
+          <a:ln w="12700">
+            <a:solidFill>
+              <a:schemeClr val="bg2"/>
+            </a:solidFill>
+            <a:prstDash val="solid"/>
+          </a:ln>
+        </p:spPr>
+      </p:sp>
+      <p:sp>
+        <p:nvSpPr>
+          <p:cNvPr id="14" name="Text 12"/>
+          <p:cNvSpPr txBox="1"/>
+          <p:nvPr/>
+        </p:nvSpPr>
+        <p:spPr>
+          <a:xfrm>
+            <a:off x="2743200" y="2103120"/>
+            <a:ext cx="1554480" cy="411480"/>
+          </a:xfrm>
+          <a:prstGeom prst="rect">
+            <a:avLst/>
+          </a:prstGeom>
+          <a:noFill/>
+          <a:ln/>
+        </p:spPr>
+        <p:txBody>
+          <a:bodyPr wrap="square" lIns="0" tIns="0" rIns="0" bIns="0" rtlCol="0" anchor="t"/>
+          <a:lstStyle/>
+          <a:p>
+            <a:pPr indent="0" marL="0">
+              <a:buNone/>
+            </a:pPr>
+            <a:r>
+              <a:rPr lang="en-US" sz="1800" b="1" dirty="0">
+                <a:solidFill>
+                  <a:schemeClr val="tx2"/>
+                </a:solidFill>
+              </a:rPr>
+              <a:t>30 Oct</a:t>
+            </a:r>
+            <a:endParaRPr lang="en-US" sz="1800" dirty="0"/>
+          </a:p>
+        </p:txBody>
+      </p:sp>
+      <p:sp>
+        <p:nvSpPr>
+          <p:cNvPr id="15" name="Text 13"/>
+          <p:cNvSpPr txBox="1"/>
+          <p:nvPr/>
+        </p:nvSpPr>
+        <p:spPr>
+          <a:xfrm>
+            <a:off x="2743200" y="2560320"/>
+            <a:ext cx="1554480" cy="731520"/>
+          </a:xfrm>
+          <a:prstGeom prst="rect">
+            <a:avLst/>
+          </a:prstGeom>
+          <a:noFill/>
+          <a:ln/>
+        </p:spPr>
+        <p:txBody>
+          <a:bodyPr wrap="square" lIns="0" tIns="0" rIns="0" bIns="0" rtlCol="0" anchor="t"/>
+          <a:lstStyle/>
+          <a:p>
+            <a:pPr indent="0" marL="0">
+              <a:buNone/>
+            </a:pPr>
+            <a:r>
+              <a:rPr lang="en-US" sz="1300" b="1" dirty="0">
+                <a:solidFill>
+                  <a:schemeClr val="tx1"/>
+                </a:solidFill>
+              </a:rPr>
+              <a:t>Sam decides</a:t>
+            </a:r>
+            <a:endParaRPr lang="en-US" sz="1300" dirty="0"/>
+          </a:p>
+        </p:txBody>
+      </p:sp>
+      <p:sp>
+        <p:nvSpPr>
+          <p:cNvPr id="16" name="Text 14"/>
+          <p:cNvSpPr txBox="1"/>
+          <p:nvPr/>
+        </p:nvSpPr>
+        <p:spPr>
+          <a:xfrm>
+            <a:off x="2743200" y="3291840"/>
+            <a:ext cx="1554480" cy="960120"/>
+          </a:xfrm>
+          <a:prstGeom prst="rect">
+            <a:avLst/>
+          </a:prstGeom>
+          <a:noFill/>
+          <a:ln/>
+        </p:spPr>
+        <p:txBody>
+          <a:bodyPr wrap="square" lIns="0" tIns="0" rIns="0" bIns="0" rtlCol="0" anchor="t"/>
+          <a:lstStyle/>
+          <a:p>
+            <a:pPr indent="0" marL="0">
+              <a:buNone/>
+            </a:pPr>
+            <a:r>
+              <a:rPr lang="en-US" sz="1100" dirty="0">
+                <a:solidFill>
+                  <a:schemeClr val="tx1"/>
+                </a:solidFill>
+              </a:rPr>
+              <a:t>This deck and the report are the inputs.</a:t>
+            </a:r>
+            <a:endParaRPr lang="en-US" sz="1100" dirty="0"/>
+          </a:p>
+        </p:txBody>
+      </p:sp>
+      <p:sp>
+        <p:nvSpPr>
+          <p:cNvPr id="17" name="Shape 15"/>
+          <p:cNvSpPr/>
+          <p:nvPr/>
+        </p:nvSpPr>
+        <p:spPr>
+          <a:xfrm>
+            <a:off x="4663440" y="1463040"/>
+            <a:ext cx="329184" cy="329184"/>
+          </a:xfrm>
+          <a:prstGeom prst="ellipse">
+            <a:avLst/>
+          </a:prstGeom>
+          <a:solidFill>
+            <a:schemeClr val="accent2"/>
+          </a:solidFill>
+          <a:ln/>
+        </p:spPr>
+      </p:sp>
+      <p:sp>
+        <p:nvSpPr>
+          <p:cNvPr id="18" name="Text 16"/>
+          <p:cNvSpPr txBox="1"/>
+          <p:nvPr/>
+        </p:nvSpPr>
+        <p:spPr>
+          <a:xfrm>
+            <a:off x="4663440" y="1463040"/>
+            <a:ext cx="329184" cy="329184"/>
+          </a:xfrm>
+          <a:prstGeom prst="rect">
+            <a:avLst/>
+          </a:prstGeom>
+          <a:noFill/>
+          <a:ln/>
+        </p:spPr>
+        <p:txBody>
+          <a:bodyPr wrap="square" lIns="0" tIns="0" rIns="0" bIns="0" rtlCol="0" anchor="ctr"/>
+          <a:lstStyle/>
+          <a:p>
+            <a:pPr algn="ctr" indent="0" marL="0">
+              <a:buNone/>
+            </a:pPr>
+            <a:r>
+              <a:rPr lang="en-US" sz="1200" b="1" dirty="0">
+                <a:solidFill>
+                  <a:schemeClr val="tx2"/>
+                </a:solidFill>
+              </a:rPr>
+              <a:t>3</a:t>
+            </a:r>
+            <a:endParaRPr lang="en-US" sz="1200" dirty="0"/>
+          </a:p>
+        </p:txBody>
+      </p:sp>
+      <p:sp>
+        <p:nvSpPr>
+          <p:cNvPr id="19" name="Shape 17"/>
+          <p:cNvSpPr/>
+          <p:nvPr/>
+        </p:nvSpPr>
+        <p:spPr>
+          <a:xfrm>
+            <a:off x="4663440" y="1965960"/>
+            <a:ext cx="1828800" cy="2377440"/>
+          </a:xfrm>
+          <a:prstGeom prst="roundRect">
+            <a:avLst>
+              <a:gd name="adj" fmla="val 5000"/>
+            </a:avLst>
+          </a:prstGeom>
+          <a:solidFill>
+            <a:schemeClr val="bg2"/>
+          </a:solidFill>
+          <a:ln w="12700">
+            <a:solidFill>
+              <a:schemeClr val="bg2"/>
+            </a:solidFill>
+            <a:prstDash val="solid"/>
+          </a:ln>
+        </p:spPr>
+      </p:sp>
+      <p:sp>
+        <p:nvSpPr>
+          <p:cNvPr id="20" name="Text 18"/>
+          <p:cNvSpPr txBox="1"/>
+          <p:nvPr/>
+        </p:nvSpPr>
+        <p:spPr>
+          <a:xfrm>
+            <a:off x="4800600" y="2103120"/>
+            <a:ext cx="1554480" cy="411480"/>
+          </a:xfrm>
+          <a:prstGeom prst="rect">
+            <a:avLst/>
+          </a:prstGeom>
+          <a:noFill/>
+          <a:ln/>
+        </p:spPr>
+        <p:txBody>
+          <a:bodyPr wrap="square" lIns="0" tIns="0" rIns="0" bIns="0" rtlCol="0" anchor="t"/>
+          <a:lstStyle/>
+          <a:p>
+            <a:pPr indent="0" marL="0">
+              <a:buNone/>
+            </a:pPr>
+            <a:r>
+              <a:rPr lang="en-US" sz="1800" b="1" dirty="0">
+                <a:solidFill>
+                  <a:schemeClr val="tx2"/>
+                </a:solidFill>
+              </a:rPr>
+              <a:t>November</a:t>
+            </a:r>
+            <a:endParaRPr lang="en-US" sz="1800" dirty="0"/>
+          </a:p>
+        </p:txBody>
+      </p:sp>
+      <p:sp>
+        <p:nvSpPr>
+          <p:cNvPr id="21" name="Text 19"/>
+          <p:cNvSpPr txBox="1"/>
+          <p:nvPr/>
+        </p:nvSpPr>
+        <p:spPr>
+          <a:xfrm>
+            <a:off x="4800600" y="2560320"/>
+            <a:ext cx="1554480" cy="731520"/>
+          </a:xfrm>
+          <a:prstGeom prst="rect">
+            <a:avLst/>
+          </a:prstGeom>
+          <a:noFill/>
+          <a:ln/>
+        </p:spPr>
+        <p:txBody>
+          <a:bodyPr wrap="square" lIns="0" tIns="0" rIns="0" bIns="0" rtlCol="0" anchor="t"/>
+          <a:lstStyle/>
+          <a:p>
+            <a:pPr indent="0" marL="0">
+              <a:buNone/>
+            </a:pPr>
+            <a:r>
+              <a:rPr lang="en-US" sz="1300" b="1" dirty="0">
+                <a:solidFill>
+                  <a:schemeClr val="tx1"/>
+                </a:solidFill>
+              </a:rPr>
+              <a:t>Three follow-up sessions</a:t>
+            </a:r>
+            <a:endParaRPr lang="en-US" sz="1300" dirty="0"/>
+          </a:p>
+        </p:txBody>
+      </p:sp>
+      <p:sp>
+        <p:nvSpPr>
+          <p:cNvPr id="22" name="Text 20"/>
+          <p:cNvSpPr txBox="1"/>
+          <p:nvPr/>
+        </p:nvSpPr>
+        <p:spPr>
+          <a:xfrm>
+            <a:off x="4800600" y="3291840"/>
+            <a:ext cx="1554480" cy="960120"/>
+          </a:xfrm>
+          <a:prstGeom prst="rect">
+            <a:avLst/>
+          </a:prstGeom>
+          <a:noFill/>
+          <a:ln/>
+        </p:spPr>
+        <p:txBody>
+          <a:bodyPr wrap="square" lIns="0" tIns="0" rIns="0" bIns="0" rtlCol="0" anchor="t"/>
+          <a:lstStyle/>
+          <a:p>
+            <a:pPr indent="0" marL="0">
+              <a:buNone/>
+            </a:pPr>
+            <a:r>
+              <a:rPr lang="en-US" sz="1100" dirty="0">
+                <a:solidFill>
+                  <a:schemeClr val="tx1"/>
+                </a:solidFill>
+              </a:rPr>
+              <a:t>With finance-team customers, if the import check is approved.</a:t>
+            </a:r>
+            <a:endParaRPr lang="en-US" sz="1100" dirty="0"/>
+          </a:p>
+        </p:txBody>
+      </p:sp>
+      <p:sp>
+        <p:nvSpPr>
+          <p:cNvPr id="23" name="Shape 21"/>
+          <p:cNvSpPr/>
+          <p:nvPr/>
+        </p:nvSpPr>
+        <p:spPr>
+          <a:xfrm>
+            <a:off x="6720840" y="1463040"/>
+            <a:ext cx="329184" cy="329184"/>
+          </a:xfrm>
+          <a:prstGeom prst="ellipse">
+            <a:avLst/>
+          </a:prstGeom>
+          <a:solidFill>
+            <a:schemeClr val="accent2"/>
+          </a:solidFill>
+          <a:ln/>
+        </p:spPr>
+      </p:sp>
+      <p:sp>
+        <p:nvSpPr>
+          <p:cNvPr id="24" name="Text 22"/>
+          <p:cNvSpPr txBox="1"/>
+          <p:nvPr/>
+        </p:nvSpPr>
+        <p:spPr>
+          <a:xfrm>
+            <a:off x="6720840" y="1463040"/>
+            <a:ext cx="329184" cy="329184"/>
+          </a:xfrm>
+          <a:prstGeom prst="rect">
+            <a:avLst/>
+          </a:prstGeom>
+          <a:noFill/>
+          <a:ln/>
+        </p:spPr>
+        <p:txBody>
+          <a:bodyPr wrap="square" lIns="0" tIns="0" rIns="0" bIns="0" rtlCol="0" anchor="ctr"/>
+          <a:lstStyle/>
+          <a:p>
+            <a:pPr algn="ctr" indent="0" marL="0">
+              <a:buNone/>
+            </a:pPr>
+            <a:r>
+              <a:rPr lang="en-US" sz="1200" b="1" dirty="0">
+                <a:solidFill>
+                  <a:schemeClr val="tx2"/>
+                </a:solidFill>
+              </a:rPr>
+              <a:t>4</a:t>
+            </a:r>
+            <a:endParaRPr lang="en-US" sz="1200" dirty="0"/>
+          </a:p>
+        </p:txBody>
+      </p:sp>
+      <p:sp>
+        <p:nvSpPr>
+          <p:cNvPr id="25" name="Shape 23"/>
+          <p:cNvSpPr/>
+          <p:nvPr/>
+        </p:nvSpPr>
+        <p:spPr>
+          <a:xfrm>
+            <a:off x="6720840" y="1965960"/>
+            <a:ext cx="1828800" cy="2377440"/>
+          </a:xfrm>
+          <a:prstGeom prst="roundRect">
+            <a:avLst>
+              <a:gd name="adj" fmla="val 5000"/>
+            </a:avLst>
+          </a:prstGeom>
+          <a:solidFill>
+            <a:schemeClr val="bg2"/>
+          </a:solidFill>
+          <a:ln w="12700">
+            <a:solidFill>
+              <a:schemeClr val="bg2"/>
+            </a:solidFill>
+            <a:prstDash val="solid"/>
+          </a:ln>
+        </p:spPr>
+      </p:sp>
+      <p:sp>
+        <p:nvSpPr>
+          <p:cNvPr id="26" name="Text 24"/>
+          <p:cNvSpPr txBox="1"/>
+          <p:nvPr/>
+        </p:nvSpPr>
+        <p:spPr>
+          <a:xfrm>
+            <a:off x="6858000" y="2103120"/>
+            <a:ext cx="1554480" cy="411480"/>
+          </a:xfrm>
+          <a:prstGeom prst="rect">
+            <a:avLst/>
+          </a:prstGeom>
+          <a:noFill/>
+          <a:ln/>
+        </p:spPr>
+        <p:txBody>
+          <a:bodyPr wrap="square" lIns="0" tIns="0" rIns="0" bIns="0" rtlCol="0" anchor="t"/>
+          <a:lstStyle/>
+          <a:p>
+            <a:pPr indent="0" marL="0">
+              <a:buNone/>
+            </a:pPr>
+            <a:r>
+              <a:rPr lang="en-US" sz="1800" b="1" dirty="0">
+                <a:solidFill>
+                  <a:schemeClr val="tx2"/>
+                </a:solidFill>
+              </a:rPr>
+              <a:t>Backlog</a:t>
+            </a:r>
+            <a:endParaRPr lang="en-US" sz="1800" dirty="0"/>
+          </a:p>
+        </p:txBody>
+      </p:sp>
+      <p:sp>
+        <p:nvSpPr>
+          <p:cNvPr id="27" name="Text 25"/>
+          <p:cNvSpPr txBox="1"/>
+          <p:nvPr/>
+        </p:nvSpPr>
+        <p:spPr>
+          <a:xfrm>
+            <a:off x="6858000" y="2560320"/>
+            <a:ext cx="1554480" cy="731520"/>
+          </a:xfrm>
+          <a:prstGeom prst="rect">
+            <a:avLst/>
+          </a:prstGeom>
+          <a:noFill/>
+          <a:ln/>
+        </p:spPr>
+        <p:txBody>
+          <a:bodyPr wrap="square" lIns="0" tIns="0" rIns="0" bIns="0" rtlCol="0" anchor="t"/>
+          <a:lstStyle/>
+          <a:p>
+            <a:pPr indent="0" marL="0">
+              <a:buNone/>
+            </a:pPr>
+            <a:r>
+              <a:rPr lang="en-US" sz="1300" b="1" dirty="0">
+                <a:solidFill>
+                  <a:schemeClr val="tx1"/>
+                </a:solidFill>
+              </a:rPr>
+              <a:t>Open question</a:t>
+            </a:r>
+            <a:endParaRPr lang="en-US" sz="1300" dirty="0"/>
+          </a:p>
+        </p:txBody>
+      </p:sp>
+      <p:sp>
+        <p:nvSpPr>
+          <p:cNvPr id="28" name="Text 26"/>
+          <p:cNvSpPr txBox="1"/>
+          <p:nvPr/>
+        </p:nvSpPr>
+        <p:spPr>
+          <a:xfrm>
+            <a:off x="6858000" y="3291840"/>
+            <a:ext cx="1554480" cy="960120"/>
+          </a:xfrm>
+          <a:prstGeom prst="rect">
+            <a:avLst/>
+          </a:prstGeom>
+          <a:noFill/>
+          <a:ln/>
+        </p:spPr>
+        <p:txBody>
+          <a:bodyPr wrap="square" lIns="0" tIns="0" rIns="0" bIns="0" rtlCol="0" anchor="t"/>
+          <a:lstStyle/>
+          <a:p>
+            <a:pPr indent="0" marL="0">
+              <a:buNone/>
+            </a:pPr>
+            <a:r>
+              <a:rPr lang="en-US" sz="1100" dirty="0">
+                <a:solidFill>
+                  <a:schemeClr val="tx1"/>
+                </a:solidFill>
+              </a:rPr>
+              <a:t>Does the import gap also affect scheduled reports?</a:t>
+            </a:r>
+            <a:endParaRPr lang="en-US" sz="1100" dirty="0"/>
           </a:p>
         </p:txBody>
       </p:sp>
@@ -4991,6 +4931,329 @@
         </p:nvSpPr>
         <p:spPr>
           <a:xfrm>
+            <a:off x="548640" y="347472"/>
+            <a:ext cx="8046720" cy="274320"/>
+          </a:xfrm>
+          <a:prstGeom prst="rect">
+            <a:avLst/>
+          </a:prstGeom>
+          <a:noFill/>
+          <a:ln/>
+        </p:spPr>
+        <p:txBody>
+          <a:bodyPr wrap="square" lIns="0" tIns="0" rIns="0" bIns="0" rtlCol="0" anchor="b"/>
+          <a:lstStyle/>
+          <a:p>
+            <a:pPr indent="0" marL="0">
+              <a:buNone/>
+            </a:pPr>
+            <a:r>
+              <a:rPr lang="en-US" sz="1050" b="1" spc="200" kern="0" dirty="0">
+                <a:solidFill>
+                  <a:schemeClr val="accent4"/>
+                </a:solidFill>
+              </a:rPr>
+              <a:t>READ WITH CARE</a:t>
+            </a:r>
+            <a:endParaRPr lang="en-US" sz="1050" dirty="0"/>
+          </a:p>
+        </p:txBody>
+      </p:sp>
+      <p:sp>
+        <p:nvSpPr>
+          <p:cNvPr id="3" name="Text 0"/>
+          <p:cNvSpPr/>
+          <p:nvPr>
+            <p:ph idx="101" type="title" hasCustomPrompt="1"/>
+          </p:nvPr>
+        </p:nvSpPr>
+        <p:spPr>
+          <a:xfrm>
+            <a:off x="548640" y="640080"/>
+            <a:ext cx="8046720" cy="548640"/>
+          </a:xfrm>
+          <a:prstGeom prst="rect">
+            <a:avLst/>
+          </a:prstGeom>
+          <a:noFill/>
+          <a:ln/>
+        </p:spPr>
+        <p:txBody>
+          <a:bodyPr wrap="square" lIns="0" tIns="0" rIns="0" bIns="0" rtlCol="0" anchor="t">
+            <a:normAutofit/>
+          </a:bodyPr>
+          <a:lstStyle/>
+          <a:p>
+            <a:pPr algn="l" indent="0" marL="0">
+              <a:buNone/>
+            </a:pPr>
+            <a:r>
+              <a:rPr lang="en-US" sz="2600" b="1" dirty="0">
+                <a:solidFill>
+                  <a:schemeClr val="tx2"/>
+                </a:solidFill>
+              </a:rPr>
+              <a:t>Limits of this study</a:t>
+            </a:r>
+            <a:endParaRPr lang="en-US" sz="2600" dirty="0"/>
+          </a:p>
+        </p:txBody>
+      </p:sp>
+      <p:sp>
+        <p:nvSpPr>
+          <p:cNvPr id="4" name="Text 2"/>
+          <p:cNvSpPr txBox="1"/>
+          <p:nvPr/>
+        </p:nvSpPr>
+        <p:spPr>
+          <a:xfrm>
+            <a:off x="548640" y="1371600"/>
+            <a:ext cx="5120640" cy="3108960"/>
+          </a:xfrm>
+          <a:prstGeom prst="rect">
+            <a:avLst/>
+          </a:prstGeom>
+          <a:noFill/>
+          <a:ln/>
+        </p:spPr>
+        <p:txBody>
+          <a:bodyPr wrap="square" lIns="0" tIns="0" rIns="0" bIns="0" rtlCol="0" anchor="t"/>
+          <a:lstStyle/>
+          <a:p>
+            <a:pPr marL="342900" indent="-342900">
+              <a:spcAft>
+                <a:spcPts val="600"/>
+              </a:spcAft>
+              <a:buSzPct val="100000"/>
+              <a:buChar char="•"/>
+            </a:pPr>
+            <a:r>
+              <a:rPr lang="en-US" sz="1400" dirty="0">
+                <a:solidFill>
+                  <a:schemeClr val="tx1"/>
+                </a:solidFill>
+              </a:rPr>
+              <a:t>Eight participants, all onboarded by CS. Self-serve customers may differ.</a:t>
+            </a:r>
+            <a:endParaRPr lang="en-US" sz="1400" dirty="0"/>
+          </a:p>
+          <a:p>
+            <a:pPr marL="342900" indent="-342900">
+              <a:spcAft>
+                <a:spcPts val="600"/>
+              </a:spcAft>
+              <a:buSzPct val="100000"/>
+              <a:buChar char="•"/>
+            </a:pPr>
+            <a:r>
+              <a:rPr lang="en-US" sz="1400" dirty="0">
+                <a:solidFill>
+                  <a:schemeClr val="tx1"/>
+                </a:solidFill>
+              </a:rPr>
+              <a:t>Two finance-team users, so Finding 2 could be bigger or smaller than it looks.</a:t>
+            </a:r>
+            <a:endParaRPr lang="en-US" sz="1400" dirty="0"/>
+          </a:p>
+          <a:p>
+            <a:pPr marL="342900" indent="-342900">
+              <a:spcAft>
+                <a:spcPts val="600"/>
+              </a:spcAft>
+              <a:buSzPct val="100000"/>
+              <a:buChar char="•"/>
+            </a:pPr>
+            <a:r>
+              <a:rPr lang="en-US" sz="1400" dirty="0">
+                <a:solidFill>
+                  <a:schemeClr val="tx1"/>
+                </a:solidFill>
+              </a:rPr>
+              <a:t>We didn’t pull the export funnel before recruiting, so we can’t say what share of customers hit Finding 1. Skipped during planning, logged 3 October.</a:t>
+            </a:r>
+            <a:endParaRPr lang="en-US" sz="1400" dirty="0"/>
+          </a:p>
+        </p:txBody>
+      </p:sp>
+      <p:sp>
+        <p:nvSpPr>
+          <p:cNvPr id="5" name="Shape 3"/>
+          <p:cNvSpPr/>
+          <p:nvPr/>
+        </p:nvSpPr>
+        <p:spPr>
+          <a:xfrm>
+            <a:off x="6035040" y="1371600"/>
+            <a:ext cx="2560320" cy="1737360"/>
+          </a:xfrm>
+          <a:prstGeom prst="roundRect">
+            <a:avLst>
+              <a:gd name="adj" fmla="val 5263"/>
+            </a:avLst>
+          </a:prstGeom>
+          <a:solidFill>
+            <a:schemeClr val="bg2"/>
+          </a:solidFill>
+          <a:ln w="12700">
+            <a:solidFill>
+              <a:schemeClr val="bg2"/>
+            </a:solidFill>
+            <a:prstDash val="solid"/>
+          </a:ln>
+        </p:spPr>
+      </p:sp>
+      <p:sp>
+        <p:nvSpPr>
+          <p:cNvPr id="6" name="Text 4"/>
+          <p:cNvSpPr txBox="1"/>
+          <p:nvPr/>
+        </p:nvSpPr>
+        <p:spPr>
+          <a:xfrm>
+            <a:off x="6217920" y="1371600"/>
+            <a:ext cx="457200" cy="548640"/>
+          </a:xfrm>
+          <a:prstGeom prst="rect">
+            <a:avLst/>
+          </a:prstGeom>
+          <a:noFill/>
+          <a:ln/>
+        </p:spPr>
+        <p:txBody>
+          <a:bodyPr wrap="square" lIns="0" tIns="0" rIns="0" bIns="0" rtlCol="0" anchor="t"/>
+          <a:lstStyle/>
+          <a:p>
+            <a:pPr indent="0" marL="0">
+              <a:buNone/>
+            </a:pPr>
+            <a:r>
+              <a:rPr lang="en-US" sz="4000" b="1" dirty="0">
+                <a:solidFill>
+                  <a:schemeClr val="accent2"/>
+                </a:solidFill>
+              </a:rPr>
+              <a:t>“</a:t>
+            </a:r>
+            <a:endParaRPr lang="en-US" sz="4000" dirty="0"/>
+          </a:p>
+        </p:txBody>
+      </p:sp>
+      <p:sp>
+        <p:nvSpPr>
+          <p:cNvPr id="7" name="Text 5"/>
+          <p:cNvSpPr txBox="1"/>
+          <p:nvPr/>
+        </p:nvSpPr>
+        <p:spPr>
+          <a:xfrm>
+            <a:off x="6217920" y="1874520"/>
+            <a:ext cx="2194560" cy="1188720"/>
+          </a:xfrm>
+          <a:prstGeom prst="rect">
+            <a:avLst/>
+          </a:prstGeom>
+          <a:noFill/>
+          <a:ln/>
+        </p:spPr>
+        <p:txBody>
+          <a:bodyPr wrap="square" lIns="0" tIns="0" rIns="0" bIns="0" rtlCol="0" anchor="t"/>
+          <a:lstStyle/>
+          <a:p>
+            <a:pPr indent="0" marL="0">
+              <a:buNone/>
+            </a:pPr>
+            <a:r>
+              <a:rPr lang="en-US" sz="1200" i="1" dirty="0">
+                <a:solidFill>
+                  <a:schemeClr val="tx2"/>
+                </a:solidFill>
+              </a:rPr>
+              <a:t>Magpie drafted this slide. The researcher chose to keep it in. It is in the report regardless.</a:t>
+            </a:r>
+            <a:endParaRPr lang="en-US" sz="1200" dirty="0"/>
+          </a:p>
+        </p:txBody>
+      </p:sp>
+      <p:sp>
+        <p:nvSpPr>
+          <p:cNvPr id="25" name="Slide Number Placeholder 0"/>
+          <p:cNvSpPr>
+            <a:spLocks noGrp="1"/>
+          </p:cNvSpPr>
+          <p:nvPr>
+            <p:ph type="sldNum" sz="quarter" idx="4294967295"/>
+          </p:nvPr>
+        </p:nvSpPr>
+        <p:spPr>
+          <a:xfrm>
+            <a:off x="8229600" y="4754880"/>
+            <a:ext cx="457200" cy="274320"/>
+          </a:xfrm>
+          <a:prstGeom prst="rect">
+            <a:avLst/>
+          </a:prstGeom>
+          <a:extLst>
+            <a:ext uri="{C572A759-6A51-4108-AA02-DFA0A04FC94B}">
+              <ma14:wrappingTextBoxFlag xmlns:ma14="http://schemas.microsoft.com/office/mac/drawingml/2011/main" val="0"/>
+            </a:ext>
+          </a:extLst>
+        </p:spPr>
+        <p:txBody>
+          <a:bodyPr/>
+          <a:lstStyle>
+            <a:lvl1pPr>
+              <a:defRPr sz="900">
+                <a:solidFill>
+                  <a:schemeClr val="accent4"/>
+                </a:solidFill>
+              </a:defRPr>
+            </a:lvl1pPr>
+          </a:lstStyle>
+          <a:p>
+            <a:pPr algn="l"/>
+            <a:fld id="{F7021451-1387-4CA6-816F-3879F97B5CBC}" type="slidenum">
+              <a:rPr b="0" lang="en-US"/>
+              <a:t>13</a:t>
+            </a:fld>
+            <a:endParaRPr lang="en-US"/>
+          </a:p>
+        </p:txBody>
+      </p:sp>
+    </p:spTree>
+  </p:cSld>
+  <p:clrMapOvr>
+    <a:masterClrMapping/>
+  </p:clrMapOvr>
+</p:sld>
+</file>
+
+<file path=ppt/slides/slide14.xml><?xml version="1.0" encoding="utf-8"?>
+<p:sld xmlns:a="http://schemas.openxmlformats.org/drawingml/2006/main" xmlns:r="http://schemas.openxmlformats.org/officeDocument/2006/relationships" xmlns:p="http://schemas.openxmlformats.org/presentationml/2006/main">
+  <p:cSld name="Slide 14">
+    <p:spTree>
+      <p:nvGrpSpPr>
+        <p:cNvPr id="1" name=""/>
+        <p:cNvGrpSpPr/>
+        <p:nvPr/>
+      </p:nvGrpSpPr>
+      <p:grpSpPr>
+        <a:xfrm>
+          <a:off x="0" y="0"/>
+          <a:ext cx="0" cy="0"/>
+          <a:chOff x="0" y="0"/>
+          <a:chExt cx="0" cy="0"/>
+        </a:xfrm>
+      </p:grpSpPr>
+      <p:sp>
+        <p:nvSpPr>
+          <p:cNvPr id="2" name="Text 0"/>
+          <p:cNvSpPr/>
+          <p:nvPr>
+            <p:ph idx="100" type="body" hasCustomPrompt="1"/>
+          </p:nvPr>
+        </p:nvSpPr>
+        <p:spPr>
+          <a:xfrm>
             <a:off x="548640" y="1371600"/>
             <a:ext cx="8046720" cy="274320"/>
           </a:xfrm>
@@ -10294,7 +10557,7 @@
         </p:nvSpPr>
         <p:spPr>
           <a:xfrm>
-            <a:off x="548640" y="1371600"/>
+            <a:off x="548640" y="347472"/>
             <a:ext cx="8046720" cy="274320"/>
           </a:xfrm>
           <a:prstGeom prst="rect">
@@ -10313,10 +10576,10 @@
             <a:r>
               <a:rPr lang="en-US" sz="1050" b="1" spc="200" kern="0" dirty="0">
                 <a:solidFill>
-                  <a:schemeClr val="accent2"/>
-                </a:solidFill>
-              </a:rPr>
-              <a:t>SUMMARY</a:t>
+                  <a:schemeClr val="accent4"/>
+                </a:solidFill>
+              </a:rPr>
+              <a:t>OTHER FINDINGS</a:t>
             </a:r>
             <a:endParaRPr lang="en-US" sz="1050" dirty="0"/>
           </a:p>
@@ -10332,8 +10595,145 @@
         </p:nvSpPr>
         <p:spPr>
           <a:xfrm>
-            <a:off x="548640" y="1691640"/>
-            <a:ext cx="8046720" cy="1188720"/>
+            <a:off x="548640" y="640080"/>
+            <a:ext cx="8046720" cy="548640"/>
+          </a:xfrm>
+          <a:prstGeom prst="rect">
+            <a:avLst/>
+          </a:prstGeom>
+          <a:noFill/>
+          <a:ln/>
+        </p:spPr>
+        <p:txBody>
+          <a:bodyPr wrap="square" lIns="0" tIns="0" rIns="0" bIns="0" rtlCol="0" anchor="t">
+            <a:normAutofit/>
+          </a:bodyPr>
+          <a:lstStyle/>
+          <a:p>
+            <a:pPr algn="l" indent="0" marL="0">
+              <a:buNone/>
+            </a:pPr>
+            <a:r>
+              <a:rPr lang="en-US" sz="2600" b="1" dirty="0">
+                <a:solidFill>
+                  <a:schemeClr val="tx2"/>
+                </a:solidFill>
+              </a:rPr>
+              <a:t>Two more things the sessions showed, kept so nothing is lost</a:t>
+            </a:r>
+            <a:endParaRPr lang="en-US" sz="2600" dirty="0"/>
+          </a:p>
+        </p:txBody>
+      </p:sp>
+      <p:sp>
+        <p:nvSpPr>
+          <p:cNvPr id="4" name="Shape 2"/>
+          <p:cNvSpPr/>
+          <p:nvPr/>
+        </p:nvSpPr>
+        <p:spPr>
+          <a:xfrm>
+            <a:off x="548640" y="1417320"/>
+            <a:ext cx="1371600" cy="347472"/>
+          </a:xfrm>
+          <a:prstGeom prst="roundRect">
+            <a:avLst>
+              <a:gd name="adj" fmla="val 50000"/>
+            </a:avLst>
+          </a:prstGeom>
+          <a:solidFill>
+            <a:schemeClr val="accent6"/>
+          </a:solidFill>
+          <a:ln w="12700">
+            <a:solidFill>
+              <a:schemeClr val="accent6"/>
+            </a:solidFill>
+            <a:prstDash val="solid"/>
+          </a:ln>
+        </p:spPr>
+      </p:sp>
+      <p:sp>
+        <p:nvSpPr>
+          <p:cNvPr id="5" name="Text 3"/>
+          <p:cNvSpPr txBox="1"/>
+          <p:nvPr/>
+        </p:nvSpPr>
+        <p:spPr>
+          <a:xfrm>
+            <a:off x="548640" y="1417320"/>
+            <a:ext cx="1371600" cy="347472"/>
+          </a:xfrm>
+          <a:prstGeom prst="rect">
+            <a:avLst/>
+          </a:prstGeom>
+          <a:noFill/>
+          <a:ln/>
+        </p:spPr>
+        <p:txBody>
+          <a:bodyPr wrap="square" lIns="0" tIns="0" rIns="0" bIns="0" rtlCol="0" anchor="ctr"/>
+          <a:lstStyle/>
+          <a:p>
+            <a:pPr algn="ctr" indent="0" marL="0">
+              <a:buNone/>
+            </a:pPr>
+            <a:r>
+              <a:rPr lang="en-US" sz="1050" b="1" dirty="0">
+                <a:solidFill>
+                  <a:schemeClr val="bg1"/>
+                </a:solidFill>
+              </a:rPr>
+              <a:t>Weak</a:t>
+            </a:r>
+            <a:endParaRPr lang="en-US" sz="1050" dirty="0"/>
+          </a:p>
+        </p:txBody>
+      </p:sp>
+      <p:sp>
+        <p:nvSpPr>
+          <p:cNvPr id="6" name="Text 4"/>
+          <p:cNvSpPr txBox="1"/>
+          <p:nvPr/>
+        </p:nvSpPr>
+        <p:spPr>
+          <a:xfrm>
+            <a:off x="2103120" y="1371600"/>
+            <a:ext cx="6492240" cy="457200"/>
+          </a:xfrm>
+          <a:prstGeom prst="rect">
+            <a:avLst/>
+          </a:prstGeom>
+          <a:noFill/>
+          <a:ln/>
+        </p:spPr>
+        <p:txBody>
+          <a:bodyPr wrap="square" lIns="0" tIns="0" rIns="0" bIns="0" rtlCol="0" anchor="ctr"/>
+          <a:lstStyle/>
+          <a:p>
+            <a:pPr indent="0" marL="0">
+              <a:buNone/>
+            </a:pPr>
+            <a:r>
+              <a:rPr lang="en-US" sz="1600" dirty="0">
+                <a:solidFill>
+                  <a:schemeClr val="tx1"/>
+                </a:solidFill>
+              </a:rPr>
+              <a:t>Two participants expected export to schedule itself monthly</a:t>
+            </a:r>
+            <a:endParaRPr lang="en-US" sz="1600" dirty="0"/>
+          </a:p>
+        </p:txBody>
+      </p:sp>
+      <p:sp>
+        <p:nvSpPr>
+          <p:cNvPr id="7" name="Text 5"/>
+          <p:cNvSpPr txBox="1"/>
+          <p:nvPr/>
+        </p:nvSpPr>
+        <p:spPr>
+          <a:xfrm>
+            <a:off x="2103120" y="1847088"/>
+            <a:ext cx="6492240" cy="457200"/>
           </a:xfrm>
           <a:prstGeom prst="rect">
             <a:avLst/>
@@ -10345,90 +10745,257 @@
           <a:bodyPr wrap="square" lIns="0" tIns="0" rIns="0" bIns="0" rtlCol="0" anchor="t"/>
           <a:lstStyle/>
           <a:p>
-            <a:pPr algn="l" indent="0" marL="0">
-              <a:buNone/>
-            </a:pPr>
-            <a:r>
-              <a:rPr lang="en-US" sz="3400" b="1" dirty="0">
+            <a:pPr indent="0" marL="0">
+              <a:buNone/>
+            </a:pPr>
+            <a:r>
+              <a:rPr lang="en-US" sz="1200" dirty="0">
+                <a:solidFill>
+                  <a:schemeClr val="accent4"/>
+                </a:solidFill>
+              </a:rPr>
+              <a:t>Unexpected: outside the research questions. Worth a line in the roadmap discussion.</a:t>
+            </a:r>
+            <a:endParaRPr lang="en-US" sz="1200" dirty="0"/>
+          </a:p>
+        </p:txBody>
+      </p:sp>
+      <p:sp>
+        <p:nvSpPr>
+          <p:cNvPr id="8" name="Shape 6"/>
+          <p:cNvSpPr/>
+          <p:nvPr/>
+        </p:nvSpPr>
+        <p:spPr>
+          <a:xfrm>
+            <a:off x="2103120" y="2395728"/>
+            <a:ext cx="6492240" cy="0"/>
+          </a:xfrm>
+          <a:prstGeom prst="line">
+            <a:avLst/>
+          </a:prstGeom>
+          <a:noFill/>
+          <a:ln w="9525">
+            <a:solidFill>
+              <a:srgbClr val="EEF3EC"/>
+            </a:solidFill>
+            <a:prstDash val="solid"/>
+          </a:ln>
+        </p:spPr>
+      </p:sp>
+      <p:sp>
+        <p:nvSpPr>
+          <p:cNvPr id="9" name="Shape 7"/>
+          <p:cNvSpPr/>
+          <p:nvPr/>
+        </p:nvSpPr>
+        <p:spPr>
+          <a:xfrm>
+            <a:off x="548640" y="2606040"/>
+            <a:ext cx="1371600" cy="347472"/>
+          </a:xfrm>
+          <a:prstGeom prst="roundRect">
+            <a:avLst>
+              <a:gd name="adj" fmla="val 50000"/>
+            </a:avLst>
+          </a:prstGeom>
+          <a:solidFill>
+            <a:schemeClr val="accent6"/>
+          </a:solidFill>
+          <a:ln w="12700">
+            <a:solidFill>
+              <a:schemeClr val="accent6"/>
+            </a:solidFill>
+            <a:prstDash val="solid"/>
+          </a:ln>
+        </p:spPr>
+      </p:sp>
+      <p:sp>
+        <p:nvSpPr>
+          <p:cNvPr id="10" name="Text 8"/>
+          <p:cNvSpPr txBox="1"/>
+          <p:nvPr/>
+        </p:nvSpPr>
+        <p:spPr>
+          <a:xfrm>
+            <a:off x="548640" y="2606040"/>
+            <a:ext cx="1371600" cy="347472"/>
+          </a:xfrm>
+          <a:prstGeom prst="rect">
+            <a:avLst/>
+          </a:prstGeom>
+          <a:noFill/>
+          <a:ln/>
+        </p:spPr>
+        <p:txBody>
+          <a:bodyPr wrap="square" lIns="0" tIns="0" rIns="0" bIns="0" rtlCol="0" anchor="ctr"/>
+          <a:lstStyle/>
+          <a:p>
+            <a:pPr algn="ctr" indent="0" marL="0">
+              <a:buNone/>
+            </a:pPr>
+            <a:r>
+              <a:rPr lang="en-US" sz="1050" b="1" dirty="0">
                 <a:solidFill>
                   <a:schemeClr val="bg1"/>
                 </a:solidFill>
               </a:rPr>
-              <a:t>Fix import before touching the dialog</a:t>
-            </a:r>
-            <a:endParaRPr lang="en-US" sz="3400" dirty="0"/>
-          </a:p>
-        </p:txBody>
-      </p:sp>
-      <p:sp>
-        <p:nvSpPr>
-          <p:cNvPr id="4" name="Text 0"/>
-          <p:cNvSpPr/>
+              <a:t>Weak</a:t>
+            </a:r>
+            <a:endParaRPr lang="en-US" sz="1050" dirty="0"/>
+          </a:p>
+        </p:txBody>
+      </p:sp>
+      <p:sp>
+        <p:nvSpPr>
+          <p:cNvPr id="11" name="Text 9"/>
+          <p:cNvSpPr txBox="1"/>
+          <p:nvPr/>
+        </p:nvSpPr>
+        <p:spPr>
+          <a:xfrm>
+            <a:off x="2103120" y="2560320"/>
+            <a:ext cx="6492240" cy="457200"/>
+          </a:xfrm>
+          <a:prstGeom prst="rect">
+            <a:avLst/>
+          </a:prstGeom>
+          <a:noFill/>
+          <a:ln/>
+        </p:spPr>
+        <p:txBody>
+          <a:bodyPr wrap="square" lIns="0" tIns="0" rIns="0" bIns="0" rtlCol="0" anchor="ctr"/>
+          <a:lstStyle/>
+          <a:p>
+            <a:pPr indent="0" marL="0">
+              <a:buNone/>
+            </a:pPr>
+            <a:r>
+              <a:rPr lang="en-US" sz="1600" dirty="0">
+                <a:solidFill>
+                  <a:schemeClr val="tx1"/>
+                </a:solidFill>
+              </a:rPr>
+              <a:t>Three of eight re-selected the same columns every time</a:t>
+            </a:r>
+            <a:endParaRPr lang="en-US" sz="1600" dirty="0"/>
+          </a:p>
+        </p:txBody>
+      </p:sp>
+      <p:sp>
+        <p:nvSpPr>
+          <p:cNvPr id="12" name="Text 10"/>
+          <p:cNvSpPr txBox="1"/>
+          <p:nvPr/>
+        </p:nvSpPr>
+        <p:spPr>
+          <a:xfrm>
+            <a:off x="2103120" y="3035808"/>
+            <a:ext cx="6492240" cy="457200"/>
+          </a:xfrm>
+          <a:prstGeom prst="rect">
+            <a:avLst/>
+          </a:prstGeom>
+          <a:noFill/>
+          <a:ln/>
+        </p:spPr>
+        <p:txBody>
+          <a:bodyPr wrap="square" lIns="0" tIns="0" rIns="0" bIns="0" rtlCol="0" anchor="t"/>
+          <a:lstStyle/>
+          <a:p>
+            <a:pPr indent="0" marL="0">
+              <a:buNone/>
+            </a:pPr>
+            <a:r>
+              <a:rPr lang="en-US" sz="1200" dirty="0">
+                <a:solidFill>
+                  <a:schemeClr val="accent4"/>
+                </a:solidFill>
+              </a:rPr>
+              <a:t>The dialog doesn’t remember the last choice. Not why anyone abandoned; logged for the dialog work.</a:t>
+            </a:r>
+            <a:endParaRPr lang="en-US" sz="1200" dirty="0"/>
+          </a:p>
+        </p:txBody>
+      </p:sp>
+      <p:sp>
+        <p:nvSpPr>
+          <p:cNvPr id="13" name="Text 11"/>
+          <p:cNvSpPr txBox="1"/>
+          <p:nvPr/>
+        </p:nvSpPr>
+        <p:spPr>
+          <a:xfrm>
+            <a:off x="548640" y="3931920"/>
+            <a:ext cx="8046720" cy="548640"/>
+          </a:xfrm>
+          <a:prstGeom prst="rect">
+            <a:avLst/>
+          </a:prstGeom>
+          <a:noFill/>
+          <a:ln/>
+        </p:spPr>
+        <p:txBody>
+          <a:bodyPr wrap="square" lIns="0" tIns="0" rIns="0" bIns="0" rtlCol="0" anchor="ctr"/>
+          <a:lstStyle/>
+          <a:p>
+            <a:pPr indent="0" marL="0">
+              <a:buNone/>
+            </a:pPr>
+            <a:r>
+              <a:rPr lang="en-US" sz="1200" dirty="0">
+                <a:solidFill>
+                  <a:schemeClr val="tx1"/>
+                </a:solidFill>
+              </a:rPr>
+              <a:t>Every finding that met the evidence bar is on this deck: the five above, or here. The full table is in the appendix.</a:t>
+            </a:r>
+            <a:endParaRPr lang="en-US" sz="1200" dirty="0"/>
+          </a:p>
+        </p:txBody>
+      </p:sp>
+      <p:sp>
+        <p:nvSpPr>
+          <p:cNvPr id="25" name="Slide Number Placeholder 0"/>
+          <p:cNvSpPr>
+            <a:spLocks noGrp="1"/>
+          </p:cNvSpPr>
           <p:nvPr>
-            <p:ph idx="102" type="body" hasCustomPrompt="1"/>
+            <p:ph type="sldNum" sz="quarter" idx="4294967295"/>
           </p:nvPr>
         </p:nvSpPr>
         <p:spPr>
           <a:xfrm>
-            <a:off x="548640" y="2971800"/>
-            <a:ext cx="8046720" cy="1463040"/>
-          </a:xfrm>
-          <a:prstGeom prst="rect">
-            <a:avLst/>
-          </a:prstGeom>
-          <a:noFill/>
-          <a:ln/>
-        </p:spPr>
-        <p:txBody>
-          <a:bodyPr wrap="square" lIns="0" tIns="0" rIns="0" bIns="0" rtlCol="0" anchor="t"/>
-          <a:lstStyle/>
-          <a:p>
-            <a:pPr indent="0" marL="0">
-              <a:spcAft>
-                <a:spcPts val="600"/>
-              </a:spcAft>
-              <a:buNone/>
-            </a:pPr>
-            <a:r>
-              <a:rPr lang="en-US" sz="1600" dirty="0">
-                <a:solidFill>
-                  <a:schemeClr val="bg2"/>
-                </a:solidFill>
-              </a:rPr>
-              <a:t>We asked why people abandon export. Mostly they don’t fail at export; they fail at import and only notice at export.</a:t>
-            </a:r>
-            <a:endParaRPr lang="en-US" sz="1600" dirty="0"/>
-          </a:p>
-          <a:p>
-            <a:pPr indent="0" marL="0">
-              <a:spcAft>
-                <a:spcPts val="600"/>
-              </a:spcAft>
-              <a:buNone/>
-            </a:pPr>
-            <a:r>
-              <a:rPr lang="en-US" sz="1600" dirty="0">
-                <a:solidFill>
-                  <a:schemeClr val="bg2"/>
-                </a:solidFill>
-              </a:rPr>
-              <a:t>A separate, smaller group is fully blocked by column order.</a:t>
-            </a:r>
-            <a:endParaRPr lang="en-US" sz="1600" dirty="0"/>
-          </a:p>
-          <a:p>
-            <a:pPr indent="0" marL="0">
-              <a:buNone/>
-            </a:pPr>
-            <a:r>
-              <a:rPr lang="en-US" sz="1600" dirty="0">
-                <a:solidFill>
-                  <a:schemeClr val="bg2"/>
-                </a:solidFill>
-              </a:rPr>
-              <a:t>Confidence is moderate overall: eight sessions, one segment over-represented.</a:t>
-            </a:r>
-            <a:endParaRPr lang="en-US" sz="1600" dirty="0"/>
+            <a:off x="8229600" y="4754880"/>
+            <a:ext cx="457200" cy="274320"/>
+          </a:xfrm>
+          <a:prstGeom prst="rect">
+            <a:avLst/>
+          </a:prstGeom>
+          <a:extLst>
+            <a:ext uri="{C572A759-6A51-4108-AA02-DFA0A04FC94B}">
+              <ma14:wrappingTextBoxFlag xmlns:ma14="http://schemas.microsoft.com/office/mac/drawingml/2011/main" val="0"/>
+            </a:ext>
+          </a:extLst>
+        </p:spPr>
+        <p:txBody>
+          <a:bodyPr/>
+          <a:lstStyle>
+            <a:lvl1pPr>
+              <a:defRPr sz="900">
+                <a:solidFill>
+                  <a:schemeClr val="accent4"/>
+                </a:solidFill>
+              </a:defRPr>
+            </a:lvl1pPr>
+          </a:lstStyle>
+          <a:p>
+            <a:pPr algn="l"/>
+            <a:fld id="{F7021451-1387-4CA6-816F-3879F97B5CBC}" type="slidenum">
+              <a:rPr b="0" lang="en-US"/>
+              <a:t>9</a:t>
+            </a:fld>
+            <a:endParaRPr lang="en-US"/>
           </a:p>
         </p:txBody>
       </p:sp>

</xml_diff>

<commit_message>
Redo the example report and readout in the house style
The examples predated the house style, quote labels and the "How AI was
used" section, so they no longer showed what Magpie writes. Both are
rewritten: claim headings and slide titles with numerals, quotes labelled
with role and company size, a [name] placeholder, a participant profile,
and the AI section. Finding 5 is now among the other findings, and two
contradictions in the old example are fixed. The deck keeps its design;
the Word files are rebuilt with pandoc from the Markdown and the current
templates.

Co-Authored-By: Claude Opus 5.5 <noreply@anthropic.com>
Claude-Session: https://claude.ai/code/session_012PVcpMwMCyL4PW5gYu9kZV
</commit_message>
<xml_diff>
--- a/docs/examples/example-readout.pptx
+++ b/docs/examples/example-readout.pptx
@@ -19,6 +19,7 @@
     <p:sldId id="267" r:id="rId13"/>
     <p:sldId id="268" r:id="rId14"/>
     <p:sldId id="269" r:id="rId15"/>
+    <p:sldId id="270" r:id="rId21"/>
   </p:sldIdLst>
   <p:notesMasterIdLst>
     <p:notesMasterId r:id="rId16"/>
@@ -2553,7 +2554,7 @@
                   <a:schemeClr val="bg1"/>
                 </a:solidFill>
               </a:rPr>
-              <a:t>Why mid-size customers abandon export in Ledgerline</a:t>
+              <a:t>Fix import before rebuilding the export dialog</a:t>
             </a:r>
             <a:endParaRPr lang="en-US" sz="3400" dirty="0"/>
           </a:p>
@@ -2619,7 +2620,7 @@
                   <a:schemeClr val="bg2"/>
                 </a:solidFill>
               </a:rPr>
-              <a:t>Eight sessions · 6 to 10 October 2026</a:t>
+              <a:t>8 sessions · 6 to 10 October 2026</a:t>
             </a:r>
             <a:endParaRPr lang="en-US" sz="1600" dirty="0"/>
           </a:p>
@@ -2720,7 +2721,7 @@
                   <a:schemeClr val="bg1"/>
                 </a:solidFill>
               </a:rPr>
-              <a:t>Fix import before touching the dialog</a:t>
+              <a:t>Most exports fail at import, so fix import first</a:t>
             </a:r>
             <a:endParaRPr lang="en-US" sz="3400" dirty="0"/>
           </a:p>
@@ -2761,7 +2762,7 @@
                   <a:schemeClr val="bg2"/>
                 </a:solidFill>
               </a:rPr>
-              <a:t>We asked why people abandon export. Mostly they don’t fail at export; they fail at import and only notice at export.</a:t>
+              <a:t>We asked why people abandon export. Mostly they fail at import and only notice it at export.</a:t>
             </a:r>
             <a:endParaRPr lang="en-US" sz="1600" dirty="0"/>
           </a:p>
@@ -2778,7 +2779,7 @@
                   <a:schemeClr val="bg2"/>
                 </a:solidFill>
               </a:rPr>
-              <a:t>A separate, smaller group is fully blocked by column order.</a:t>
+              <a:t>A smaller group, finance teams, is fully blocked by column order.</a:t>
             </a:r>
             <a:endParaRPr lang="en-US" sz="1600" dirty="0"/>
           </a:p>
@@ -2792,7 +2793,7 @@
                   <a:schemeClr val="bg2"/>
                 </a:solidFill>
               </a:rPr>
-              <a:t>Confidence is moderate overall: eight sessions, one segment over-represented.</a:t>
+              <a:t>Confidence is moderate overall: 8 sessions, all recruited through CS.</a:t>
             </a:r>
             <a:endParaRPr lang="en-US" sz="1600" dirty="0"/>
           </a:p>
@@ -2895,7 +2896,7 @@
                   <a:schemeClr val="tx2"/>
                 </a:solidFill>
               </a:rPr>
-              <a:t>Recommendations</a:t>
+              <a:t>Four actions, each with an owner</a:t>
             </a:r>
             <a:endParaRPr lang="en-US" sz="2600" dirty="0"/>
           </a:p>
@@ -3169,7 +3170,7 @@
                             <a:schemeClr val="tx1"/>
                           </a:solidFill>
                         </a:rPr>
-                        <a:t>Add a column-mapping check at import that warns when saved reports use unmapped columns</a:t>
+                        <a:t>Warn at import when saved reports use unmapped columns</a:t>
                       </a:r>
                       <a:endParaRPr lang="en-US" sz="1100" dirty="0"/>
                     </a:p>
@@ -3430,7 +3431,7 @@
                             <a:schemeClr val="tx1"/>
                           </a:solidFill>
                         </a:rPr>
-                        <a:t>Findings 1, 3</a:t>
+                        <a:t>Findings 1 and 3</a:t>
                       </a:r>
                       <a:endParaRPr lang="en-US" sz="1100" dirty="0"/>
                     </a:p>
@@ -3580,7 +3581,7 @@
                             <a:schemeClr val="tx1"/>
                           </a:solidFill>
                         </a:rPr>
-                        <a:t>Support (Marco) with CS</a:t>
+                        <a:t>Support (Marco), with CS</a:t>
                       </a:r>
                       <a:endParaRPr lang="en-US" sz="1100" dirty="0"/>
                     </a:p>
@@ -3654,7 +3655,7 @@
                             <a:schemeClr val="tx1"/>
                           </a:solidFill>
                         </a:rPr>
-                        <a:t>Whether column order is Q1 or later</a:t>
+                        <a:t>Whether column order goes in Q1 or later</a:t>
                       </a:r>
                       <a:endParaRPr lang="en-US" sz="1100" dirty="0"/>
                     </a:p>
@@ -3899,19 +3900,11 @@
                   <a:schemeClr val="accent4"/>
                 </a:solidFill>
               </a:rPr>
-              <a:t>The uncomfortable one is row two. </a:t>
+              <a:t>Action 2 is the uncomfortable one: the study was commissioned for a dialog rebuild, and the evidence says the rebuild would miss the cause.</a:t>
             </a:r>
             <a:pPr indent="0" marL="0">
               <a:buNone/>
             </a:pPr>
-            <a:r>
-              <a:rPr lang="en-US" sz="1200" dirty="0">
-                <a:solidFill>
-                  <a:schemeClr val="accent4"/>
-                </a:solidFill>
-              </a:rPr>
-              <a:t>The study was commissioned to inform a dialog rebuild, and the evidence says the rebuild would miss the cause.</a:t>
-            </a:r>
             <a:endParaRPr lang="en-US" sz="1200" dirty="0"/>
           </a:p>
         </p:txBody>
@@ -4058,7 +4051,7 @@
                   <a:schemeClr val="tx2"/>
                 </a:solidFill>
               </a:rPr>
-              <a:t>Next steps</a:t>
+              <a:t>Sam decides on 30 October, after Support sizes finding 2</a:t>
             </a:r>
             <a:endParaRPr lang="en-US" sz="2600" dirty="0"/>
           </a:p>
@@ -4272,7 +4265,7 @@
                   <a:schemeClr val="tx1"/>
                 </a:solidFill>
               </a:rPr>
-              <a:t>Sizes Finding 2 before the decision.</a:t>
+              <a:t>Sizes finding 2 before the decision.</a:t>
             </a:r>
             <a:endParaRPr lang="en-US" sz="1100" dirty="0"/>
           </a:p>
@@ -4618,7 +4611,7 @@
                   <a:schemeClr val="tx1"/>
                 </a:solidFill>
               </a:rPr>
-              <a:t>Three follow-up sessions</a:t>
+              <a:t>3 follow-up sessions</a:t>
             </a:r>
             <a:endParaRPr lang="en-US" sz="1300" dirty="0"/>
           </a:p>
@@ -4993,7 +4986,7 @@
                   <a:schemeClr val="tx2"/>
                 </a:solidFill>
               </a:rPr>
-              <a:t>Limits of this study</a:t>
+              <a:t>What this study can’t tell us</a:t>
             </a:r>
             <a:endParaRPr lang="en-US" sz="2600" dirty="0"/>
           </a:p>
@@ -5033,7 +5026,7 @@
                   <a:schemeClr val="tx1"/>
                 </a:solidFill>
               </a:rPr>
-              <a:t>Eight participants, all onboarded by CS. Self-serve customers may differ.</a:t>
+              <a:t>All 8 participants were recruited through CS, so self-serve customers may differ.</a:t>
             </a:r>
             <a:endParaRPr lang="en-US" sz="1400" dirty="0"/>
           </a:p>
@@ -5051,7 +5044,7 @@
                   <a:schemeClr val="tx1"/>
                 </a:solidFill>
               </a:rPr>
-              <a:t>Two finance-team users, so Finding 2 could be bigger or smaller than it looks.</a:t>
+              <a:t>Only 2 were from finance teams, so finding 2 could be bigger or smaller than it looks.</a:t>
             </a:r>
             <a:endParaRPr lang="en-US" sz="1400" dirty="0"/>
           </a:p>
@@ -5069,7 +5062,7 @@
                   <a:schemeClr val="tx1"/>
                 </a:solidFill>
               </a:rPr>
-              <a:t>We didn’t pull the export funnel before recruiting, so we can’t say what share of customers hit Finding 1. Skipped during planning, logged 3 October.</a:t>
+              <a:t>We didn’t pull the export funnel before recruiting, so we can’t say what share of customers hit finding 1.</a:t>
             </a:r>
             <a:endParaRPr lang="en-US" sz="1400" dirty="0"/>
           </a:p>
@@ -5168,7 +5161,7 @@
                   <a:schemeClr val="tx2"/>
                 </a:solidFill>
               </a:rPr>
-              <a:t>Magpie drafted this slide. The researcher chose to keep it in. It is in the report regardless.</a:t>
+              <a:t>Magpie drafted this slide and the researcher chose to keep it in. The limits are in the report either way.</a:t>
             </a:r>
             <a:endParaRPr lang="en-US" sz="1200" dirty="0"/>
           </a:p>
@@ -5314,7 +5307,7 @@
                   <a:schemeClr val="bg1"/>
                 </a:solidFill>
               </a:rPr>
-              <a:t>Appendix</a:t>
+              <a:t>Appendix: for the deeper dive</a:t>
             </a:r>
             <a:endParaRPr lang="en-US" sz="3400" dirty="0"/>
           </a:p>
@@ -5353,7 +5346,7 @@
                   <a:schemeClr val="bg2"/>
                 </a:solidFill>
               </a:rPr>
-              <a:t>Participant profile</a:t>
+              <a:t>Participant profile, with role, seats and team for P1 to P8</a:t>
             </a:r>
             <a:endParaRPr lang="en-US" sz="1600" dirty="0"/>
           </a:p>
@@ -5368,7 +5361,7 @@
                   <a:schemeClr val="bg2"/>
                 </a:solidFill>
               </a:rPr>
-              <a:t>Full findings with coding frame and all quotes</a:t>
+              <a:t>Full findings with the coding frame and every quote</a:t>
             </a:r>
             <a:endParaRPr lang="en-US" sz="1600" dirty="0"/>
           </a:p>
@@ -5383,7 +5376,7 @@
                   <a:schemeClr val="bg2"/>
                 </a:solidFill>
               </a:rPr>
-              <a:t>Guide and task script</a:t>
+              <a:t>The interview guide and task script</a:t>
             </a:r>
             <a:endParaRPr lang="en-US" sz="1600" dirty="0"/>
           </a:p>
@@ -5413,7 +5406,200 @@
                   <a:schemeClr val="bg2"/>
                 </a:solidFill>
               </a:rPr>
-              <a:t>Links: study record, report, recordings (access-controlled)</a:t>
+              <a:t>Links to the study record, the report and the recordings (access-controlled)</a:t>
+            </a:r>
+            <a:endParaRPr lang="en-US" sz="1600" dirty="0"/>
+          </a:p>
+        </p:txBody>
+      </p:sp>
+    </p:spTree>
+  </p:cSld>
+  <p:clrMapOvr>
+    <a:masterClrMapping/>
+  </p:clrMapOvr>
+</p:sld>
+</file>
+
+<file path=ppt/slides/slide15.xml><?xml version="1.0" encoding="utf-8"?>
+<p:sld xmlns:a="http://schemas.openxmlformats.org/drawingml/2006/main" xmlns:p="http://schemas.openxmlformats.org/presentationml/2006/main" xmlns:r="http://schemas.openxmlformats.org/officeDocument/2006/relationships">
+  <p:cSld>
+    <p:spTree>
+      <p:nvGrpSpPr>
+        <p:cNvPr id="1" name=""/>
+        <p:cNvGrpSpPr/>
+        <p:nvPr/>
+      </p:nvGrpSpPr>
+      <p:grpSpPr/>
+      <p:sp>
+        <p:nvSpPr>
+          <p:cNvPr id="2" name="Text 0"/>
+          <p:cNvSpPr/>
+          <p:nvPr>
+            <p:ph idx="100" type="body" hasCustomPrompt="1"/>
+          </p:nvPr>
+        </p:nvSpPr>
+        <p:spPr>
+          <a:xfrm>
+            <a:off x="548640" y="731520"/>
+            <a:ext cx="8046720" cy="274320"/>
+          </a:xfrm>
+          <a:prstGeom prst="rect">
+            <a:avLst/>
+          </a:prstGeom>
+          <a:noFill/>
+          <a:ln/>
+        </p:spPr>
+        <p:txBody>
+          <a:bodyPr wrap="square" lIns="0" tIns="0" rIns="0" bIns="0" rtlCol="0" anchor="b"/>
+          <a:lstStyle/>
+          <a:p>
+            <a:pPr indent="0" marL="0">
+              <a:buNone/>
+            </a:pPr>
+            <a:r>
+              <a:rPr lang="en-US" sz="1050" b="1" spc="200" kern="0" dirty="0">
+                <a:solidFill>
+                  <a:schemeClr val="accent2"/>
+                </a:solidFill>
+              </a:rPr>
+              <a:t>APPENDIX</a:t>
+            </a:r>
+            <a:endParaRPr lang="en-US" sz="1050" dirty="0"/>
+          </a:p>
+        </p:txBody>
+      </p:sp>
+      <p:sp>
+        <p:nvSpPr>
+          <p:cNvPr id="3" name="Text 0"/>
+          <p:cNvSpPr/>
+          <p:nvPr>
+            <p:ph idx="101" type="title" hasCustomPrompt="1"/>
+          </p:nvPr>
+        </p:nvSpPr>
+        <p:spPr>
+          <a:xfrm>
+            <a:off x="548640" y="1051560"/>
+            <a:ext cx="8046720" cy="1188720"/>
+          </a:xfrm>
+          <a:prstGeom prst="rect">
+            <a:avLst/>
+          </a:prstGeom>
+          <a:noFill/>
+          <a:ln/>
+        </p:spPr>
+        <p:txBody>
+          <a:bodyPr wrap="square" lIns="0" tIns="0" rIns="0" bIns="0" rtlCol="0" anchor="t"/>
+          <a:lstStyle/>
+          <a:p>
+            <a:pPr algn="l" indent="0" marL="0">
+              <a:buNone/>
+            </a:pPr>
+            <a:r>
+              <a:rPr lang="en-US" sz="3400" b="1" dirty="0">
+                <a:solidFill>
+                  <a:schemeClr val="bg1"/>
+                </a:solidFill>
+              </a:rPr>
+              <a:t>How AI was used</a:t>
+            </a:r>
+            <a:endParaRPr lang="en-US" sz="3400" dirty="0"/>
+          </a:p>
+        </p:txBody>
+      </p:sp>
+      <p:sp>
+        <p:nvSpPr>
+          <p:cNvPr id="4" name="Text 0"/>
+          <p:cNvSpPr/>
+          <p:nvPr>
+            <p:ph idx="102" type="body" hasCustomPrompt="1"/>
+          </p:nvPr>
+        </p:nvSpPr>
+        <p:spPr>
+          <a:xfrm>
+            <a:off x="548640" y="2331720"/>
+            <a:ext cx="8046720" cy="1463040"/>
+          </a:xfrm>
+          <a:prstGeom prst="rect">
+            <a:avLst/>
+          </a:prstGeom>
+          <a:noFill/>
+          <a:ln/>
+        </p:spPr>
+        <p:txBody>
+          <a:bodyPr wrap="square" lIns="0" tIns="0" rIns="0" bIns="0" rtlCol="0" anchor="t"/>
+          <a:lstStyle/>
+          <a:p>
+            <a:pPr marL="342900" indent="-342900">
+              <a:buSzPct val="100000"/>
+              <a:buChar char="•"/>
+            </a:pPr>
+            <a:r>
+              <a:rPr lang="en-US" sz="1600" dirty="0">
+                <a:solidFill>
+                  <a:schemeClr val="bg2"/>
+                </a:solidFill>
+              </a:rPr>
+              <a:t>Magpie, in Claude Code, drafted the plan, guide, findings, report and this deck.</a:t>
+            </a:r>
+            <a:endParaRPr lang="en-US" sz="1600" dirty="0"/>
+          </a:p>
+          <a:p>
+            <a:pPr marL="342900" indent="-342900">
+              <a:buSzPct val="100000"/>
+              <a:buChar char="•"/>
+            </a:pPr>
+            <a:r>
+              <a:rPr lang="en-US" sz="1600" dirty="0">
+                <a:solidFill>
+                  <a:schemeClr val="bg2"/>
+                </a:solidFill>
+              </a:rPr>
+              <a:t>Priya ran every session, named her own patterns first, decided each theme, and wrote the recommendations.</a:t>
+            </a:r>
+            <a:endParaRPr lang="en-US" sz="1600" dirty="0"/>
+          </a:p>
+          <a:p>
+            <a:pPr marL="342900" indent="-342900">
+              <a:buSzPct val="100000"/>
+              <a:buChar char="•"/>
+            </a:pPr>
+            <a:r>
+              <a:rPr lang="en-US" sz="1600" dirty="0">
+                <a:solidFill>
+                  <a:schemeClr val="bg2"/>
+                </a:solidFill>
+              </a:rPr>
+              <a:t>She reviewed the findings on 12 October and this deck on 14 October.</a:t>
+            </a:r>
+            <a:endParaRPr lang="en-US" sz="1600" dirty="0"/>
+          </a:p>
+          <a:p>
+            <a:pPr marL="342900" indent="-342900">
+              <a:buSzPct val="100000"/>
+              <a:buChar char="•"/>
+            </a:pPr>
+            <a:r>
+              <a:rPr lang="en-US" sz="1600" dirty="0">
+                <a:solidFill>
+                  <a:schemeClr val="bg2"/>
+                </a:solidFill>
+              </a:rPr>
+              <a:t>Quotes and counts were checked by code; an AI reviewer raised 11 points and 8 changed the findings.</a:t>
+            </a:r>
+            <a:endParaRPr lang="en-US" sz="1600" dirty="0"/>
+          </a:p>
+          <a:p>
+            <a:pPr marL="342900" indent="-342900">
+              <a:buSzPct val="100000"/>
+              <a:buChar char="•"/>
+            </a:pPr>
+            <a:r>
+              <a:rPr lang="en-US" sz="1600" dirty="0">
+                <a:solidFill>
+                  <a:schemeClr val="bg2"/>
+                </a:solidFill>
+              </a:rPr>
+              <a:t>The reviewer is a model too and can be wrong. The video tool transcribed the sessions.</a:t>
             </a:r>
             <a:endParaRPr lang="en-US" sz="1600" dirty="0"/>
           </a:p>
@@ -5516,7 +5702,7 @@
                   <a:schemeClr val="tx2"/>
                 </a:solidFill>
               </a:rPr>
-              <a:t>Why we did this</a:t>
+              <a:t>We studied export to decide where Q1 engineering time goes</a:t>
             </a:r>
             <a:endParaRPr lang="en-US" sz="2600" dirty="0"/>
           </a:p>
@@ -5795,7 +5981,7 @@
                   <a:schemeClr val="tx1"/>
                 </a:solidFill>
               </a:rPr>
-              <a:t>“Weekly active sharers” is our H2 goal. 212 export tickets in Q3 [Support].</a:t>
+              <a:t>“Weekly active sharers” is our H2 goal, and Support logged 212 export tickets in Q3 [Support].</a:t>
             </a:r>
             <a:endParaRPr lang="en-US" sz="1250" dirty="0"/>
           </a:p>
@@ -5946,7 +6132,7 @@
                   <a:schemeClr val="tx1"/>
                 </a:solidFill>
               </a:rPr>
-              <a:t>Export is the second most-used admin feature [2025 survey]. No research on why it fails. Field reps: “customers hate the export” [indirect].</a:t>
+              <a:t>Export is the second most-used admin feature [2025 survey], and nobody had studied why it fails.</a:t>
             </a:r>
             <a:endParaRPr lang="en-US" sz="1250" dirty="0"/>
           </a:p>
@@ -6248,7 +6434,7 @@
                   <a:schemeClr val="tx1"/>
                 </a:solidFill>
               </a:rPr>
-              <a:t>Job: get the month’s numbers into finance. Journey: Share a report, step 3 of 4. Persona: Report builder.</a:t>
+              <a:t>Export, which report builders use weekly: step 3 of 4 of “Share a report”, for the Report builder persona.</a:t>
             </a:r>
             <a:endParaRPr lang="en-US" sz="1250" dirty="0"/>
           </a:p>
@@ -6396,7 +6582,7 @@
                   <a:schemeClr val="tx2"/>
                 </a:solidFill>
               </a:rPr>
-              <a:t>What we did</a:t>
+              <a:t>We watched 8 report builders try a real export on their own accounts</a:t>
             </a:r>
             <a:endParaRPr lang="en-US" sz="2600" dirty="0"/>
           </a:p>
@@ -6828,7 +7014,7 @@
                   <a:schemeClr val="tx1"/>
                 </a:solidFill>
               </a:rPr>
-              <a:t>Report builders at mid-size customers, recruited from our own users by the CS team. A short interview about their last export, then a live export task on their own account: export last month’s revenue report to CSV.</a:t>
+              <a:t>Report builders at mid-size customers, recruited from our own customers by the CS team. A short interview about their last export, then a live export task on their own account: export last month’s revenue report to CSV.</a:t>
             </a:r>
             <a:endParaRPr lang="en-US" sz="1400" dirty="0"/>
           </a:p>
@@ -7012,7 +7198,7 @@
                   <a:schemeClr val="tx2"/>
                 </a:solidFill>
               </a:rPr>
-              <a:t>Top findings, in order of strength and impact</a:t>
+              <a:t>Four findings the decision rests on, ranked</a:t>
             </a:r>
             <a:endParaRPr lang="en-US" sz="2600" dirty="0"/>
           </a:p>
@@ -7104,7 +7290,7 @@
                   <a:schemeClr val="tx1"/>
                 </a:solidFill>
               </a:rPr>
-              <a:t>Most abandoned exports fail at import, not export</a:t>
+              <a:t>For 5 of 8, export failed because import never mapped the columns</a:t>
             </a:r>
             <a:endParaRPr lang="en-US" sz="1600" dirty="0"/>
           </a:p>
@@ -7282,7 +7468,7 @@
                   <a:schemeClr val="tx1"/>
                 </a:solidFill>
               </a:rPr>
-              <a:t>Finance-team participants could not complete any export</a:t>
+              <a:t>Both finance-team participants couldn’t get a file their finance system accepts</a:t>
             </a:r>
             <a:endParaRPr lang="en-US" sz="1600" dirty="0"/>
           </a:p>
@@ -7345,7 +7531,7 @@
                   <a:schemeClr val="bg1"/>
                 </a:solidFill>
               </a:rPr>
-              <a:t>Weak, but serious</a:t>
+              <a:t>Weak · serious case</a:t>
             </a:r>
             <a:endParaRPr lang="en-US" sz="1050" dirty="0"/>
           </a:p>
@@ -7460,7 +7646,7 @@
                   <a:schemeClr val="tx1"/>
                 </a:solidFill>
               </a:rPr>
-              <a:t>The workaround is email</a:t>
+              <a:t>6 of 8 work around export by emailing the file to a colleague</a:t>
             </a:r>
             <a:endParaRPr lang="en-US" sz="1600" dirty="0"/>
           </a:p>
@@ -7638,7 +7824,7 @@
                   <a:schemeClr val="tx1"/>
                 </a:solidFill>
               </a:rPr>
-              <a:t>Nobody understood “Include hidden fields”</a:t>
+              <a:t>7 of 8 couldn’t say what “Include hidden fields” does</a:t>
             </a:r>
             <a:endParaRPr lang="en-US" sz="1600" dirty="0"/>
           </a:p>
@@ -7702,184 +7888,6 @@
                 </a:solidFill>
               </a:rPr>
               <a:t>Moderate</a:t>
-            </a:r>
-            <a:endParaRPr lang="en-US" sz="1050" dirty="0"/>
-          </a:p>
-        </p:txBody>
-      </p:sp>
-      <p:sp>
-        <p:nvSpPr>
-          <p:cNvPr id="27" name="Shape 25"/>
-          <p:cNvSpPr/>
-          <p:nvPr/>
-        </p:nvSpPr>
-        <p:spPr>
-          <a:xfrm>
-            <a:off x="1097280" y="3840480"/>
-            <a:ext cx="7498080" cy="0"/>
-          </a:xfrm>
-          <a:prstGeom prst="line">
-            <a:avLst/>
-          </a:prstGeom>
-          <a:noFill/>
-          <a:ln w="9525">
-            <a:solidFill>
-              <a:srgbClr val="EEF3EC"/>
-            </a:solidFill>
-            <a:prstDash val="solid"/>
-          </a:ln>
-        </p:spPr>
-      </p:sp>
-      <p:sp>
-        <p:nvSpPr>
-          <p:cNvPr id="28" name="Shape 26"/>
-          <p:cNvSpPr/>
-          <p:nvPr/>
-        </p:nvSpPr>
-        <p:spPr>
-          <a:xfrm>
-            <a:off x="548640" y="3950208"/>
-            <a:ext cx="384048" cy="384048"/>
-          </a:xfrm>
-          <a:prstGeom prst="ellipse">
-            <a:avLst/>
-          </a:prstGeom>
-          <a:solidFill>
-            <a:schemeClr val="accent6"/>
-          </a:solidFill>
-          <a:ln/>
-        </p:spPr>
-      </p:sp>
-      <p:sp>
-        <p:nvSpPr>
-          <p:cNvPr id="29" name="Text 27"/>
-          <p:cNvSpPr txBox="1"/>
-          <p:nvPr/>
-        </p:nvSpPr>
-        <p:spPr>
-          <a:xfrm>
-            <a:off x="548640" y="3950208"/>
-            <a:ext cx="384048" cy="384048"/>
-          </a:xfrm>
-          <a:prstGeom prst="rect">
-            <a:avLst/>
-          </a:prstGeom>
-          <a:noFill/>
-          <a:ln/>
-        </p:spPr>
-        <p:txBody>
-          <a:bodyPr wrap="square" lIns="0" tIns="0" rIns="0" bIns="0" rtlCol="0" anchor="ctr"/>
-          <a:lstStyle/>
-          <a:p>
-            <a:pPr algn="ctr" indent="0" marL="0">
-              <a:buNone/>
-            </a:pPr>
-            <a:r>
-              <a:rPr lang="en-US" sz="1400" b="1" dirty="0">
-                <a:solidFill>
-                  <a:schemeClr val="bg1"/>
-                </a:solidFill>
-              </a:rPr>
-              <a:t>5</a:t>
-            </a:r>
-            <a:endParaRPr lang="en-US" sz="1400" dirty="0"/>
-          </a:p>
-        </p:txBody>
-      </p:sp>
-      <p:sp>
-        <p:nvSpPr>
-          <p:cNvPr id="30" name="Text 28"/>
-          <p:cNvSpPr txBox="1"/>
-          <p:nvPr/>
-        </p:nvSpPr>
-        <p:spPr>
-          <a:xfrm>
-            <a:off x="1097280" y="3858768"/>
-            <a:ext cx="5669280" cy="566928"/>
-          </a:xfrm>
-          <a:prstGeom prst="rect">
-            <a:avLst/>
-          </a:prstGeom>
-          <a:noFill/>
-          <a:ln/>
-        </p:spPr>
-        <p:txBody>
-          <a:bodyPr wrap="square" lIns="0" tIns="0" rIns="0" bIns="0" rtlCol="0" anchor="ctr"/>
-          <a:lstStyle/>
-          <a:p>
-            <a:pPr indent="0" marL="0">
-              <a:buNone/>
-            </a:pPr>
-            <a:r>
-              <a:rPr lang="en-US" sz="1600" dirty="0">
-                <a:solidFill>
-                  <a:schemeClr val="tx1"/>
-                </a:solidFill>
-              </a:rPr>
-              <a:t>Filename confusion is real but minor</a:t>
-            </a:r>
-            <a:endParaRPr lang="en-US" sz="1600" dirty="0"/>
-          </a:p>
-        </p:txBody>
-      </p:sp>
-      <p:sp>
-        <p:nvSpPr>
-          <p:cNvPr id="31" name="Shape 29"/>
-          <p:cNvSpPr/>
-          <p:nvPr/>
-        </p:nvSpPr>
-        <p:spPr>
-          <a:xfrm>
-            <a:off x="6949440" y="3968496"/>
-            <a:ext cx="1645920" cy="347472"/>
-          </a:xfrm>
-          <a:prstGeom prst="roundRect">
-            <a:avLst>
-              <a:gd name="adj" fmla="val 50000"/>
-            </a:avLst>
-          </a:prstGeom>
-          <a:solidFill>
-            <a:schemeClr val="accent6"/>
-          </a:solidFill>
-          <a:ln w="12700">
-            <a:solidFill>
-              <a:schemeClr val="accent6"/>
-            </a:solidFill>
-            <a:prstDash val="solid"/>
-          </a:ln>
-        </p:spPr>
-      </p:sp>
-      <p:sp>
-        <p:nvSpPr>
-          <p:cNvPr id="32" name="Text 30"/>
-          <p:cNvSpPr txBox="1"/>
-          <p:nvPr/>
-        </p:nvSpPr>
-        <p:spPr>
-          <a:xfrm>
-            <a:off x="6949440" y="3968496"/>
-            <a:ext cx="1645920" cy="347472"/>
-          </a:xfrm>
-          <a:prstGeom prst="rect">
-            <a:avLst/>
-          </a:prstGeom>
-          <a:noFill/>
-          <a:ln/>
-        </p:spPr>
-        <p:txBody>
-          <a:bodyPr wrap="square" lIns="0" tIns="0" rIns="0" bIns="0" rtlCol="0" anchor="ctr"/>
-          <a:lstStyle/>
-          <a:p>
-            <a:pPr algn="ctr" indent="0" marL="0">
-              <a:buNone/>
-            </a:pPr>
-            <a:r>
-              <a:rPr lang="en-US" sz="1050" b="1" dirty="0">
-                <a:solidFill>
-                  <a:schemeClr val="bg1"/>
-                </a:solidFill>
-              </a:rPr>
-              <a:t>Weak</a:t>
             </a:r>
             <a:endParaRPr lang="en-US" sz="1050" dirty="0"/>
           </a:p>
@@ -7987,7 +7995,7 @@
                   <a:schemeClr val="accent4"/>
                 </a:solidFill>
               </a:rPr>
-              <a:t>FINDING 1 OF 5  ·  STRONG</a:t>
+              <a:t>FINDING 1 OF 4  ·  STRONG</a:t>
             </a:r>
             <a:endParaRPr lang="en-US" sz="1050" dirty="0"/>
           </a:p>
@@ -8027,7 +8035,7 @@
                   <a:schemeClr val="tx2"/>
                 </a:solidFill>
               </a:rPr>
-              <a:t>Most abandoned exports fail at import</a:t>
+              <a:t>For 5 of 8, export failed because import never mapped the columns</a:t>
             </a:r>
             <a:endParaRPr lang="en-US" sz="2600" dirty="0"/>
           </a:p>
@@ -8126,7 +8134,7 @@
                   <a:schemeClr val="tx1"/>
                 </a:solidFill>
               </a:rPr>
-              <a:t>stopped when the preview showed empty columns. All five: columns never mapped at import</a:t>
+              <a:t>stopped when the preview showed empty columns that import had never mapped</a:t>
             </a:r>
             <a:endParaRPr lang="en-US" sz="1150" dirty="0"/>
           </a:p>
@@ -8225,7 +8233,7 @@
                   <a:schemeClr val="tx1"/>
                 </a:solidFill>
               </a:rPr>
-              <a:t>In every case the account’s import mapping had skipped those columns. We checked in the admin view during the session.</a:t>
+              <a:t>In all 5 accounts the import mapping had skipped those columns. We checked in the admin view during the session.</a:t>
             </a:r>
             <a:endParaRPr lang="en-US" sz="1400" dirty="0"/>
           </a:p>
@@ -8311,7 +8319,7 @@
                   <a:schemeClr val="accent4"/>
                 </a:solidFill>
               </a:rPr>
-              <a:t>P3</a:t>
+              <a:t>P3, operations analyst, 120 seats</a:t>
             </a:r>
             <a:endParaRPr lang="en-US" sz="1300" dirty="0"/>
           </a:p>
@@ -8455,7 +8463,7 @@
                   <a:schemeClr val="tx1"/>
                 </a:solidFill>
               </a:rPr>
-              <a:t>P2 and P5 exported fine. Both had CS run their import for them.</a:t>
+              <a:t>P2 and P5 exported every column. Both had CS run their import for them.</a:t>
             </a:r>
             <a:endParaRPr lang="en-US" sz="1100" dirty="0"/>
           </a:p>
@@ -8527,7 +8535,7 @@
                   <a:schemeClr val="tx1"/>
                 </a:solidFill>
               </a:rPr>
-              <a:t>A new dialog wouldn’t have helped five of the six who abandoned. The fix is earlier in the journey, and belongs to a different team.</a:t>
+              <a:t>A new dialog wouldn’t have helped 5 of the 6 who abandoned. The fix is earlier in the journey, and belongs to a different team.</a:t>
             </a:r>
             <a:endParaRPr lang="en-US" sz="1100" dirty="0"/>
           </a:p>
@@ -8635,7 +8643,7 @@
                   <a:schemeClr val="accent4"/>
                 </a:solidFill>
               </a:rPr>
-              <a:t>FINDING 2 OF 5  ·  WEAK, BUT SERIOUS</a:t>
+              <a:t>FINDING 2 OF 4  ·  WEAK  ·  SERIOUS CASE</a:t>
             </a:r>
             <a:endParaRPr lang="en-US" sz="1050" dirty="0"/>
           </a:p>
@@ -8675,7 +8683,7 @@
                   <a:schemeClr val="tx2"/>
                 </a:solidFill>
               </a:rPr>
-              <a:t>Finance teams could not complete any export</a:t>
+              <a:t>Both finance-team participants couldn’t get a file their system accepts</a:t>
             </a:r>
             <a:endParaRPr lang="en-US" sz="2600" dirty="0"/>
           </a:p>
@@ -8774,7 +8782,7 @@
                   <a:schemeClr val="tx1"/>
                 </a:solidFill>
               </a:rPr>
-              <a:t>both reconciling against an external finance system, gave up entirely</a:t>
+              <a:t>reconcile against an external finance system that rejects the export’s column order</a:t>
             </a:r>
             <a:endParaRPr lang="en-US" sz="1150" dirty="0"/>
           </a:p>
@@ -8837,7 +8845,7 @@
                   <a:schemeClr val="bg1"/>
                 </a:solidFill>
               </a:rPr>
-              <a:t>Weak, but serious</a:t>
+              <a:t>Weak · serious case</a:t>
             </a:r>
             <a:endParaRPr lang="en-US" sz="1100" dirty="0"/>
           </a:p>
@@ -8873,7 +8881,7 @@
                   <a:schemeClr val="tx1"/>
                 </a:solidFill>
               </a:rPr>
-              <a:t>P5 and P7 need a fixed column order the export can’t produce. Both tried twice.</a:t>
+              <a:t>P5 and P7 need a fixed column order export can’t produce. P7 gave up; P5’s file was rejected.</a:t>
             </a:r>
             <a:endParaRPr lang="en-US" sz="1400" dirty="0"/>
           </a:p>
@@ -8959,7 +8967,7 @@
                   <a:schemeClr val="accent4"/>
                 </a:solidFill>
               </a:rPr>
-              <a:t>P7</a:t>
+              <a:t>P7, finance controller, 450 seats</a:t>
             </a:r>
             <a:endParaRPr lang="en-US" sz="1300" dirty="0"/>
           </a:p>
@@ -9103,7 +9111,7 @@
                   <a:schemeClr val="tx1"/>
                 </a:solidFill>
               </a:rPr>
-              <a:t>The other six had no column-order need. This may be a segment problem, not a general one.</a:t>
+              <a:t>The other 6 had no column-order need. This may be one segment’s problem, not everyone’s.</a:t>
             </a:r>
             <a:endParaRPr lang="en-US" sz="1100" dirty="0"/>
           </a:p>
@@ -9283,7 +9291,7 @@
                   <a:schemeClr val="accent4"/>
                 </a:solidFill>
               </a:rPr>
-              <a:t>FINDING 3 OF 5  ·  STRONG</a:t>
+              <a:t>FINDING 3 OF 4  ·  STRONG</a:t>
             </a:r>
             <a:endParaRPr lang="en-US" sz="1050" dirty="0"/>
           </a:p>
@@ -9323,7 +9331,7 @@
                   <a:schemeClr val="tx2"/>
                 </a:solidFill>
               </a:rPr>
-              <a:t>The workaround is email</a:t>
+              <a:t>6 of 8 work around export by emailing the file to a colleague</a:t>
             </a:r>
             <a:endParaRPr lang="en-US" sz="2600" dirty="0"/>
           </a:p>
@@ -9521,7 +9529,7 @@
                   <a:schemeClr val="tx1"/>
                 </a:solidFill>
               </a:rPr>
-              <a:t>Described unprompted. The export funnel shows a completion; the real work then happens in email.</a:t>
+              <a:t>Described without being asked. The funnel counts these exports as complete; the real work then happens in email.</a:t>
             </a:r>
             <a:endParaRPr lang="en-US" sz="1400" dirty="0"/>
           </a:p>
@@ -9593,7 +9601,7 @@
                   <a:schemeClr val="tx2"/>
                 </a:solidFill>
               </a:rPr>
-              <a:t>“Sent the raw file to a colleague and asked them to fix it.”</a:t>
+              <a:t>“Sent the raw file to [name] and asked them to fix it.”</a:t>
             </a:r>
             <a:endParaRPr lang="en-US" sz="1300" dirty="0"/>
           </a:p>
@@ -9607,7 +9615,7 @@
                   <a:schemeClr val="accent4"/>
                 </a:solidFill>
               </a:rPr>
-              <a:t>P1</a:t>
+              <a:t>P1, operations manager, 80 seats</a:t>
             </a:r>
             <a:endParaRPr lang="en-US" sz="1300" dirty="0"/>
           </a:p>
@@ -9751,7 +9759,7 @@
                   <a:schemeClr val="tx1"/>
                 </a:solidFill>
               </a:rPr>
-              <a:t>P2 and P5 reported no workaround; P2 exports rarely.</a:t>
+              <a:t>P2 and P5 reported no workaround. P2 rarely exports.</a:t>
             </a:r>
             <a:endParaRPr lang="en-US" sz="1100" dirty="0"/>
           </a:p>
@@ -9931,7 +9939,7 @@
                   <a:schemeClr val="accent4"/>
                 </a:solidFill>
               </a:rPr>
-              <a:t>FINDING 4 OF 5  ·  MODERATE</a:t>
+              <a:t>FINDING 4 OF 4  ·  MODERATE</a:t>
             </a:r>
             <a:endParaRPr lang="en-US" sz="1050" dirty="0"/>
           </a:p>
@@ -9971,7 +9979,7 @@
                   <a:schemeClr val="tx2"/>
                 </a:solidFill>
               </a:rPr>
-              <a:t>Nobody understood “Include hidden fields”</a:t>
+              <a:t>7 of 8 couldn’t say what “Include hidden fields” does</a:t>
             </a:r>
             <a:endParaRPr lang="en-US" sz="2600" dirty="0"/>
           </a:p>
@@ -10169,7 +10177,7 @@
                   <a:schemeClr val="tx1"/>
                 </a:solidFill>
               </a:rPr>
-              <a:t>Nobody could say what a hidden field was. We didn’t test alternative labels.</a:t>
+              <a:t>None of the 7 could say what a hidden field was. We didn’t test other labels.</a:t>
             </a:r>
             <a:endParaRPr lang="en-US" sz="1400" dirty="0"/>
           </a:p>
@@ -10255,7 +10263,7 @@
                   <a:schemeClr val="accent4"/>
                 </a:solidFill>
               </a:rPr>
-              <a:t>P4</a:t>
+              <a:t>P4, reporting lead, 310 seats</a:t>
             </a:r>
             <a:endParaRPr lang="en-US" sz="1300" dirty="0"/>
           </a:p>
@@ -10399,7 +10407,7 @@
                   <a:schemeClr val="tx1"/>
                 </a:solidFill>
               </a:rPr>
-              <a:t>P8 used it correctly, having read the help article.</a:t>
+              <a:t>P8 used it correctly after reading the help article.</a:t>
             </a:r>
             <a:endParaRPr lang="en-US" sz="1100" dirty="0"/>
           </a:p>
@@ -10471,7 +10479,7 @@
                   <a:schemeClr val="tx1"/>
                 </a:solidFill>
               </a:rPr>
-              <a:t>A cheap labelling fix inside the dialog. Not why people abandon, but free.</a:t>
+              <a:t>A cheap labelling fix inside the dialog. Not why people abandon, and it costs little.</a:t>
             </a:r>
             <a:endParaRPr lang="en-US" sz="1100" dirty="0"/>
           </a:p>
@@ -10619,7 +10627,7 @@
                   <a:schemeClr val="tx2"/>
                 </a:solidFill>
               </a:rPr>
-              <a:t>Two more things the sessions showed, kept so nothing is lost</a:t>
+              <a:t>Three more findings, kept so nothing is lost</a:t>
             </a:r>
             <a:endParaRPr lang="en-US" sz="2600" dirty="0"/>
           </a:p>
@@ -10718,7 +10726,7 @@
                   <a:schemeClr val="tx1"/>
                 </a:solidFill>
               </a:rPr>
-              <a:t>Two participants expected export to schedule itself monthly</a:t>
+              <a:t>2 of 8 expected export to run on a monthly schedule by itself</a:t>
             </a:r>
             <a:endParaRPr lang="en-US" sz="1600" dirty="0"/>
           </a:p>
@@ -10768,7 +10776,7 @@
         </p:nvSpPr>
         <p:spPr>
           <a:xfrm>
-            <a:off x="2103120" y="2395728"/>
+            <a:off x="2103120" y="2194560"/>
             <a:ext cx="6492240" cy="0"/>
           </a:xfrm>
           <a:prstGeom prst="line">
@@ -10791,7 +10799,7 @@
         </p:nvSpPr>
         <p:spPr>
           <a:xfrm>
-            <a:off x="548640" y="2606040"/>
+            <a:off x="548640" y="2331720"/>
             <a:ext cx="1371600" cy="347472"/>
           </a:xfrm>
           <a:prstGeom prst="roundRect">
@@ -10818,7 +10826,7 @@
         </p:nvSpPr>
         <p:spPr>
           <a:xfrm>
-            <a:off x="548640" y="2606040"/>
+            <a:off x="548640" y="2331720"/>
             <a:ext cx="1371600" cy="347472"/>
           </a:xfrm>
           <a:prstGeom prst="rect">
@@ -10854,7 +10862,7 @@
         </p:nvSpPr>
         <p:spPr>
           <a:xfrm>
-            <a:off x="2103120" y="2560320"/>
+            <a:off x="2103120" y="2286000"/>
             <a:ext cx="6492240" cy="457200"/>
           </a:xfrm>
           <a:prstGeom prst="rect">
@@ -10876,7 +10884,7 @@
                   <a:schemeClr val="tx1"/>
                 </a:solidFill>
               </a:rPr>
-              <a:t>Three of eight re-selected the same columns every time</a:t>
+              <a:t>3 of 8 re-selected the same columns every time</a:t>
             </a:r>
             <a:endParaRPr lang="en-US" sz="1600" dirty="0"/>
           </a:p>
@@ -10890,7 +10898,7 @@
         </p:nvSpPr>
         <p:spPr>
           <a:xfrm>
-            <a:off x="2103120" y="3035808"/>
+            <a:off x="2103120" y="2761488"/>
             <a:ext cx="6492240" cy="457200"/>
           </a:xfrm>
           <a:prstGeom prst="rect">
@@ -10913,6 +10921,164 @@
                 </a:solidFill>
               </a:rPr>
               <a:t>The dialog doesn’t remember the last choice. Not why anyone abandoned; logged for the dialog work.</a:t>
+            </a:r>
+            <a:endParaRPr lang="en-US" sz="1200" dirty="0"/>
+          </a:p>
+        </p:txBody>
+      </p:sp>
+      <p:sp>
+        <p:nvSpPr>
+          <p:cNvPr id="8" name="Shape 6"/>
+          <p:cNvSpPr/>
+          <p:nvPr/>
+        </p:nvSpPr>
+        <p:spPr>
+          <a:xfrm>
+            <a:off x="2103120" y="3108960"/>
+            <a:ext cx="6492240" cy="0"/>
+          </a:xfrm>
+          <a:prstGeom prst="line">
+            <a:avLst/>
+          </a:prstGeom>
+          <a:noFill/>
+          <a:ln w="9525">
+            <a:solidFill>
+              <a:srgbClr val="EEF3EC"/>
+            </a:solidFill>
+            <a:prstDash val="solid"/>
+          </a:ln>
+        </p:spPr>
+      </p:sp>
+      <p:sp>
+        <p:nvSpPr>
+          <p:cNvPr id="9" name="Shape 7"/>
+          <p:cNvSpPr/>
+          <p:nvPr/>
+        </p:nvSpPr>
+        <p:spPr>
+          <a:xfrm>
+            <a:off x="548640" y="3246120"/>
+            <a:ext cx="1371600" cy="347472"/>
+          </a:xfrm>
+          <a:prstGeom prst="roundRect">
+            <a:avLst>
+              <a:gd name="adj" fmla="val 50000"/>
+            </a:avLst>
+          </a:prstGeom>
+          <a:solidFill>
+            <a:schemeClr val="accent6"/>
+          </a:solidFill>
+          <a:ln w="12700">
+            <a:solidFill>
+              <a:schemeClr val="accent6"/>
+            </a:solidFill>
+            <a:prstDash val="solid"/>
+          </a:ln>
+        </p:spPr>
+      </p:sp>
+      <p:sp>
+        <p:nvSpPr>
+          <p:cNvPr id="10" name="Text 8"/>
+          <p:cNvSpPr txBox="1"/>
+          <p:nvPr/>
+        </p:nvSpPr>
+        <p:spPr>
+          <a:xfrm>
+            <a:off x="548640" y="3246120"/>
+            <a:ext cx="1371600" cy="347472"/>
+          </a:xfrm>
+          <a:prstGeom prst="rect">
+            <a:avLst/>
+          </a:prstGeom>
+          <a:noFill/>
+          <a:ln/>
+        </p:spPr>
+        <p:txBody>
+          <a:bodyPr wrap="square" lIns="0" tIns="0" rIns="0" bIns="0" rtlCol="0" anchor="ctr"/>
+          <a:lstStyle/>
+          <a:p>
+            <a:pPr algn="ctr" indent="0" marL="0">
+              <a:buNone/>
+            </a:pPr>
+            <a:r>
+              <a:rPr lang="en-US" sz="1050" b="1" dirty="0">
+                <a:solidFill>
+                  <a:schemeClr val="bg1"/>
+                </a:solidFill>
+              </a:rPr>
+              <a:t>Weak</a:t>
+            </a:r>
+            <a:endParaRPr lang="en-US" sz="1050" dirty="0"/>
+          </a:p>
+        </p:txBody>
+      </p:sp>
+      <p:sp>
+        <p:nvSpPr>
+          <p:cNvPr id="11" name="Text 9"/>
+          <p:cNvSpPr txBox="1"/>
+          <p:nvPr/>
+        </p:nvSpPr>
+        <p:spPr>
+          <a:xfrm>
+            <a:off x="2103120" y="3200400"/>
+            <a:ext cx="6492240" cy="457200"/>
+          </a:xfrm>
+          <a:prstGeom prst="rect">
+            <a:avLst/>
+          </a:prstGeom>
+          <a:noFill/>
+          <a:ln/>
+        </p:spPr>
+        <p:txBody>
+          <a:bodyPr wrap="square" lIns="0" tIns="0" rIns="0" bIns="0" rtlCol="0" anchor="ctr"/>
+          <a:lstStyle/>
+          <a:p>
+            <a:pPr indent="0" marL="0">
+              <a:buNone/>
+            </a:pPr>
+            <a:r>
+              <a:rPr lang="en-US" sz="1600" dirty="0">
+                <a:solidFill>
+                  <a:schemeClr val="tx1"/>
+                </a:solidFill>
+              </a:rPr>
+              <a:t>3 of 8 renamed the default filename</a:t>
+            </a:r>
+            <a:endParaRPr lang="en-US" sz="1600" dirty="0"/>
+          </a:p>
+        </p:txBody>
+      </p:sp>
+      <p:sp>
+        <p:nvSpPr>
+          <p:cNvPr id="12" name="Text 10"/>
+          <p:cNvSpPr txBox="1"/>
+          <p:nvPr/>
+        </p:nvSpPr>
+        <p:spPr>
+          <a:xfrm>
+            <a:off x="2103120" y="3675888"/>
+            <a:ext cx="6492240" cy="457200"/>
+          </a:xfrm>
+          <a:prstGeom prst="rect">
+            <a:avLst/>
+          </a:prstGeom>
+          <a:noFill/>
+          <a:ln/>
+        </p:spPr>
+        <p:txBody>
+          <a:bodyPr wrap="square" lIns="0" tIns="0" rIns="0" bIns="0" rtlCol="0" anchor="t"/>
+          <a:lstStyle/>
+          <a:p>
+            <a:pPr indent="0" marL="0">
+              <a:buNone/>
+            </a:pPr>
+            <a:r>
+              <a:rPr lang="en-US" sz="1200" dirty="0">
+                <a:solidFill>
+                  <a:schemeClr val="accent4"/>
+                </a:solidFill>
+              </a:rPr>
+              <a:t>Nobody stopped because of it. Recorded so it isn’t raised again as a priority.</a:t>
             </a:r>
             <a:endParaRPr lang="en-US" sz="1200" dirty="0"/>
           </a:p>
@@ -10926,7 +11092,7 @@
         </p:nvSpPr>
         <p:spPr>
           <a:xfrm>
-            <a:off x="548640" y="3931920"/>
+            <a:off x="548640" y="4069080"/>
             <a:ext cx="8046720" cy="548640"/>
           </a:xfrm>
           <a:prstGeom prst="rect">
@@ -10948,7 +11114,7 @@
                   <a:schemeClr val="tx1"/>
                 </a:solidFill>
               </a:rPr>
-              <a:t>Every finding that met the evidence bar is on this deck: the five above, or here. The full table is in the appendix.</a:t>
+              <a:t>Every finding that met the evidence bar is in this deck: the four above, or here. The full table is in the appendix.</a:t>
             </a:r>
             <a:endParaRPr lang="en-US" sz="1200" dirty="0"/>
           </a:p>

</xml_diff>

<commit_message>
Draw the example summary from the study and drop named owners
Kirsten's review: the summary shouldn't follow fixed product and business
headings, and no single named person should carry the decision. The
summary slide now comes from the study's question and findings, the deck
and report say "the team" instead of naming the PM, and recommendations
name the teams involved, with who takes each one left for the teams to
agree.

Co-Authored-By: Claude Opus 5.5 <noreply@anthropic.com>
Claude-Session: https://claude.ai/code/session_012PVcpMwMCyL4PW5gYu9kZV
</commit_message>
<xml_diff>
--- a/docs/examples/example-readout.pptx
+++ b/docs/examples/example-readout.pptx
@@ -3732,7 +3732,7 @@
                 </a:solidFill>
                 <a:latin typeface="Calibri"/>
               </a:rPr>
-              <a:t>14 October 2026 · Priya Nair, UX Research · For Sam Okafor, PM Reporting</a:t>
+              <a:t>14 October 2026 · Priya Nair, UX Research · For the Reporting team</a:t>
             </a:r>
           </a:p>
         </p:txBody>
@@ -5552,7 +5552,7 @@
                 </a:solidFill>
                 <a:latin typeface="Calibri"/>
               </a:rPr>
-              <a:t>Owner: </a:t>
+              <a:t>Teams involved: </a:t>
             </a:r>
             <a:r>
               <a:rPr sz="1400" b="0" i="0">
@@ -5561,7 +5561,7 @@
                 </a:solidFill>
                 <a:latin typeface="Calibri"/>
               </a:rPr>
-              <a:t>Data Pipeline team (Lena)</a:t>
+              <a:t>Data Pipeline, Reporting</a:t>
             </a:r>
           </a:p>
           <a:p>
@@ -5757,7 +5757,7 @@
                 </a:solidFill>
                 <a:latin typeface="Calibri"/>
               </a:rPr>
-              <a:t>Owner: </a:t>
+              <a:t>Teams involved: </a:t>
             </a:r>
             <a:r>
               <a:rPr sz="1400" b="0" i="0">
@@ -5766,7 +5766,7 @@
                 </a:solidFill>
                 <a:latin typeface="Calibri"/>
               </a:rPr>
-              <a:t>Sam</a:t>
+              <a:t>Reporting</a:t>
             </a:r>
           </a:p>
           <a:p>
@@ -5962,7 +5962,7 @@
                 </a:solidFill>
                 <a:latin typeface="Calibri"/>
               </a:rPr>
-              <a:t>Owner: </a:t>
+              <a:t>Teams involved: </a:t>
             </a:r>
             <a:r>
               <a:rPr sz="1400" b="0" i="0">
@@ -5971,7 +5971,7 @@
                 </a:solidFill>
                 <a:latin typeface="Calibri"/>
               </a:rPr>
-              <a:t>Support (Marco), with Customer Success</a:t>
+              <a:t>Support, Customer Success</a:t>
             </a:r>
           </a:p>
           <a:p>
@@ -6167,7 +6167,7 @@
                 </a:solidFill>
                 <a:latin typeface="Calibri"/>
               </a:rPr>
-              <a:t>Owner: </a:t>
+              <a:t>Teams involved: </a:t>
             </a:r>
             <a:r>
               <a:rPr sz="1400" b="0" i="0">
@@ -6176,7 +6176,7 @@
                 </a:solidFill>
                 <a:latin typeface="Calibri"/>
               </a:rPr>
-              <a:t>Design (Aisha)</a:t>
+              <a:t>Design</a:t>
             </a:r>
           </a:p>
           <a:p>
@@ -6196,6 +6196,45 @@
                 <a:latin typeface="Calibri"/>
               </a:rPr>
               <a:t>Fixes finding 4</a:t>
+            </a:r>
+          </a:p>
+        </p:txBody>
+      </p:sp>
+      <p:sp>
+        <p:nvSpPr>
+          <p:cNvPr id="22" name="TextBox 21"/>
+          <p:cNvSpPr txBox="1"/>
+          <p:nvPr/>
+        </p:nvSpPr>
+        <p:spPr>
+          <a:xfrm>
+            <a:off x="640080" y="5989320"/>
+            <a:ext cx="10881360" cy="320040"/>
+          </a:xfrm>
+          <a:prstGeom prst="rect">
+            <a:avLst/>
+          </a:prstGeom>
+          <a:noFill/>
+        </p:spPr>
+        <p:txBody>
+          <a:bodyPr wrap="square" anchor="t" lIns="0" rIns="0" tIns="0" bIns="0">
+            <a:spAutoFit/>
+          </a:bodyPr>
+          <a:lstStyle/>
+          <a:p>
+            <a:pPr algn="l">
+              <a:lnSpc>
+                <a:spcPct val="110000"/>
+              </a:lnSpc>
+            </a:pPr>
+            <a:r>
+              <a:rPr sz="1400" b="0" i="0">
+                <a:solidFill>
+                  <a:srgbClr val="5B6A60"/>
+                </a:solidFill>
+                <a:latin typeface="Calibri"/>
+              </a:rPr>
+              <a:t>Who takes each one is for the teams to agree together.</a:t>
             </a:r>
           </a:p>
         </p:txBody>
@@ -6299,7 +6338,7 @@
                 </a:solidFill>
                 <a:latin typeface="Cambria"/>
               </a:rPr>
-              <a:t>Sam decides on 30 October</a:t>
+              <a:t>The team decides by 30 October</a:t>
             </a:r>
           </a:p>
         </p:txBody>
@@ -6704,7 +6743,7 @@
                 </a:solidFill>
                 <a:latin typeface="Calibri"/>
               </a:rPr>
-              <a:t>Sam decides</a:t>
+              <a:t>The team decides</a:t>
             </a:r>
           </a:p>
         </p:txBody>
@@ -8705,7 +8744,7 @@
                 </a:solidFill>
                 <a:latin typeface="Calibri"/>
               </a:rPr>
-              <a:t>Priya, the researcher, </a:t>
+              <a:t>The researcher </a:t>
             </a:r>
             <a:r>
               <a:rPr sz="1800" b="0" i="0">
@@ -8714,7 +8753,7 @@
                 </a:solidFill>
                 <a:latin typeface="Calibri"/>
               </a:rPr>
-              <a:t>ran every session, noted her own patterns before seeing Magpie's, decided on each finding, and wrote the recommendations. She reviewed the findings on 12 October and this deck on 14 October.</a:t>
+              <a:t>ran every session, noted their own patterns before seeing Magpie's, decided on each finding, and wrote the recommendations. They reviewed the findings on 12 October and this deck on 14 October.</a:t>
             </a:r>
           </a:p>
           <a:p>
@@ -8770,7 +8809,7 @@
                 </a:solidFill>
                 <a:latin typeface="Calibri"/>
               </a:rPr>
-              <a:t>came from the video tool, and Priya corrected them against the recordings.</a:t>
+              <a:t>came from the video tool, and the researcher corrected them against the recordings.</a:t>
             </a:r>
           </a:p>
         </p:txBody>
@@ -8874,7 +8913,7 @@
                 </a:solidFill>
                 <a:latin typeface="Cambria"/>
               </a:rPr>
-              <a:t>What we learned, and what it means</a:t>
+              <a:t>What we learned, in short</a:t>
             </a:r>
           </a:p>
         </p:txBody>
@@ -8959,18 +8998,76 @@
       </p:sp>
       <p:sp>
         <p:nvSpPr>
-          <p:cNvPr id="6" name="Rounded Rectangle 5"/>
+          <p:cNvPr id="6" name="TextBox 5"/>
+          <p:cNvSpPr txBox="1"/>
+          <p:nvPr/>
+        </p:nvSpPr>
+        <p:spPr>
+          <a:xfrm>
+            <a:off x="640080" y="1828800"/>
+            <a:ext cx="4206240" cy="3291840"/>
+          </a:xfrm>
+          <a:prstGeom prst="rect">
+            <a:avLst/>
+          </a:prstGeom>
+          <a:noFill/>
+        </p:spPr>
+        <p:txBody>
+          <a:bodyPr wrap="square" anchor="t" lIns="0" rIns="0" tIns="0" bIns="0">
+            <a:spAutoFit/>
+          </a:bodyPr>
+          <a:lstStyle/>
+          <a:p>
+            <a:pPr algn="l">
+              <a:lnSpc>
+                <a:spcPct val="115000"/>
+              </a:lnSpc>
+            </a:pPr>
+            <a:r>
+              <a:rPr sz="2600" b="1" i="0">
+                <a:solidFill>
+                  <a:srgbClr val="2C5F2D"/>
+                </a:solidFill>
+                <a:latin typeface="Cambria"/>
+              </a:rPr>
+              <a:t>We set out to learn why new customers give up on export.</a:t>
+            </a:r>
+          </a:p>
+          <a:p>
+            <a:pPr algn="l">
+              <a:lnSpc>
+                <a:spcPct val="115000"/>
+              </a:lnSpc>
+              <a:spcBef>
+                <a:spcPts val="1300"/>
+              </a:spcBef>
+            </a:pPr>
+            <a:r>
+              <a:rPr sz="1800" b="0" i="0">
+                <a:solidFill>
+                  <a:srgbClr val="5B6A60"/>
+                </a:solidFill>
+                <a:latin typeface="Calibri"/>
+              </a:rPr>
+              <a:t>The answer points earlier in the journey than we expected.</a:t>
+            </a:r>
+          </a:p>
+        </p:txBody>
+      </p:sp>
+      <p:sp>
+        <p:nvSpPr>
+          <p:cNvPr id="7" name="Rounded Rectangle 6"/>
           <p:cNvSpPr/>
           <p:nvPr/>
         </p:nvSpPr>
         <p:spPr>
           <a:xfrm>
-            <a:off x="640080" y="1783080"/>
-            <a:ext cx="3474720" cy="4206240"/>
+            <a:off x="5257800" y="1783080"/>
+            <a:ext cx="6309360" cy="1207008"/>
           </a:xfrm>
           <a:prstGeom prst="roundRect">
             <a:avLst>
-              <a:gd name="adj" fmla="val 4000"/>
+              <a:gd name="adj" fmla="val 8000"/>
             </a:avLst>
           </a:prstGeom>
           <a:solidFill>
@@ -9005,20 +9102,100 @@
       </p:sp>
       <p:sp>
         <p:nvSpPr>
-          <p:cNvPr id="7" name="Rectangle 6"/>
+          <p:cNvPr id="8" name="TextBox 7"/>
+          <p:cNvSpPr txBox="1"/>
+          <p:nvPr/>
+        </p:nvSpPr>
+        <p:spPr>
+          <a:xfrm>
+            <a:off x="5577840" y="1965960"/>
+            <a:ext cx="5760720" cy="365760"/>
+          </a:xfrm>
+          <a:prstGeom prst="rect">
+            <a:avLst/>
+          </a:prstGeom>
+          <a:noFill/>
+        </p:spPr>
+        <p:txBody>
+          <a:bodyPr wrap="square" anchor="t" lIns="0" rIns="0" tIns="0" bIns="0">
+            <a:spAutoFit/>
+          </a:bodyPr>
+          <a:lstStyle/>
+          <a:p>
+            <a:pPr algn="l">
+              <a:lnSpc>
+                <a:spcPct val="110000"/>
+              </a:lnSpc>
+            </a:pPr>
+            <a:r>
+              <a:rPr sz="1900" b="1" i="0">
+                <a:solidFill>
+                  <a:srgbClr val="2C5F2D"/>
+                </a:solidFill>
+                <a:latin typeface="Calibri"/>
+              </a:rPr>
+              <a:t>Import is where it breaks.</a:t>
+            </a:r>
+          </a:p>
+        </p:txBody>
+      </p:sp>
+      <p:sp>
+        <p:nvSpPr>
+          <p:cNvPr id="9" name="TextBox 8"/>
+          <p:cNvSpPr txBox="1"/>
+          <p:nvPr/>
+        </p:nvSpPr>
+        <p:spPr>
+          <a:xfrm>
+            <a:off x="5577840" y="2331720"/>
+            <a:ext cx="5760720" cy="640080"/>
+          </a:xfrm>
+          <a:prstGeom prst="rect">
+            <a:avLst/>
+          </a:prstGeom>
+          <a:noFill/>
+        </p:spPr>
+        <p:txBody>
+          <a:bodyPr wrap="square" anchor="t" lIns="0" rIns="0" tIns="0" bIns="0">
+            <a:spAutoFit/>
+          </a:bodyPr>
+          <a:lstStyle/>
+          <a:p>
+            <a:pPr algn="l">
+              <a:lnSpc>
+                <a:spcPct val="110000"/>
+              </a:lnSpc>
+            </a:pPr>
+            <a:r>
+              <a:rPr sz="1500" b="0" i="0">
+                <a:solidFill>
+                  <a:srgbClr val="1F2A24"/>
+                </a:solidFill>
+                <a:latin typeface="Calibri"/>
+              </a:rPr>
+              <a:t>For 5 of the 6 people who gave up, import had quietly skipped columns. A new export screen wouldn't have helped them.</a:t>
+            </a:r>
+          </a:p>
+        </p:txBody>
+      </p:sp>
+      <p:sp>
+        <p:nvSpPr>
+          <p:cNvPr id="10" name="Rounded Rectangle 9"/>
           <p:cNvSpPr/>
           <p:nvPr/>
         </p:nvSpPr>
         <p:spPr>
           <a:xfrm>
-            <a:off x="640080" y="1783080"/>
-            <a:ext cx="3474720" cy="82296"/>
-          </a:xfrm>
-          <a:prstGeom prst="rect">
-            <a:avLst/>
+            <a:off x="5257800" y="3154680"/>
+            <a:ext cx="6309360" cy="1207008"/>
+          </a:xfrm>
+          <a:prstGeom prst="roundRect">
+            <a:avLst>
+              <a:gd name="adj" fmla="val 8000"/>
+            </a:avLst>
           </a:prstGeom>
           <a:solidFill>
-            <a:srgbClr val="2C5F2D"/>
+            <a:srgbClr val="EEF3EC"/>
           </a:solidFill>
           <a:ln>
             <a:noFill/>
@@ -9049,14 +9226,14 @@
       </p:sp>
       <p:sp>
         <p:nvSpPr>
-          <p:cNvPr id="8" name="TextBox 7"/>
-          <p:cNvSpPr txBox="1"/>
-          <p:nvPr/>
-        </p:nvSpPr>
-        <p:spPr>
-          <a:xfrm>
-            <a:off x="960120" y="2148840"/>
-            <a:ext cx="2834640" cy="457200"/>
+          <p:cNvPr id="11" name="TextBox 10"/>
+          <p:cNvSpPr txBox="1"/>
+          <p:nvPr/>
+        </p:nvSpPr>
+        <p:spPr>
+          <a:xfrm>
+            <a:off x="5577840" y="3337560"/>
+            <a:ext cx="5760720" cy="365760"/>
           </a:xfrm>
           <a:prstGeom prst="rect">
             <a:avLst/>
@@ -9075,70 +9252,70 @@
               </a:lnSpc>
             </a:pPr>
             <a:r>
-              <a:rPr sz="2000" b="1" i="0">
+              <a:rPr sz="1900" b="1" i="0">
                 <a:solidFill>
                   <a:srgbClr val="2C5F2D"/>
                 </a:solidFill>
-                <a:latin typeface="Cambria"/>
-              </a:rPr>
-              <a:t>What we learned</a:t>
-            </a:r>
-          </a:p>
-        </p:txBody>
-      </p:sp>
-      <p:sp>
-        <p:nvSpPr>
-          <p:cNvPr id="9" name="TextBox 8"/>
-          <p:cNvSpPr txBox="1"/>
-          <p:nvPr/>
-        </p:nvSpPr>
-        <p:spPr>
-          <a:xfrm>
-            <a:off x="960120" y="2743200"/>
-            <a:ext cx="2834640" cy="3108960"/>
-          </a:xfrm>
-          <a:prstGeom prst="rect">
-            <a:avLst/>
-          </a:prstGeom>
-          <a:noFill/>
-        </p:spPr>
-        <p:txBody>
-          <a:bodyPr wrap="square" anchor="t" lIns="0" rIns="0" tIns="0" bIns="0">
-            <a:spAutoFit/>
-          </a:bodyPr>
-          <a:lstStyle/>
-          <a:p>
-            <a:pPr algn="l">
-              <a:lnSpc>
-                <a:spcPct val="120000"/>
-              </a:lnSpc>
-            </a:pPr>
-            <a:r>
-              <a:rPr sz="1700" b="0" i="0">
+                <a:latin typeface="Calibri"/>
+              </a:rPr>
+              <a:t>The problem is bigger than our numbers show.</a:t>
+            </a:r>
+          </a:p>
+        </p:txBody>
+      </p:sp>
+      <p:sp>
+        <p:nvSpPr>
+          <p:cNvPr id="12" name="TextBox 11"/>
+          <p:cNvSpPr txBox="1"/>
+          <p:nvPr/>
+        </p:nvSpPr>
+        <p:spPr>
+          <a:xfrm>
+            <a:off x="5577840" y="3703320"/>
+            <a:ext cx="5760720" cy="640080"/>
+          </a:xfrm>
+          <a:prstGeom prst="rect">
+            <a:avLst/>
+          </a:prstGeom>
+          <a:noFill/>
+        </p:spPr>
+        <p:txBody>
+          <a:bodyPr wrap="square" anchor="t" lIns="0" rIns="0" tIns="0" bIns="0">
+            <a:spAutoFit/>
+          </a:bodyPr>
+          <a:lstStyle/>
+          <a:p>
+            <a:pPr algn="l">
+              <a:lnSpc>
+                <a:spcPct val="110000"/>
+              </a:lnSpc>
+            </a:pPr>
+            <a:r>
+              <a:rPr sz="1500" b="0" i="0">
                 <a:solidFill>
                   <a:srgbClr val="1F2A24"/>
                 </a:solidFill>
                 <a:latin typeface="Calibri"/>
               </a:rPr>
-              <a:t>Most people who gave up on export were stuck before they started. Import had quietly skipped some of their columns, so the file came out with gaps. They fix it by emailing the file to a colleague.</a:t>
-            </a:r>
-          </a:p>
-        </p:txBody>
-      </p:sp>
-      <p:sp>
-        <p:nvSpPr>
-          <p:cNvPr id="10" name="Rounded Rectangle 9"/>
+              <a:t>6 of 8 fix the file by emailing it to a colleague, so these exports count as successes.</a:t>
+            </a:r>
+          </a:p>
+        </p:txBody>
+      </p:sp>
+      <p:sp>
+        <p:nvSpPr>
+          <p:cNvPr id="13" name="Rounded Rectangle 12"/>
           <p:cNvSpPr/>
           <p:nvPr/>
         </p:nvSpPr>
         <p:spPr>
           <a:xfrm>
-            <a:off x="4343400" y="1783080"/>
-            <a:ext cx="3474720" cy="4206240"/>
+            <a:off x="5257800" y="4526280"/>
+            <a:ext cx="6309360" cy="1207008"/>
           </a:xfrm>
           <a:prstGeom prst="roundRect">
             <a:avLst>
-              <a:gd name="adj" fmla="val 4000"/>
+              <a:gd name="adj" fmla="val 8000"/>
             </a:avLst>
           </a:prstGeom>
           <a:solidFill>
@@ -9173,58 +9350,14 @@
       </p:sp>
       <p:sp>
         <p:nvSpPr>
-          <p:cNvPr id="11" name="Rectangle 10"/>
-          <p:cNvSpPr/>
-          <p:nvPr/>
-        </p:nvSpPr>
-        <p:spPr>
-          <a:xfrm>
-            <a:off x="4343400" y="1783080"/>
-            <a:ext cx="3474720" cy="82296"/>
-          </a:xfrm>
-          <a:prstGeom prst="rect">
-            <a:avLst/>
-          </a:prstGeom>
-          <a:solidFill>
-            <a:srgbClr val="50808E"/>
-          </a:solidFill>
-          <a:ln>
-            <a:noFill/>
-          </a:ln>
-          <a:effectLst/>
-        </p:spPr>
-        <p:style>
-          <a:lnRef idx="1">
-            <a:schemeClr val="accent1"/>
-          </a:lnRef>
-          <a:fillRef idx="3">
-            <a:schemeClr val="accent1"/>
-          </a:fillRef>
-          <a:effectRef idx="2">
-            <a:schemeClr val="accent1"/>
-          </a:effectRef>
-          <a:fontRef idx="minor">
-            <a:schemeClr val="lt1"/>
-          </a:fontRef>
-        </p:style>
-        <p:txBody>
-          <a:bodyPr rtlCol="0" anchor="ctr"/>
-          <a:lstStyle/>
-          <a:p>
-            <a:pPr algn="ctr"/>
-          </a:p>
-        </p:txBody>
-      </p:sp>
-      <p:sp>
-        <p:nvSpPr>
-          <p:cNvPr id="12" name="TextBox 11"/>
-          <p:cNvSpPr txBox="1"/>
-          <p:nvPr/>
-        </p:nvSpPr>
-        <p:spPr>
-          <a:xfrm>
-            <a:off x="4663440" y="2148840"/>
-            <a:ext cx="2834640" cy="457200"/>
+          <p:cNvPr id="14" name="TextBox 13"/>
+          <p:cNvSpPr txBox="1"/>
+          <p:nvPr/>
+        </p:nvSpPr>
+        <p:spPr>
+          <a:xfrm>
+            <a:off x="5577840" y="4709160"/>
+            <a:ext cx="5760720" cy="365760"/>
           </a:xfrm>
           <a:prstGeom prst="rect">
             <a:avLst/>
@@ -9243,143 +9376,53 @@
               </a:lnSpc>
             </a:pPr>
             <a:r>
-              <a:rPr sz="2000" b="1" i="0">
+              <a:rPr sz="1900" b="1" i="0">
                 <a:solidFill>
                   <a:srgbClr val="2C5F2D"/>
                 </a:solidFill>
-                <a:latin typeface="Cambria"/>
-              </a:rPr>
-              <a:t>For the product</a:t>
-            </a:r>
-          </a:p>
-        </p:txBody>
-      </p:sp>
-      <p:sp>
-        <p:nvSpPr>
-          <p:cNvPr id="13" name="TextBox 12"/>
-          <p:cNvSpPr txBox="1"/>
-          <p:nvPr/>
-        </p:nvSpPr>
-        <p:spPr>
-          <a:xfrm>
-            <a:off x="4663440" y="2743200"/>
-            <a:ext cx="2834640" cy="3108960"/>
-          </a:xfrm>
-          <a:prstGeom prst="rect">
-            <a:avLst/>
-          </a:prstGeom>
-          <a:noFill/>
-        </p:spPr>
-        <p:txBody>
-          <a:bodyPr wrap="square" anchor="t" lIns="0" rIns="0" tIns="0" bIns="0">
-            <a:spAutoFit/>
-          </a:bodyPr>
-          <a:lstStyle/>
-          <a:p>
-            <a:pPr algn="l">
-              <a:lnSpc>
-                <a:spcPct val="120000"/>
-              </a:lnSpc>
-            </a:pPr>
-            <a:r>
-              <a:rPr sz="1700" b="0" i="0">
+                <a:latin typeface="Calibri"/>
+              </a:rPr>
+              <a:t>Finance teams are fully blocked.</a:t>
+            </a:r>
+          </a:p>
+        </p:txBody>
+      </p:sp>
+      <p:sp>
+        <p:nvSpPr>
+          <p:cNvPr id="15" name="TextBox 14"/>
+          <p:cNvSpPr txBox="1"/>
+          <p:nvPr/>
+        </p:nvSpPr>
+        <p:spPr>
+          <a:xfrm>
+            <a:off x="5577840" y="5074920"/>
+            <a:ext cx="5760720" cy="640080"/>
+          </a:xfrm>
+          <a:prstGeom prst="rect">
+            <a:avLst/>
+          </a:prstGeom>
+          <a:noFill/>
+        </p:spPr>
+        <p:txBody>
+          <a:bodyPr wrap="square" anchor="t" lIns="0" rIns="0" tIns="0" bIns="0">
+            <a:spAutoFit/>
+          </a:bodyPr>
+          <a:lstStyle/>
+          <a:p>
+            <a:pPr algn="l">
+              <a:lnSpc>
+                <a:spcPct val="110000"/>
+              </a:lnSpc>
+            </a:pPr>
+            <a:r>
+              <a:rPr sz="1500" b="0" i="0">
                 <a:solidFill>
                   <a:srgbClr val="1F2A24"/>
                 </a:solidFill>
                 <a:latin typeface="Calibri"/>
               </a:rPr>
-              <a:t>A new export screen wouldn't fix this. A check at import, warning people about skipped columns, would. A small group, finance teams, needs a fixed column order.</a:t>
-            </a:r>
-          </a:p>
-        </p:txBody>
-      </p:sp>
-      <p:sp>
-        <p:nvSpPr>
-          <p:cNvPr id="14" name="Rounded Rectangle 13"/>
-          <p:cNvSpPr/>
-          <p:nvPr/>
-        </p:nvSpPr>
-        <p:spPr>
-          <a:xfrm>
-            <a:off x="8046720" y="1783080"/>
-            <a:ext cx="3474720" cy="4206240"/>
-          </a:xfrm>
-          <a:prstGeom prst="roundRect">
-            <a:avLst>
-              <a:gd name="adj" fmla="val 4000"/>
-            </a:avLst>
-          </a:prstGeom>
-          <a:solidFill>
-            <a:srgbClr val="EEF3EC"/>
-          </a:solidFill>
-          <a:ln>
-            <a:noFill/>
-          </a:ln>
-          <a:effectLst/>
-        </p:spPr>
-        <p:style>
-          <a:lnRef idx="1">
-            <a:schemeClr val="accent1"/>
-          </a:lnRef>
-          <a:fillRef idx="3">
-            <a:schemeClr val="accent1"/>
-          </a:fillRef>
-          <a:effectRef idx="2">
-            <a:schemeClr val="accent1"/>
-          </a:effectRef>
-          <a:fontRef idx="minor">
-            <a:schemeClr val="lt1"/>
-          </a:fontRef>
-        </p:style>
-        <p:txBody>
-          <a:bodyPr rtlCol="0" anchor="ctr"/>
-          <a:lstStyle/>
-          <a:p>
-            <a:pPr algn="ctr"/>
-          </a:p>
-        </p:txBody>
-      </p:sp>
-      <p:sp>
-        <p:nvSpPr>
-          <p:cNvPr id="15" name="Rectangle 14"/>
-          <p:cNvSpPr/>
-          <p:nvPr/>
-        </p:nvSpPr>
-        <p:spPr>
-          <a:xfrm>
-            <a:off x="8046720" y="1783080"/>
-            <a:ext cx="3474720" cy="82296"/>
-          </a:xfrm>
-          <a:prstGeom prst="rect">
-            <a:avLst/>
-          </a:prstGeom>
-          <a:solidFill>
-            <a:srgbClr val="97BC62"/>
-          </a:solidFill>
-          <a:ln>
-            <a:noFill/>
-          </a:ln>
-          <a:effectLst/>
-        </p:spPr>
-        <p:style>
-          <a:lnRef idx="1">
-            <a:schemeClr val="accent1"/>
-          </a:lnRef>
-          <a:fillRef idx="3">
-            <a:schemeClr val="accent1"/>
-          </a:fillRef>
-          <a:effectRef idx="2">
-            <a:schemeClr val="accent1"/>
-          </a:effectRef>
-          <a:fontRef idx="minor">
-            <a:schemeClr val="lt1"/>
-          </a:fontRef>
-        </p:style>
-        <p:txBody>
-          <a:bodyPr rtlCol="0" anchor="ctr"/>
-          <a:lstStyle/>
-          <a:p>
-            <a:pPr algn="ctr"/>
+              <a:t>Only 2 people, but neither could get a file their finance system accepts.</a:t>
+            </a:r>
           </a:p>
         </p:txBody>
       </p:sp>
@@ -9391,8 +9434,8 @@
         </p:nvSpPr>
         <p:spPr>
           <a:xfrm>
-            <a:off x="8366760" y="2148840"/>
-            <a:ext cx="2834640" cy="457200"/>
+            <a:off x="640080" y="5897880"/>
+            <a:ext cx="10881360" cy="365760"/>
           </a:xfrm>
           <a:prstGeom prst="rect">
             <a:avLst/>
@@ -9411,52 +9454,22 @@
               </a:lnSpc>
             </a:pPr>
             <a:r>
-              <a:rPr sz="2000" b="1" i="0">
+              <a:rPr sz="1800" b="1" i="0">
                 <a:solidFill>
                   <a:srgbClr val="2C5F2D"/>
                 </a:solidFill>
-                <a:latin typeface="Cambria"/>
-              </a:rPr>
-              <a:t>For the business</a:t>
-            </a:r>
-          </a:p>
-        </p:txBody>
-      </p:sp>
-      <p:sp>
-        <p:nvSpPr>
-          <p:cNvPr id="17" name="TextBox 16"/>
-          <p:cNvSpPr txBox="1"/>
-          <p:nvPr/>
-        </p:nvSpPr>
-        <p:spPr>
-          <a:xfrm>
-            <a:off x="8366760" y="2743200"/>
-            <a:ext cx="2834640" cy="3108960"/>
-          </a:xfrm>
-          <a:prstGeom prst="rect">
-            <a:avLst/>
-          </a:prstGeom>
-          <a:noFill/>
-        </p:spPr>
-        <p:txBody>
-          <a:bodyPr wrap="square" anchor="t" lIns="0" rIns="0" tIns="0" bIns="0">
-            <a:spAutoFit/>
-          </a:bodyPr>
-          <a:lstStyle/>
-          <a:p>
-            <a:pPr algn="l">
-              <a:lnSpc>
-                <a:spcPct val="120000"/>
-              </a:lnSpc>
-            </a:pPr>
-            <a:r>
-              <a:rPr sz="1700" b="0" i="0">
+                <a:latin typeface="Calibri"/>
+              </a:rPr>
+              <a:t>So: </a:t>
+            </a:r>
+            <a:r>
+              <a:rPr sz="1800" b="0" i="0">
                 <a:solidFill>
                   <a:srgbClr val="1F2A24"/>
                 </a:solidFill>
                 <a:latin typeface="Calibri"/>
               </a:rPr>
-              <a:t>The planned rebuild, about one engineer-quarter, would miss the cause. Fixing import goes after the 212 export tickets from last quarter and our goal of more weekly sharing.</a:t>
+              <a:t>fix import first, then decide whether the export screen still needs a rebuild.</a:t>
             </a:r>
           </a:p>
         </p:txBody>
@@ -9560,7 +9573,7 @@
                 </a:solidFill>
                 <a:latin typeface="Cambria"/>
               </a:rPr>
-              <a:t>Sam has to choose where Q1 effort goes</a:t>
+              <a:t>The team is choosing where Q1 effort goes</a:t>
             </a:r>
           </a:p>
         </p:txBody>
@@ -9938,7 +9951,7 @@
                 </a:solidFill>
                 <a:latin typeface="Calibri"/>
               </a:rPr>
-              <a:t>30 October, by Sam Okafor, PM Reporting.</a:t>
+              <a:t>30 October, by the Reporting team.</a:t>
             </a:r>
           </a:p>
           <a:p>

</xml_diff>

<commit_message>
Add "How we'll know it worked" line and a private researcher debrief
Readout and report next steps gain one look-back line (standard 8.17).
Stage 8 now offers the researcher a private debrief once, kept out of
the study record, report and readout (template, standard 8.18).
Examples, deck, scenarios, counts and adapters updated.

Co-Authored-By: Claude Opus 5.5 <noreply@anthropic.com>
Claude-Session: https://claude.ai/code/session_012PVcpQ13Geo6ZufTveDUwp
</commit_message>
<xml_diff>
--- a/docs/examples/example-readout.pptx
+++ b/docs/examples/example-readout.pptx
@@ -6518,7 +6518,7 @@
         <p:spPr>
           <a:xfrm>
             <a:off x="640080" y="2651760"/>
-            <a:ext cx="2606040" cy="457200"/>
+            <a:ext cx="2057400" cy="457200"/>
           </a:xfrm>
           <a:prstGeom prst="rect">
             <a:avLst/>
@@ -6557,7 +6557,7 @@
         <p:spPr>
           <a:xfrm>
             <a:off x="640080" y="3200400"/>
-            <a:ext cx="2423160" cy="822960"/>
+            <a:ext cx="1874520" cy="822960"/>
           </a:xfrm>
           <a:prstGeom prst="rect">
             <a:avLst/>
@@ -6595,8 +6595,8 @@
         </p:nvSpPr>
         <p:spPr>
           <a:xfrm>
-            <a:off x="640080" y="4069080"/>
-            <a:ext cx="2423160" cy="1097280"/>
+            <a:off x="640080" y="4206240"/>
+            <a:ext cx="1874520" cy="1097280"/>
           </a:xfrm>
           <a:prstGeom prst="rect">
             <a:avLst/>
@@ -6634,7 +6634,7 @@
         </p:nvSpPr>
         <p:spPr>
           <a:xfrm>
-            <a:off x="3401568" y="2057400"/>
+            <a:off x="2852928" y="2057400"/>
             <a:ext cx="347472" cy="347472"/>
           </a:xfrm>
           <a:prstGeom prst="ellipse">
@@ -6678,8 +6678,8 @@
         </p:nvSpPr>
         <p:spPr>
           <a:xfrm>
-            <a:off x="3401568" y="2651760"/>
-            <a:ext cx="2606040" cy="457200"/>
+            <a:off x="2852928" y="2651760"/>
+            <a:ext cx="2057400" cy="457200"/>
           </a:xfrm>
           <a:prstGeom prst="rect">
             <a:avLst/>
@@ -6717,8 +6717,8 @@
         </p:nvSpPr>
         <p:spPr>
           <a:xfrm>
-            <a:off x="3401568" y="3200400"/>
-            <a:ext cx="2423160" cy="822960"/>
+            <a:off x="2852928" y="3200400"/>
+            <a:ext cx="1874520" cy="822960"/>
           </a:xfrm>
           <a:prstGeom prst="rect">
             <a:avLst/>
@@ -6756,8 +6756,8 @@
         </p:nvSpPr>
         <p:spPr>
           <a:xfrm>
-            <a:off x="3401568" y="4069080"/>
-            <a:ext cx="2423160" cy="1097280"/>
+            <a:off x="2852928" y="4206240"/>
+            <a:ext cx="1874520" cy="1097280"/>
           </a:xfrm>
           <a:prstGeom prst="rect">
             <a:avLst/>
@@ -6795,7 +6795,7 @@
         </p:nvSpPr>
         <p:spPr>
           <a:xfrm>
-            <a:off x="6163056" y="2057400"/>
+            <a:off x="5065776" y="2057400"/>
             <a:ext cx="347472" cy="347472"/>
           </a:xfrm>
           <a:prstGeom prst="ellipse">
@@ -6839,8 +6839,8 @@
         </p:nvSpPr>
         <p:spPr>
           <a:xfrm>
-            <a:off x="6163056" y="2651760"/>
-            <a:ext cx="2606040" cy="457200"/>
+            <a:off x="5065776" y="2651760"/>
+            <a:ext cx="2057400" cy="457200"/>
           </a:xfrm>
           <a:prstGeom prst="rect">
             <a:avLst/>
@@ -6878,8 +6878,8 @@
         </p:nvSpPr>
         <p:spPr>
           <a:xfrm>
-            <a:off x="6163056" y="3200400"/>
-            <a:ext cx="2423160" cy="822960"/>
+            <a:off x="5065776" y="3200400"/>
+            <a:ext cx="1874520" cy="822960"/>
           </a:xfrm>
           <a:prstGeom prst="rect">
             <a:avLst/>
@@ -6917,8 +6917,8 @@
         </p:nvSpPr>
         <p:spPr>
           <a:xfrm>
-            <a:off x="6163056" y="4069080"/>
-            <a:ext cx="2423160" cy="1097280"/>
+            <a:off x="5065776" y="4206240"/>
+            <a:ext cx="1874520" cy="1097280"/>
           </a:xfrm>
           <a:prstGeom prst="rect">
             <a:avLst/>
@@ -6956,7 +6956,7 @@
         </p:nvSpPr>
         <p:spPr>
           <a:xfrm>
-            <a:off x="8924544" y="2057400"/>
+            <a:off x="7278624" y="2057400"/>
             <a:ext cx="347472" cy="347472"/>
           </a:xfrm>
           <a:prstGeom prst="ellipse">
@@ -7000,8 +7000,8 @@
         </p:nvSpPr>
         <p:spPr>
           <a:xfrm>
-            <a:off x="8924544" y="2651760"/>
-            <a:ext cx="2606040" cy="457200"/>
+            <a:off x="7278624" y="2651760"/>
+            <a:ext cx="2057400" cy="457200"/>
           </a:xfrm>
           <a:prstGeom prst="rect">
             <a:avLst/>
@@ -7026,6 +7026,167 @@
                 </a:solidFill>
                 <a:latin typeface="Cambria"/>
               </a:rPr>
+              <a:t>January</a:t>
+            </a:r>
+          </a:p>
+        </p:txBody>
+      </p:sp>
+      <p:sp>
+        <p:nvSpPr>
+          <p:cNvPr id="21" name="TextBox 20"/>
+          <p:cNvSpPr txBox="1"/>
+          <p:nvPr/>
+        </p:nvSpPr>
+        <p:spPr>
+          <a:xfrm>
+            <a:off x="7278624" y="3200400"/>
+            <a:ext cx="1874520" cy="822960"/>
+          </a:xfrm>
+          <a:prstGeom prst="rect">
+            <a:avLst/>
+          </a:prstGeom>
+          <a:noFill/>
+        </p:spPr>
+        <p:txBody>
+          <a:bodyPr wrap="square" anchor="t" lIns="0" rIns="0" tIns="0" bIns="0">
+            <a:spAutoFit/>
+          </a:bodyPr>
+          <a:lstStyle/>
+          <a:p>
+            <a:pPr algn="l">
+              <a:lnSpc>
+                <a:spcPct val="110000"/>
+              </a:lnSpc>
+            </a:pPr>
+            <a:r>
+              <a:rPr sz="1700" b="1" i="0">
+                <a:solidFill>
+                  <a:srgbClr val="1F2A24"/>
+                </a:solidFill>
+                <a:latin typeface="Calibri"/>
+              </a:rPr>
+              <a:t>Check it worked</a:t>
+            </a:r>
+          </a:p>
+        </p:txBody>
+      </p:sp>
+      <p:sp>
+        <p:nvSpPr>
+          <p:cNvPr id="22" name="TextBox 21"/>
+          <p:cNvSpPr txBox="1"/>
+          <p:nvPr/>
+        </p:nvSpPr>
+        <p:spPr>
+          <a:xfrm>
+            <a:off x="7278624" y="4206240"/>
+            <a:ext cx="1874520" cy="1097280"/>
+          </a:xfrm>
+          <a:prstGeom prst="rect">
+            <a:avLst/>
+          </a:prstGeom>
+          <a:noFill/>
+        </p:spPr>
+        <p:txBody>
+          <a:bodyPr wrap="square" anchor="t" lIns="0" rIns="0" tIns="0" bIns="0">
+            <a:spAutoFit/>
+          </a:bodyPr>
+          <a:lstStyle/>
+          <a:p>
+            <a:pPr algn="l">
+              <a:lnSpc>
+                <a:spcPct val="115000"/>
+              </a:lnSpc>
+            </a:pPr>
+            <a:r>
+              <a:rPr sz="1500" b="0" i="0">
+                <a:solidFill>
+                  <a:srgbClr val="5B6A60"/>
+                </a:solidFill>
+                <a:latin typeface="Calibri"/>
+              </a:rPr>
+              <a:t>Fewer exports abandoned after a recent import.</a:t>
+            </a:r>
+          </a:p>
+        </p:txBody>
+      </p:sp>
+      <p:sp>
+        <p:nvSpPr>
+          <p:cNvPr id="23" name="Oval 22"/>
+          <p:cNvSpPr/>
+          <p:nvPr/>
+        </p:nvSpPr>
+        <p:spPr>
+          <a:xfrm>
+            <a:off x="9491472" y="2057400"/>
+            <a:ext cx="347472" cy="347472"/>
+          </a:xfrm>
+          <a:prstGeom prst="ellipse">
+            <a:avLst/>
+          </a:prstGeom>
+          <a:solidFill>
+            <a:srgbClr val="97BC62"/>
+          </a:solidFill>
+          <a:ln>
+            <a:noFill/>
+          </a:ln>
+          <a:effectLst/>
+        </p:spPr>
+        <p:style>
+          <a:lnRef idx="1">
+            <a:schemeClr val="accent1"/>
+          </a:lnRef>
+          <a:fillRef idx="3">
+            <a:schemeClr val="accent1"/>
+          </a:fillRef>
+          <a:effectRef idx="2">
+            <a:schemeClr val="accent1"/>
+          </a:effectRef>
+          <a:fontRef idx="minor">
+            <a:schemeClr val="lt1"/>
+          </a:fontRef>
+        </p:style>
+        <p:txBody>
+          <a:bodyPr rtlCol="0" anchor="ctr"/>
+          <a:lstStyle/>
+          <a:p>
+            <a:pPr algn="ctr"/>
+          </a:p>
+        </p:txBody>
+      </p:sp>
+      <p:sp>
+        <p:nvSpPr>
+          <p:cNvPr id="24" name="TextBox 23"/>
+          <p:cNvSpPr txBox="1"/>
+          <p:nvPr/>
+        </p:nvSpPr>
+        <p:spPr>
+          <a:xfrm>
+            <a:off x="9491472" y="2651760"/>
+            <a:ext cx="2057400" cy="457200"/>
+          </a:xfrm>
+          <a:prstGeom prst="rect">
+            <a:avLst/>
+          </a:prstGeom>
+          <a:noFill/>
+        </p:spPr>
+        <p:txBody>
+          <a:bodyPr wrap="square" anchor="t" lIns="0" rIns="0" tIns="0" bIns="0">
+            <a:spAutoFit/>
+          </a:bodyPr>
+          <a:lstStyle/>
+          <a:p>
+            <a:pPr algn="l">
+              <a:lnSpc>
+                <a:spcPct val="110000"/>
+              </a:lnSpc>
+            </a:pPr>
+            <a:r>
+              <a:rPr sz="2400" b="1" i="0">
+                <a:solidFill>
+                  <a:srgbClr val="2C5F2D"/>
+                </a:solidFill>
+                <a:latin typeface="Cambria"/>
+              </a:rPr>
               <a:t>Later</a:t>
             </a:r>
           </a:p>
@@ -7033,14 +7194,14 @@
       </p:sp>
       <p:sp>
         <p:nvSpPr>
-          <p:cNvPr id="21" name="TextBox 20"/>
-          <p:cNvSpPr txBox="1"/>
-          <p:nvPr/>
-        </p:nvSpPr>
-        <p:spPr>
-          <a:xfrm>
-            <a:off x="8924544" y="3200400"/>
-            <a:ext cx="2423160" cy="822960"/>
+          <p:cNvPr id="25" name="TextBox 24"/>
+          <p:cNvSpPr txBox="1"/>
+          <p:nvPr/>
+        </p:nvSpPr>
+        <p:spPr>
+          <a:xfrm>
+            <a:off x="9491472" y="3200400"/>
+            <a:ext cx="1874520" cy="822960"/>
           </a:xfrm>
           <a:prstGeom prst="rect">
             <a:avLst/>
@@ -7072,14 +7233,14 @@
       </p:sp>
       <p:sp>
         <p:nvSpPr>
-          <p:cNvPr id="22" name="TextBox 21"/>
-          <p:cNvSpPr txBox="1"/>
-          <p:nvPr/>
-        </p:nvSpPr>
-        <p:spPr>
-          <a:xfrm>
-            <a:off x="8924544" y="4069080"/>
-            <a:ext cx="2423160" cy="1097280"/>
+          <p:cNvPr id="26" name="TextBox 25"/>
+          <p:cNvSpPr txBox="1"/>
+          <p:nvPr/>
+        </p:nvSpPr>
+        <p:spPr>
+          <a:xfrm>
+            <a:off x="9491472" y="4206240"/>
+            <a:ext cx="1874520" cy="1097280"/>
           </a:xfrm>
           <a:prstGeom prst="rect">
             <a:avLst/>

</xml_diff>

<commit_message>
Switch to American English and update the README
Add a standing rule that every output is in American English (spelling,
words, and month-first dates), with standard A.29, the american-english
scenario, a house style note and a check in tools/check.py. Convert the
repository to American English, leaving participant transcripts, earlier
changelog entries and saved eval runs as written. Update the README for
the drafting gate, review state in the status line, the release check,
confidence and priority, and method choice, with current counts and sizes.

Co-Authored-By: Claude Opus 5.5 <noreply@anthropic.com>
Claude-Session: https://claude.ai/code/session_012PVcpLGYotdV4G7tcrcVDi
</commit_message>
<xml_diff>
--- a/docs/examples/example-readout.pptx
+++ b/docs/examples/example-readout.pptx
@@ -3732,7 +3732,7 @@
                 </a:solidFill>
                 <a:latin typeface="Calibri"/>
               </a:rPr>
-              <a:t>14 October 2026 · Priya Nair, UX Research · For the Reporting team</a:t>
+              <a:t>October 14, 2026 · Priya Nair, UX Research · For the Reporting team</a:t>
             </a:r>
           </a:p>
         </p:txBody>
@@ -6338,7 +6338,7 @@
                 </a:solidFill>
                 <a:latin typeface="Cambria"/>
               </a:rPr>
-              <a:t>The team decides by 30 October</a:t>
+              <a:t>The team decides by October 30</a:t>
             </a:r>
           </a:p>
         </p:txBody>
@@ -8753,7 +8753,7 @@
                 </a:solidFill>
                 <a:latin typeface="Calibri"/>
               </a:rPr>
-              <a:t>ran every session, noted their own patterns before seeing Magpie's, decided on each finding, and wrote the recommendations. They reviewed the findings on 12 October and this deck on 14 October.</a:t>
+              <a:t>ran every session, noted their own patterns before seeing Magpie's, decided on each finding, and wrote the recommendations. They reviewed the findings on October 12 and this deck on October 14.</a:t>
             </a:r>
           </a:p>
           <a:p>
@@ -9951,7 +9951,7 @@
                 </a:solidFill>
                 <a:latin typeface="Calibri"/>
               </a:rPr>
-              <a:t>30 October, by the Reporting team.</a:t>
+              <a:t>October 30, by the Reporting team.</a:t>
             </a:r>
           </a:p>
           <a:p>

</xml_diff>